<commit_message>
sunum + pptx revize: filler temizliği, slayt 8 işlem listesi, 10 marka/fırsat
- Slayt 4: filler cümle sadeleştirildi; Slayt 5: "işaret edebilir" → "işaret eder"
- Slayt 8: kafa karıştıran llms işareti notu kaldırıldı; en çok işlem ürünleri doğrulanmış
  veriyle güncellendi (Stanley/SJCAM/Lumberjack/Tefal tost/Özdilek yorgan)
- Marka merceği + yükselenler: 10 markaya çıkarıldı; Dönüşüm Fırsatı: 10 sayfa
- build-pptx.js aynı revizyonlarla güncellendi; PPTX yeniden üretildi (içerik QA geçti)

Co-Authored-By: Claude Opus 4.8 <noreply@anthropic.com>
</commit_message>
<xml_diff>
--- a/sunum/Ozdilekteyim-AI-Trafik-Analizi-Sunum.pptx
+++ b/sunum/Ozdilekteyim-AI-Trafik-Analizi-Sunum.pptx
@@ -1096,9 +1096,9 @@
           </c:dLbls>
           <c:cat>
             <c:multiLvlStrRef>
-              <c:f>Sheet1!$A$2:$A$9</c:f>
+              <c:f>Sheet1!$A$2:$A$11</c:f>
               <c:multiLvlStrCache>
-                <c:ptCount val="8"/>
+                <c:ptCount val="10"/>
                 <c:lvl>
                   <c:pt idx="0">
                     <c:v>Özdilek</c:v>
@@ -1124,16 +1124,22 @@
                   <c:pt idx="7">
                     <c:v>Guess</c:v>
                   </c:pt>
+                  <c:pt idx="8">
+                    <c:v>Koton</c:v>
+                  </c:pt>
+                  <c:pt idx="9">
+                    <c:v>Merrell</c:v>
+                  </c:pt>
                 </c:lvl>
               </c:multiLvlStrCache>
             </c:multiLvlStrRef>
           </c:cat>
           <c:val>
             <c:numRef>
-              <c:f>Sheet1!$B$2:$B$9</c:f>
+              <c:f>Sheet1!$B$2:$B$11</c:f>
               <c:numCache>
                 <c:formatCode>General</c:formatCode>
-                <c:ptCount val="8"/>
+                <c:ptCount val="10"/>
                 <c:pt idx="0">
                   <c:v>1823</c:v>
                 </c:pt>
@@ -1157,6 +1163,12 @@
                 </c:pt>
                 <c:pt idx="7">
                   <c:v>542</c:v>
+                </c:pt>
+                <c:pt idx="8">
+                  <c:v>472</c:v>
+                </c:pt>
+                <c:pt idx="9">
+                  <c:v>454</c:v>
                 </c:pt>
               </c:numCache>
             </c:numRef>
@@ -1355,9 +1367,9 @@
           </c:dLbls>
           <c:cat>
             <c:multiLvlStrRef>
-              <c:f>Sheet1!$A$2:$A$7</c:f>
+              <c:f>Sheet1!$A$2:$A$11</c:f>
               <c:multiLvlStrCache>
-                <c:ptCount val="6"/>
+                <c:ptCount val="10"/>
                 <c:lvl>
                   <c:pt idx="0">
                     <c:v>Özdilek</c:v>
@@ -1377,16 +1389,28 @@
                   <c:pt idx="5">
                     <c:v>New Balance</c:v>
                   </c:pt>
+                  <c:pt idx="6">
+                    <c:v>Puma</c:v>
+                  </c:pt>
+                  <c:pt idx="7">
+                    <c:v>Mavi</c:v>
+                  </c:pt>
+                  <c:pt idx="8">
+                    <c:v>Urban Care</c:v>
+                  </c:pt>
+                  <c:pt idx="9">
+                    <c:v>Under Armour</c:v>
+                  </c:pt>
                 </c:lvl>
               </c:multiLvlStrCache>
             </c:multiLvlStrRef>
           </c:cat>
           <c:val>
             <c:numRef>
-              <c:f>Sheet1!$B$2:$B$7</c:f>
+              <c:f>Sheet1!$B$2:$B$11</c:f>
               <c:numCache>
                 <c:formatCode>General</c:formatCode>
-                <c:ptCount val="6"/>
+                <c:ptCount val="10"/>
                 <c:pt idx="0">
                   <c:v>391</c:v>
                 </c:pt>
@@ -1404,6 +1428,18 @@
                 </c:pt>
                 <c:pt idx="5">
                   <c:v>190</c:v>
+                </c:pt>
+                <c:pt idx="6">
+                  <c:v>140</c:v>
+                </c:pt>
+                <c:pt idx="7">
+                  <c:v>123</c:v>
+                </c:pt>
+                <c:pt idx="8">
+                  <c:v>89</c:v>
+                </c:pt>
+                <c:pt idx="9">
+                  <c:v>69</c:v>
                 </c:pt>
               </c:numCache>
             </c:numRef>
@@ -5737,7 +5773,7 @@
           </p:nvPr>
         </p:nvGraphicFramePr>
         <p:xfrm>
-          <a:off x="457200" y="1737360"/>
+          <a:off x="457200" y="1645920"/>
           <a:ext cx="6675120" cy="914400"/>
         </p:xfrm>
         <a:graphic>
@@ -5750,7 +5786,7 @@
                 <a:gridCol w="1005840"/>
                 <a:gridCol w="1005840"/>
               </a:tblGrid>
-              <a:tr h="411480">
+              <a:tr h="365760">
                 <a:tc>
                   <a:txBody>
                     <a:bodyPr/>
@@ -5760,7 +5796,7 @@
                         <a:buNone/>
                       </a:pPr>
                       <a:r>
-                        <a:rPr lang="en-US" sz="1200" b="1" dirty="0">
+                        <a:rPr lang="en-US" sz="1100" b="1" dirty="0">
                           <a:solidFill>
                             <a:srgbClr val="10332F"/>
                           </a:solidFill>
@@ -5770,7 +5806,7 @@
                         </a:rPr>
                         <a:t>Sayfa</a:t>
                       </a:r>
-                      <a:endParaRPr lang="en-US" sz="1200" dirty="0">
+                      <a:endParaRPr lang="en-US" sz="1100" dirty="0">
                         <a:latin typeface="Calibri" charset="0"/>
                         <a:ea typeface="Calibri" charset="0"/>
                         <a:cs typeface="Calibri" charset="0"/>
@@ -5825,7 +5861,7 @@
                         <a:buNone/>
                       </a:pPr>
                       <a:r>
-                        <a:rPr lang="en-US" sz="1200" b="1" dirty="0">
+                        <a:rPr lang="en-US" sz="1100" b="1" dirty="0">
                           <a:solidFill>
                             <a:srgbClr val="10332F"/>
                           </a:solidFill>
@@ -5835,7 +5871,7 @@
                         </a:rPr>
                         <a:t>Tip</a:t>
                       </a:r>
-                      <a:endParaRPr lang="en-US" sz="1200" dirty="0">
+                      <a:endParaRPr lang="en-US" sz="1100" dirty="0">
                         <a:latin typeface="Calibri" charset="0"/>
                         <a:ea typeface="Calibri" charset="0"/>
                         <a:cs typeface="Calibri" charset="0"/>
@@ -5890,7 +5926,7 @@
                         <a:buNone/>
                       </a:pPr>
                       <a:r>
-                        <a:rPr lang="en-US" sz="1200" b="1" dirty="0">
+                        <a:rPr lang="en-US" sz="1100" b="1" dirty="0">
                           <a:solidFill>
                             <a:srgbClr val="10332F"/>
                           </a:solidFill>
@@ -5900,7 +5936,7 @@
                         </a:rPr>
                         <a:t>Oturum</a:t>
                       </a:r>
-                      <a:endParaRPr lang="en-US" sz="1200" dirty="0">
+                      <a:endParaRPr lang="en-US" sz="1100" dirty="0">
                         <a:latin typeface="Calibri" charset="0"/>
                         <a:ea typeface="Calibri" charset="0"/>
                         <a:cs typeface="Calibri" charset="0"/>
@@ -5955,7 +5991,7 @@
                         <a:buNone/>
                       </a:pPr>
                       <a:r>
-                        <a:rPr lang="en-US" sz="1200" b="1" dirty="0">
+                        <a:rPr lang="en-US" sz="1100" b="1" dirty="0">
                           <a:solidFill>
                             <a:srgbClr val="10332F"/>
                           </a:solidFill>
@@ -5965,7 +6001,7 @@
                         </a:rPr>
                         <a:t>İşlem</a:t>
                       </a:r>
-                      <a:endParaRPr lang="en-US" sz="1200" dirty="0">
+                      <a:endParaRPr lang="en-US" sz="1100" dirty="0">
                         <a:latin typeface="Calibri" charset="0"/>
                         <a:ea typeface="Calibri" charset="0"/>
                         <a:cs typeface="Calibri" charset="0"/>
@@ -6012,7 +6048,7 @@
                   </a:tcPr>
                 </a:tc>
               </a:tr>
-              <a:tr h="411480">
+              <a:tr h="365760">
                 <a:tc>
                   <a:txBody>
                     <a:bodyPr/>
@@ -6022,7 +6058,7 @@
                         <a:buNone/>
                       </a:pPr>
                       <a:r>
-                        <a:rPr lang="en-US" sz="1200" dirty="0">
+                        <a:rPr lang="en-US" sz="1100" dirty="0">
                           <a:solidFill>
                             <a:srgbClr val="10332F"/>
                           </a:solidFill>
@@ -6032,7 +6068,7 @@
                         </a:rPr>
                         <a:t>philips su arıtma cihazı</a:t>
                       </a:r>
-                      <a:endParaRPr lang="en-US" sz="1200" dirty="0">
+                      <a:endParaRPr lang="en-US" sz="1100" dirty="0">
                         <a:latin typeface="Calibri" charset="0"/>
                         <a:ea typeface="Calibri" charset="0"/>
                         <a:cs typeface="Calibri" charset="0"/>
@@ -6087,7 +6123,7 @@
                         <a:buNone/>
                       </a:pPr>
                       <a:r>
-                        <a:rPr lang="en-US" sz="1200" dirty="0">
+                        <a:rPr lang="en-US" sz="1100" dirty="0">
                           <a:solidFill>
                             <a:srgbClr val="10332F"/>
                           </a:solidFill>
@@ -6097,7 +6133,7 @@
                         </a:rPr>
                         <a:t>Ürün</a:t>
                       </a:r>
-                      <a:endParaRPr lang="en-US" sz="1200" dirty="0">
+                      <a:endParaRPr lang="en-US" sz="1100" dirty="0">
                         <a:latin typeface="Calibri" charset="0"/>
                         <a:ea typeface="Calibri" charset="0"/>
                         <a:cs typeface="Calibri" charset="0"/>
@@ -6152,7 +6188,7 @@
                         <a:buNone/>
                       </a:pPr>
                       <a:r>
-                        <a:rPr lang="en-US" sz="1200" dirty="0">
+                        <a:rPr lang="en-US" sz="1100" dirty="0">
                           <a:solidFill>
                             <a:srgbClr val="10332F"/>
                           </a:solidFill>
@@ -6162,7 +6198,7 @@
                         </a:rPr>
                         <a:t>317</a:t>
                       </a:r>
-                      <a:endParaRPr lang="en-US" sz="1200" dirty="0">
+                      <a:endParaRPr lang="en-US" sz="1100" dirty="0">
                         <a:latin typeface="Calibri" charset="0"/>
                         <a:ea typeface="Calibri" charset="0"/>
                         <a:cs typeface="Calibri" charset="0"/>
@@ -6217,7 +6253,7 @@
                         <a:buNone/>
                       </a:pPr>
                       <a:r>
-                        <a:rPr lang="en-US" sz="1200" b="1" dirty="0">
+                        <a:rPr lang="en-US" sz="1100" b="1" dirty="0">
                           <a:solidFill>
                             <a:srgbClr val="D32F2F"/>
                           </a:solidFill>
@@ -6227,7 +6263,7 @@
                         </a:rPr>
                         <a:t>0</a:t>
                       </a:r>
-                      <a:endParaRPr lang="en-US" sz="1200" dirty="0">
+                      <a:endParaRPr lang="en-US" sz="1100" dirty="0">
                         <a:latin typeface="Calibri" charset="0"/>
                         <a:ea typeface="Calibri" charset="0"/>
                         <a:cs typeface="Calibri" charset="0"/>
@@ -6277,7 +6313,7 @@
                   </a:tcPr>
                 </a:tc>
               </a:tr>
-              <a:tr h="411480">
+              <a:tr h="365760">
                 <a:tc>
                   <a:txBody>
                     <a:bodyPr/>
@@ -6287,7 +6323,7 @@
                         <a:buNone/>
                       </a:pPr>
                       <a:r>
-                        <a:rPr lang="en-US" sz="1200" dirty="0">
+                        <a:rPr lang="en-US" sz="1100" dirty="0">
                           <a:solidFill>
                             <a:srgbClr val="10332F"/>
                           </a:solidFill>
@@ -6297,7 +6333,7 @@
                         </a:rPr>
                         <a:t>anasayfa</a:t>
                       </a:r>
-                      <a:endParaRPr lang="en-US" sz="1200" dirty="0">
+                      <a:endParaRPr lang="en-US" sz="1100" dirty="0">
                         <a:latin typeface="Calibri" charset="0"/>
                         <a:ea typeface="Calibri" charset="0"/>
                         <a:cs typeface="Calibri" charset="0"/>
@@ -6352,7 +6388,7 @@
                         <a:buNone/>
                       </a:pPr>
                       <a:r>
-                        <a:rPr lang="en-US" sz="1200" dirty="0">
+                        <a:rPr lang="en-US" sz="1100" dirty="0">
                           <a:solidFill>
                             <a:srgbClr val="10332F"/>
                           </a:solidFill>
@@ -6362,7 +6398,7 @@
                         </a:rPr>
                         <a:t>Anasayfa</a:t>
                       </a:r>
-                      <a:endParaRPr lang="en-US" sz="1200" dirty="0">
+                      <a:endParaRPr lang="en-US" sz="1100" dirty="0">
                         <a:latin typeface="Calibri" charset="0"/>
                         <a:ea typeface="Calibri" charset="0"/>
                         <a:cs typeface="Calibri" charset="0"/>
@@ -6417,7 +6453,7 @@
                         <a:buNone/>
                       </a:pPr>
                       <a:r>
-                        <a:rPr lang="en-US" sz="1200" dirty="0">
+                        <a:rPr lang="en-US" sz="1100" dirty="0">
                           <a:solidFill>
                             <a:srgbClr val="10332F"/>
                           </a:solidFill>
@@ -6427,7 +6463,7 @@
                         </a:rPr>
                         <a:t>173</a:t>
                       </a:r>
-                      <a:endParaRPr lang="en-US" sz="1200" dirty="0">
+                      <a:endParaRPr lang="en-US" sz="1100" dirty="0">
                         <a:latin typeface="Calibri" charset="0"/>
                         <a:ea typeface="Calibri" charset="0"/>
                         <a:cs typeface="Calibri" charset="0"/>
@@ -6482,7 +6518,7 @@
                         <a:buNone/>
                       </a:pPr>
                       <a:r>
-                        <a:rPr lang="en-US" sz="1200" b="1" dirty="0">
+                        <a:rPr lang="en-US" sz="1100" b="1" dirty="0">
                           <a:solidFill>
                             <a:srgbClr val="D32F2F"/>
                           </a:solidFill>
@@ -6492,7 +6528,7 @@
                         </a:rPr>
                         <a:t>0</a:t>
                       </a:r>
-                      <a:endParaRPr lang="en-US" sz="1200" dirty="0">
+                      <a:endParaRPr lang="en-US" sz="1100" dirty="0">
                         <a:latin typeface="Calibri" charset="0"/>
                         <a:ea typeface="Calibri" charset="0"/>
                         <a:cs typeface="Calibri" charset="0"/>
@@ -6542,7 +6578,7 @@
                   </a:tcPr>
                 </a:tc>
               </a:tr>
-              <a:tr h="411480">
+              <a:tr h="365760">
                 <a:tc>
                   <a:txBody>
                     <a:bodyPr/>
@@ -6552,7 +6588,7 @@
                         <a:buNone/>
                       </a:pPr>
                       <a:r>
-                        <a:rPr lang="en-US" sz="1200" dirty="0">
+                        <a:rPr lang="en-US" sz="1100" dirty="0">
                           <a:solidFill>
                             <a:srgbClr val="10332F"/>
                           </a:solidFill>
@@ -6562,7 +6598,7 @@
                         </a:rPr>
                         <a:t>özdilek point happy aile seti</a:t>
                       </a:r>
-                      <a:endParaRPr lang="en-US" sz="1200" dirty="0">
+                      <a:endParaRPr lang="en-US" sz="1100" dirty="0">
                         <a:latin typeface="Calibri" charset="0"/>
                         <a:ea typeface="Calibri" charset="0"/>
                         <a:cs typeface="Calibri" charset="0"/>
@@ -6617,7 +6653,7 @@
                         <a:buNone/>
                       </a:pPr>
                       <a:r>
-                        <a:rPr lang="en-US" sz="1200" dirty="0">
+                        <a:rPr lang="en-US" sz="1100" dirty="0">
                           <a:solidFill>
                             <a:srgbClr val="10332F"/>
                           </a:solidFill>
@@ -6627,7 +6663,7 @@
                         </a:rPr>
                         <a:t>Ürün</a:t>
                       </a:r>
-                      <a:endParaRPr lang="en-US" sz="1200" dirty="0">
+                      <a:endParaRPr lang="en-US" sz="1100" dirty="0">
                         <a:latin typeface="Calibri" charset="0"/>
                         <a:ea typeface="Calibri" charset="0"/>
                         <a:cs typeface="Calibri" charset="0"/>
@@ -6682,7 +6718,7 @@
                         <a:buNone/>
                       </a:pPr>
                       <a:r>
-                        <a:rPr lang="en-US" sz="1200" dirty="0">
+                        <a:rPr lang="en-US" sz="1100" dirty="0">
                           <a:solidFill>
                             <a:srgbClr val="10332F"/>
                           </a:solidFill>
@@ -6692,7 +6728,7 @@
                         </a:rPr>
                         <a:t>98</a:t>
                       </a:r>
-                      <a:endParaRPr lang="en-US" sz="1200" dirty="0">
+                      <a:endParaRPr lang="en-US" sz="1100" dirty="0">
                         <a:latin typeface="Calibri" charset="0"/>
                         <a:ea typeface="Calibri" charset="0"/>
                         <a:cs typeface="Calibri" charset="0"/>
@@ -6747,7 +6783,7 @@
                         <a:buNone/>
                       </a:pPr>
                       <a:r>
-                        <a:rPr lang="en-US" sz="1200" b="1" dirty="0">
+                        <a:rPr lang="en-US" sz="1100" b="1" dirty="0">
                           <a:solidFill>
                             <a:srgbClr val="D32F2F"/>
                           </a:solidFill>
@@ -6757,7 +6793,7 @@
                         </a:rPr>
                         <a:t>0</a:t>
                       </a:r>
-                      <a:endParaRPr lang="en-US" sz="1200" dirty="0">
+                      <a:endParaRPr lang="en-US" sz="1100" dirty="0">
                         <a:latin typeface="Calibri" charset="0"/>
                         <a:ea typeface="Calibri" charset="0"/>
                         <a:cs typeface="Calibri" charset="0"/>
@@ -6807,7 +6843,7 @@
                   </a:tcPr>
                 </a:tc>
               </a:tr>
-              <a:tr h="411480">
+              <a:tr h="365760">
                 <a:tc>
                   <a:txBody>
                     <a:bodyPr/>
@@ -6817,7 +6853,7 @@
                         <a:buNone/>
                       </a:pPr>
                       <a:r>
-                        <a:rPr lang="en-US" sz="1200" dirty="0">
+                        <a:rPr lang="en-US" sz="1100" dirty="0">
                           <a:solidFill>
                             <a:srgbClr val="10332F"/>
                           </a:solidFill>
@@ -6827,7 +6863,7 @@
                         </a:rPr>
                         <a:t>philips hava temizleme cihazı</a:t>
                       </a:r>
-                      <a:endParaRPr lang="en-US" sz="1200" dirty="0">
+                      <a:endParaRPr lang="en-US" sz="1100" dirty="0">
                         <a:latin typeface="Calibri" charset="0"/>
                         <a:ea typeface="Calibri" charset="0"/>
                         <a:cs typeface="Calibri" charset="0"/>
@@ -6882,7 +6918,7 @@
                         <a:buNone/>
                       </a:pPr>
                       <a:r>
-                        <a:rPr lang="en-US" sz="1200" dirty="0">
+                        <a:rPr lang="en-US" sz="1100" dirty="0">
                           <a:solidFill>
                             <a:srgbClr val="10332F"/>
                           </a:solidFill>
@@ -6892,7 +6928,7 @@
                         </a:rPr>
                         <a:t>Ürün</a:t>
                       </a:r>
-                      <a:endParaRPr lang="en-US" sz="1200" dirty="0">
+                      <a:endParaRPr lang="en-US" sz="1100" dirty="0">
                         <a:latin typeface="Calibri" charset="0"/>
                         <a:ea typeface="Calibri" charset="0"/>
                         <a:cs typeface="Calibri" charset="0"/>
@@ -6947,7 +6983,7 @@
                         <a:buNone/>
                       </a:pPr>
                       <a:r>
-                        <a:rPr lang="en-US" sz="1200" dirty="0">
+                        <a:rPr lang="en-US" sz="1100" dirty="0">
                           <a:solidFill>
                             <a:srgbClr val="10332F"/>
                           </a:solidFill>
@@ -6957,7 +6993,7 @@
                         </a:rPr>
                         <a:t>67</a:t>
                       </a:r>
-                      <a:endParaRPr lang="en-US" sz="1200" dirty="0">
+                      <a:endParaRPr lang="en-US" sz="1100" dirty="0">
                         <a:latin typeface="Calibri" charset="0"/>
                         <a:ea typeface="Calibri" charset="0"/>
                         <a:cs typeface="Calibri" charset="0"/>
@@ -7012,7 +7048,7 @@
                         <a:buNone/>
                       </a:pPr>
                       <a:r>
-                        <a:rPr lang="en-US" sz="1200" b="1" dirty="0">
+                        <a:rPr lang="en-US" sz="1100" b="1" dirty="0">
                           <a:solidFill>
                             <a:srgbClr val="D32F2F"/>
                           </a:solidFill>
@@ -7022,7 +7058,7 @@
                         </a:rPr>
                         <a:t>0</a:t>
                       </a:r>
-                      <a:endParaRPr lang="en-US" sz="1200" dirty="0">
+                      <a:endParaRPr lang="en-US" sz="1100" dirty="0">
                         <a:latin typeface="Calibri" charset="0"/>
                         <a:ea typeface="Calibri" charset="0"/>
                         <a:cs typeface="Calibri" charset="0"/>
@@ -7072,7 +7108,7 @@
                   </a:tcPr>
                 </a:tc>
               </a:tr>
-              <a:tr h="411480">
+              <a:tr h="365760">
                 <a:tc>
                   <a:txBody>
                     <a:bodyPr/>
@@ -7082,7 +7118,7 @@
                         <a:buNone/>
                       </a:pPr>
                       <a:r>
-                        <a:rPr lang="en-US" sz="1200" dirty="0">
+                        <a:rPr lang="en-US" sz="1100" dirty="0">
                           <a:solidFill>
                             <a:srgbClr val="10332F"/>
                           </a:solidFill>
@@ -7092,7 +7128,7 @@
                         </a:rPr>
                         <a:t>acton pocket camera gimbal</a:t>
                       </a:r>
-                      <a:endParaRPr lang="en-US" sz="1200" dirty="0">
+                      <a:endParaRPr lang="en-US" sz="1100" dirty="0">
                         <a:latin typeface="Calibri" charset="0"/>
                         <a:ea typeface="Calibri" charset="0"/>
                         <a:cs typeface="Calibri" charset="0"/>
@@ -7147,7 +7183,7 @@
                         <a:buNone/>
                       </a:pPr>
                       <a:r>
-                        <a:rPr lang="en-US" sz="1200" dirty="0">
+                        <a:rPr lang="en-US" sz="1100" dirty="0">
                           <a:solidFill>
                             <a:srgbClr val="10332F"/>
                           </a:solidFill>
@@ -7157,7 +7193,7 @@
                         </a:rPr>
                         <a:t>Ürün</a:t>
                       </a:r>
-                      <a:endParaRPr lang="en-US" sz="1200" dirty="0">
+                      <a:endParaRPr lang="en-US" sz="1100" dirty="0">
                         <a:latin typeface="Calibri" charset="0"/>
                         <a:ea typeface="Calibri" charset="0"/>
                         <a:cs typeface="Calibri" charset="0"/>
@@ -7212,7 +7248,7 @@
                         <a:buNone/>
                       </a:pPr>
                       <a:r>
-                        <a:rPr lang="en-US" sz="1200" dirty="0">
+                        <a:rPr lang="en-US" sz="1100" dirty="0">
                           <a:solidFill>
                             <a:srgbClr val="10332F"/>
                           </a:solidFill>
@@ -7222,7 +7258,7 @@
                         </a:rPr>
                         <a:t>62</a:t>
                       </a:r>
-                      <a:endParaRPr lang="en-US" sz="1200" dirty="0">
+                      <a:endParaRPr lang="en-US" sz="1100" dirty="0">
                         <a:latin typeface="Calibri" charset="0"/>
                         <a:ea typeface="Calibri" charset="0"/>
                         <a:cs typeface="Calibri" charset="0"/>
@@ -7277,7 +7313,7 @@
                         <a:buNone/>
                       </a:pPr>
                       <a:r>
-                        <a:rPr lang="en-US" sz="1200" b="1" dirty="0">
+                        <a:rPr lang="en-US" sz="1100" b="1" dirty="0">
                           <a:solidFill>
                             <a:srgbClr val="D32F2F"/>
                           </a:solidFill>
@@ -7287,7 +7323,7 @@
                         </a:rPr>
                         <a:t>0</a:t>
                       </a:r>
-                      <a:endParaRPr lang="en-US" sz="1200" dirty="0">
+                      <a:endParaRPr lang="en-US" sz="1100" dirty="0">
                         <a:latin typeface="Calibri" charset="0"/>
                         <a:ea typeface="Calibri" charset="0"/>
                         <a:cs typeface="Calibri" charset="0"/>
@@ -7337,7 +7373,7 @@
                   </a:tcPr>
                 </a:tc>
               </a:tr>
-              <a:tr h="411480">
+              <a:tr h="365760">
                 <a:tc>
                   <a:txBody>
                     <a:bodyPr/>
@@ -7347,7 +7383,7 @@
                         <a:buNone/>
                       </a:pPr>
                       <a:r>
-                        <a:rPr lang="en-US" sz="1200" dirty="0">
+                        <a:rPr lang="en-US" sz="1100" dirty="0">
                           <a:solidFill>
                             <a:srgbClr val="10332F"/>
                           </a:solidFill>
@@ -7357,7 +7393,7 @@
                         </a:rPr>
                         <a:t>acton selfie aksiyon kamerası</a:t>
                       </a:r>
-                      <a:endParaRPr lang="en-US" sz="1200" dirty="0">
+                      <a:endParaRPr lang="en-US" sz="1100" dirty="0">
                         <a:latin typeface="Calibri" charset="0"/>
                         <a:ea typeface="Calibri" charset="0"/>
                         <a:cs typeface="Calibri" charset="0"/>
@@ -7412,7 +7448,7 @@
                         <a:buNone/>
                       </a:pPr>
                       <a:r>
-                        <a:rPr lang="en-US" sz="1200" dirty="0">
+                        <a:rPr lang="en-US" sz="1100" dirty="0">
                           <a:solidFill>
                             <a:srgbClr val="10332F"/>
                           </a:solidFill>
@@ -7422,7 +7458,7 @@
                         </a:rPr>
                         <a:t>Ürün</a:t>
                       </a:r>
-                      <a:endParaRPr lang="en-US" sz="1200" dirty="0">
+                      <a:endParaRPr lang="en-US" sz="1100" dirty="0">
                         <a:latin typeface="Calibri" charset="0"/>
                         <a:ea typeface="Calibri" charset="0"/>
                         <a:cs typeface="Calibri" charset="0"/>
@@ -7477,7 +7513,7 @@
                         <a:buNone/>
                       </a:pPr>
                       <a:r>
-                        <a:rPr lang="en-US" sz="1200" dirty="0">
+                        <a:rPr lang="en-US" sz="1100" dirty="0">
                           <a:solidFill>
                             <a:srgbClr val="10332F"/>
                           </a:solidFill>
@@ -7487,7 +7523,7 @@
                         </a:rPr>
                         <a:t>54</a:t>
                       </a:r>
-                      <a:endParaRPr lang="en-US" sz="1200" dirty="0">
+                      <a:endParaRPr lang="en-US" sz="1100" dirty="0">
                         <a:latin typeface="Calibri" charset="0"/>
                         <a:ea typeface="Calibri" charset="0"/>
                         <a:cs typeface="Calibri" charset="0"/>
@@ -7542,7 +7578,7 @@
                         <a:buNone/>
                       </a:pPr>
                       <a:r>
-                        <a:rPr lang="en-US" sz="1200" b="1" dirty="0">
+                        <a:rPr lang="en-US" sz="1100" b="1" dirty="0">
                           <a:solidFill>
                             <a:srgbClr val="D32F2F"/>
                           </a:solidFill>
@@ -7552,7 +7588,1067 @@
                         </a:rPr>
                         <a:t>0</a:t>
                       </a:r>
-                      <a:endParaRPr lang="en-US" sz="1200" dirty="0">
+                      <a:endParaRPr lang="en-US" sz="1100" dirty="0">
+                        <a:latin typeface="Calibri" charset="0"/>
+                        <a:ea typeface="Calibri" charset="0"/>
+                        <a:cs typeface="Calibri" charset="0"/>
+                      </a:endParaRPr>
+                    </a:p>
+                  </a:txBody>
+                  <a:tcPr marL="91440" marR="91440" marT="45720" marB="45720" anchor="ctr">
+                    <a:lnL w="6350" cap="flat" cmpd="sng" algn="ctr">
+                      <a:solidFill>
+                        <a:srgbClr val="E0E0E0"/>
+                      </a:solidFill>
+                      <a:prstDash val="solid"/>
+                      <a:round/>
+                      <a:headEnd type="none" w="med" len="med"/>
+                      <a:tailEnd type="none" w="med" len="med"/>
+                    </a:lnL>
+                    <a:lnR w="6350" cap="flat" cmpd="sng" algn="ctr">
+                      <a:solidFill>
+                        <a:srgbClr val="E0E0E0"/>
+                      </a:solidFill>
+                      <a:prstDash val="solid"/>
+                      <a:round/>
+                      <a:headEnd type="none" w="med" len="med"/>
+                      <a:tailEnd type="none" w="med" len="med"/>
+                    </a:lnR>
+                    <a:lnT w="6350" cap="flat" cmpd="sng" algn="ctr">
+                      <a:solidFill>
+                        <a:srgbClr val="E0E0E0"/>
+                      </a:solidFill>
+                      <a:prstDash val="solid"/>
+                      <a:round/>
+                      <a:headEnd type="none" w="med" len="med"/>
+                      <a:tailEnd type="none" w="med" len="med"/>
+                    </a:lnT>
+                    <a:lnB w="6350" cap="flat" cmpd="sng" algn="ctr">
+                      <a:solidFill>
+                        <a:srgbClr val="E0E0E0"/>
+                      </a:solidFill>
+                      <a:prstDash val="solid"/>
+                      <a:round/>
+                      <a:headEnd type="none" w="med" len="med"/>
+                      <a:tailEnd type="none" w="med" len="med"/>
+                    </a:lnB>
+                    <a:solidFill>
+                      <a:srgbClr val="FFCDD2"/>
+                    </a:solidFill>
+                  </a:tcPr>
+                </a:tc>
+              </a:tr>
+              <a:tr h="365760">
+                <a:tc>
+                  <a:txBody>
+                    <a:bodyPr/>
+                    <a:lstStyle/>
+                    <a:p>
+                      <a:pPr indent="0" marL="0">
+                        <a:buNone/>
+                      </a:pPr>
+                      <a:r>
+                        <a:rPr lang="en-US" sz="1100" dirty="0">
+                          <a:solidFill>
+                            <a:srgbClr val="10332F"/>
+                          </a:solidFill>
+                          <a:latin typeface="Calibri" pitchFamily="34" charset="0"/>
+                          <a:ea typeface="Calibri" pitchFamily="34" charset="-122"/>
+                          <a:cs typeface="Calibri" pitchFamily="34" charset="-120"/>
+                        </a:rPr>
+                        <a:t>dyson supersonic saç kurutma</a:t>
+                      </a:r>
+                      <a:endParaRPr lang="en-US" sz="1100" dirty="0">
+                        <a:latin typeface="Calibri" charset="0"/>
+                        <a:ea typeface="Calibri" charset="0"/>
+                        <a:cs typeface="Calibri" charset="0"/>
+                      </a:endParaRPr>
+                    </a:p>
+                  </a:txBody>
+                  <a:tcPr marL="91440" marR="91440" marT="45720" marB="45720" anchor="ctr">
+                    <a:lnL w="6350" cap="flat" cmpd="sng" algn="ctr">
+                      <a:solidFill>
+                        <a:srgbClr val="E0E0E0"/>
+                      </a:solidFill>
+                      <a:prstDash val="solid"/>
+                      <a:round/>
+                      <a:headEnd type="none" w="med" len="med"/>
+                      <a:tailEnd type="none" w="med" len="med"/>
+                    </a:lnL>
+                    <a:lnR w="6350" cap="flat" cmpd="sng" algn="ctr">
+                      <a:solidFill>
+                        <a:srgbClr val="E0E0E0"/>
+                      </a:solidFill>
+                      <a:prstDash val="solid"/>
+                      <a:round/>
+                      <a:headEnd type="none" w="med" len="med"/>
+                      <a:tailEnd type="none" w="med" len="med"/>
+                    </a:lnR>
+                    <a:lnT w="6350" cap="flat" cmpd="sng" algn="ctr">
+                      <a:solidFill>
+                        <a:srgbClr val="E0E0E0"/>
+                      </a:solidFill>
+                      <a:prstDash val="solid"/>
+                      <a:round/>
+                      <a:headEnd type="none" w="med" len="med"/>
+                      <a:tailEnd type="none" w="med" len="med"/>
+                    </a:lnT>
+                    <a:lnB w="6350" cap="flat" cmpd="sng" algn="ctr">
+                      <a:solidFill>
+                        <a:srgbClr val="E0E0E0"/>
+                      </a:solidFill>
+                      <a:prstDash val="solid"/>
+                      <a:round/>
+                      <a:headEnd type="none" w="med" len="med"/>
+                      <a:tailEnd type="none" w="med" len="med"/>
+                    </a:lnB>
+                  </a:tcPr>
+                </a:tc>
+                <a:tc>
+                  <a:txBody>
+                    <a:bodyPr/>
+                    <a:lstStyle/>
+                    <a:p>
+                      <a:pPr indent="0" marL="0">
+                        <a:buNone/>
+                      </a:pPr>
+                      <a:r>
+                        <a:rPr lang="en-US" sz="1100" dirty="0">
+                          <a:solidFill>
+                            <a:srgbClr val="10332F"/>
+                          </a:solidFill>
+                          <a:latin typeface="Calibri" pitchFamily="34" charset="0"/>
+                          <a:ea typeface="Calibri" pitchFamily="34" charset="-122"/>
+                          <a:cs typeface="Calibri" pitchFamily="34" charset="-120"/>
+                        </a:rPr>
+                        <a:t>Ürün</a:t>
+                      </a:r>
+                      <a:endParaRPr lang="en-US" sz="1100" dirty="0">
+                        <a:latin typeface="Calibri" charset="0"/>
+                        <a:ea typeface="Calibri" charset="0"/>
+                        <a:cs typeface="Calibri" charset="0"/>
+                      </a:endParaRPr>
+                    </a:p>
+                  </a:txBody>
+                  <a:tcPr marL="91440" marR="91440" marT="45720" marB="45720" anchor="ctr">
+                    <a:lnL w="6350" cap="flat" cmpd="sng" algn="ctr">
+                      <a:solidFill>
+                        <a:srgbClr val="E0E0E0"/>
+                      </a:solidFill>
+                      <a:prstDash val="solid"/>
+                      <a:round/>
+                      <a:headEnd type="none" w="med" len="med"/>
+                      <a:tailEnd type="none" w="med" len="med"/>
+                    </a:lnL>
+                    <a:lnR w="6350" cap="flat" cmpd="sng" algn="ctr">
+                      <a:solidFill>
+                        <a:srgbClr val="E0E0E0"/>
+                      </a:solidFill>
+                      <a:prstDash val="solid"/>
+                      <a:round/>
+                      <a:headEnd type="none" w="med" len="med"/>
+                      <a:tailEnd type="none" w="med" len="med"/>
+                    </a:lnR>
+                    <a:lnT w="6350" cap="flat" cmpd="sng" algn="ctr">
+                      <a:solidFill>
+                        <a:srgbClr val="E0E0E0"/>
+                      </a:solidFill>
+                      <a:prstDash val="solid"/>
+                      <a:round/>
+                      <a:headEnd type="none" w="med" len="med"/>
+                      <a:tailEnd type="none" w="med" len="med"/>
+                    </a:lnT>
+                    <a:lnB w="6350" cap="flat" cmpd="sng" algn="ctr">
+                      <a:solidFill>
+                        <a:srgbClr val="E0E0E0"/>
+                      </a:solidFill>
+                      <a:prstDash val="solid"/>
+                      <a:round/>
+                      <a:headEnd type="none" w="med" len="med"/>
+                      <a:tailEnd type="none" w="med" len="med"/>
+                    </a:lnB>
+                  </a:tcPr>
+                </a:tc>
+                <a:tc>
+                  <a:txBody>
+                    <a:bodyPr/>
+                    <a:lstStyle/>
+                    <a:p>
+                      <a:pPr algn="r" indent="0" marL="0">
+                        <a:buNone/>
+                      </a:pPr>
+                      <a:r>
+                        <a:rPr lang="en-US" sz="1100" dirty="0">
+                          <a:solidFill>
+                            <a:srgbClr val="10332F"/>
+                          </a:solidFill>
+                          <a:latin typeface="Calibri" pitchFamily="34" charset="0"/>
+                          <a:ea typeface="Calibri" pitchFamily="34" charset="-122"/>
+                          <a:cs typeface="Calibri" pitchFamily="34" charset="-120"/>
+                        </a:rPr>
+                        <a:t>47</a:t>
+                      </a:r>
+                      <a:endParaRPr lang="en-US" sz="1100" dirty="0">
+                        <a:latin typeface="Calibri" charset="0"/>
+                        <a:ea typeface="Calibri" charset="0"/>
+                        <a:cs typeface="Calibri" charset="0"/>
+                      </a:endParaRPr>
+                    </a:p>
+                  </a:txBody>
+                  <a:tcPr marL="91440" marR="91440" marT="45720" marB="45720" anchor="ctr">
+                    <a:lnL w="6350" cap="flat" cmpd="sng" algn="ctr">
+                      <a:solidFill>
+                        <a:srgbClr val="E0E0E0"/>
+                      </a:solidFill>
+                      <a:prstDash val="solid"/>
+                      <a:round/>
+                      <a:headEnd type="none" w="med" len="med"/>
+                      <a:tailEnd type="none" w="med" len="med"/>
+                    </a:lnL>
+                    <a:lnR w="6350" cap="flat" cmpd="sng" algn="ctr">
+                      <a:solidFill>
+                        <a:srgbClr val="E0E0E0"/>
+                      </a:solidFill>
+                      <a:prstDash val="solid"/>
+                      <a:round/>
+                      <a:headEnd type="none" w="med" len="med"/>
+                      <a:tailEnd type="none" w="med" len="med"/>
+                    </a:lnR>
+                    <a:lnT w="6350" cap="flat" cmpd="sng" algn="ctr">
+                      <a:solidFill>
+                        <a:srgbClr val="E0E0E0"/>
+                      </a:solidFill>
+                      <a:prstDash val="solid"/>
+                      <a:round/>
+                      <a:headEnd type="none" w="med" len="med"/>
+                      <a:tailEnd type="none" w="med" len="med"/>
+                    </a:lnT>
+                    <a:lnB w="6350" cap="flat" cmpd="sng" algn="ctr">
+                      <a:solidFill>
+                        <a:srgbClr val="E0E0E0"/>
+                      </a:solidFill>
+                      <a:prstDash val="solid"/>
+                      <a:round/>
+                      <a:headEnd type="none" w="med" len="med"/>
+                      <a:tailEnd type="none" w="med" len="med"/>
+                    </a:lnB>
+                  </a:tcPr>
+                </a:tc>
+                <a:tc>
+                  <a:txBody>
+                    <a:bodyPr/>
+                    <a:lstStyle/>
+                    <a:p>
+                      <a:pPr algn="r" indent="0" marL="0">
+                        <a:buNone/>
+                      </a:pPr>
+                      <a:r>
+                        <a:rPr lang="en-US" sz="1100" b="1" dirty="0">
+                          <a:solidFill>
+                            <a:srgbClr val="D32F2F"/>
+                          </a:solidFill>
+                          <a:latin typeface="Calibri" pitchFamily="34" charset="0"/>
+                          <a:ea typeface="Calibri" pitchFamily="34" charset="-122"/>
+                          <a:cs typeface="Calibri" pitchFamily="34" charset="-120"/>
+                        </a:rPr>
+                        <a:t>0</a:t>
+                      </a:r>
+                      <a:endParaRPr lang="en-US" sz="1100" dirty="0">
+                        <a:latin typeface="Calibri" charset="0"/>
+                        <a:ea typeface="Calibri" charset="0"/>
+                        <a:cs typeface="Calibri" charset="0"/>
+                      </a:endParaRPr>
+                    </a:p>
+                  </a:txBody>
+                  <a:tcPr marL="91440" marR="91440" marT="45720" marB="45720" anchor="ctr">
+                    <a:lnL w="6350" cap="flat" cmpd="sng" algn="ctr">
+                      <a:solidFill>
+                        <a:srgbClr val="E0E0E0"/>
+                      </a:solidFill>
+                      <a:prstDash val="solid"/>
+                      <a:round/>
+                      <a:headEnd type="none" w="med" len="med"/>
+                      <a:tailEnd type="none" w="med" len="med"/>
+                    </a:lnL>
+                    <a:lnR w="6350" cap="flat" cmpd="sng" algn="ctr">
+                      <a:solidFill>
+                        <a:srgbClr val="E0E0E0"/>
+                      </a:solidFill>
+                      <a:prstDash val="solid"/>
+                      <a:round/>
+                      <a:headEnd type="none" w="med" len="med"/>
+                      <a:tailEnd type="none" w="med" len="med"/>
+                    </a:lnR>
+                    <a:lnT w="6350" cap="flat" cmpd="sng" algn="ctr">
+                      <a:solidFill>
+                        <a:srgbClr val="E0E0E0"/>
+                      </a:solidFill>
+                      <a:prstDash val="solid"/>
+                      <a:round/>
+                      <a:headEnd type="none" w="med" len="med"/>
+                      <a:tailEnd type="none" w="med" len="med"/>
+                    </a:lnT>
+                    <a:lnB w="6350" cap="flat" cmpd="sng" algn="ctr">
+                      <a:solidFill>
+                        <a:srgbClr val="E0E0E0"/>
+                      </a:solidFill>
+                      <a:prstDash val="solid"/>
+                      <a:round/>
+                      <a:headEnd type="none" w="med" len="med"/>
+                      <a:tailEnd type="none" w="med" len="med"/>
+                    </a:lnB>
+                    <a:solidFill>
+                      <a:srgbClr val="FFCDD2"/>
+                    </a:solidFill>
+                  </a:tcPr>
+                </a:tc>
+              </a:tr>
+              <a:tr h="365760">
+                <a:tc>
+                  <a:txBody>
+                    <a:bodyPr/>
+                    <a:lstStyle/>
+                    <a:p>
+                      <a:pPr indent="0" marL="0">
+                        <a:buNone/>
+                      </a:pPr>
+                      <a:r>
+                        <a:rPr lang="en-US" sz="1100" dirty="0">
+                          <a:solidFill>
+                            <a:srgbClr val="10332F"/>
+                          </a:solidFill>
+                          <a:latin typeface="Calibri" pitchFamily="34" charset="0"/>
+                          <a:ea typeface="Calibri" pitchFamily="34" charset="-122"/>
+                          <a:cs typeface="Calibri" pitchFamily="34" charset="-120"/>
+                        </a:rPr>
+                        <a:t>tcl movetime çocuk saati</a:t>
+                      </a:r>
+                      <a:endParaRPr lang="en-US" sz="1100" dirty="0">
+                        <a:latin typeface="Calibri" charset="0"/>
+                        <a:ea typeface="Calibri" charset="0"/>
+                        <a:cs typeface="Calibri" charset="0"/>
+                      </a:endParaRPr>
+                    </a:p>
+                  </a:txBody>
+                  <a:tcPr marL="91440" marR="91440" marT="45720" marB="45720" anchor="ctr">
+                    <a:lnL w="6350" cap="flat" cmpd="sng" algn="ctr">
+                      <a:solidFill>
+                        <a:srgbClr val="E0E0E0"/>
+                      </a:solidFill>
+                      <a:prstDash val="solid"/>
+                      <a:round/>
+                      <a:headEnd type="none" w="med" len="med"/>
+                      <a:tailEnd type="none" w="med" len="med"/>
+                    </a:lnL>
+                    <a:lnR w="6350" cap="flat" cmpd="sng" algn="ctr">
+                      <a:solidFill>
+                        <a:srgbClr val="E0E0E0"/>
+                      </a:solidFill>
+                      <a:prstDash val="solid"/>
+                      <a:round/>
+                      <a:headEnd type="none" w="med" len="med"/>
+                      <a:tailEnd type="none" w="med" len="med"/>
+                    </a:lnR>
+                    <a:lnT w="6350" cap="flat" cmpd="sng" algn="ctr">
+                      <a:solidFill>
+                        <a:srgbClr val="E0E0E0"/>
+                      </a:solidFill>
+                      <a:prstDash val="solid"/>
+                      <a:round/>
+                      <a:headEnd type="none" w="med" len="med"/>
+                      <a:tailEnd type="none" w="med" len="med"/>
+                    </a:lnT>
+                    <a:lnB w="6350" cap="flat" cmpd="sng" algn="ctr">
+                      <a:solidFill>
+                        <a:srgbClr val="E0E0E0"/>
+                      </a:solidFill>
+                      <a:prstDash val="solid"/>
+                      <a:round/>
+                      <a:headEnd type="none" w="med" len="med"/>
+                      <a:tailEnd type="none" w="med" len="med"/>
+                    </a:lnB>
+                  </a:tcPr>
+                </a:tc>
+                <a:tc>
+                  <a:txBody>
+                    <a:bodyPr/>
+                    <a:lstStyle/>
+                    <a:p>
+                      <a:pPr indent="0" marL="0">
+                        <a:buNone/>
+                      </a:pPr>
+                      <a:r>
+                        <a:rPr lang="en-US" sz="1100" dirty="0">
+                          <a:solidFill>
+                            <a:srgbClr val="10332F"/>
+                          </a:solidFill>
+                          <a:latin typeface="Calibri" pitchFamily="34" charset="0"/>
+                          <a:ea typeface="Calibri" pitchFamily="34" charset="-122"/>
+                          <a:cs typeface="Calibri" pitchFamily="34" charset="-120"/>
+                        </a:rPr>
+                        <a:t>Ürün</a:t>
+                      </a:r>
+                      <a:endParaRPr lang="en-US" sz="1100" dirty="0">
+                        <a:latin typeface="Calibri" charset="0"/>
+                        <a:ea typeface="Calibri" charset="0"/>
+                        <a:cs typeface="Calibri" charset="0"/>
+                      </a:endParaRPr>
+                    </a:p>
+                  </a:txBody>
+                  <a:tcPr marL="91440" marR="91440" marT="45720" marB="45720" anchor="ctr">
+                    <a:lnL w="6350" cap="flat" cmpd="sng" algn="ctr">
+                      <a:solidFill>
+                        <a:srgbClr val="E0E0E0"/>
+                      </a:solidFill>
+                      <a:prstDash val="solid"/>
+                      <a:round/>
+                      <a:headEnd type="none" w="med" len="med"/>
+                      <a:tailEnd type="none" w="med" len="med"/>
+                    </a:lnL>
+                    <a:lnR w="6350" cap="flat" cmpd="sng" algn="ctr">
+                      <a:solidFill>
+                        <a:srgbClr val="E0E0E0"/>
+                      </a:solidFill>
+                      <a:prstDash val="solid"/>
+                      <a:round/>
+                      <a:headEnd type="none" w="med" len="med"/>
+                      <a:tailEnd type="none" w="med" len="med"/>
+                    </a:lnR>
+                    <a:lnT w="6350" cap="flat" cmpd="sng" algn="ctr">
+                      <a:solidFill>
+                        <a:srgbClr val="E0E0E0"/>
+                      </a:solidFill>
+                      <a:prstDash val="solid"/>
+                      <a:round/>
+                      <a:headEnd type="none" w="med" len="med"/>
+                      <a:tailEnd type="none" w="med" len="med"/>
+                    </a:lnT>
+                    <a:lnB w="6350" cap="flat" cmpd="sng" algn="ctr">
+                      <a:solidFill>
+                        <a:srgbClr val="E0E0E0"/>
+                      </a:solidFill>
+                      <a:prstDash val="solid"/>
+                      <a:round/>
+                      <a:headEnd type="none" w="med" len="med"/>
+                      <a:tailEnd type="none" w="med" len="med"/>
+                    </a:lnB>
+                  </a:tcPr>
+                </a:tc>
+                <a:tc>
+                  <a:txBody>
+                    <a:bodyPr/>
+                    <a:lstStyle/>
+                    <a:p>
+                      <a:pPr algn="r" indent="0" marL="0">
+                        <a:buNone/>
+                      </a:pPr>
+                      <a:r>
+                        <a:rPr lang="en-US" sz="1100" dirty="0">
+                          <a:solidFill>
+                            <a:srgbClr val="10332F"/>
+                          </a:solidFill>
+                          <a:latin typeface="Calibri" pitchFamily="34" charset="0"/>
+                          <a:ea typeface="Calibri" pitchFamily="34" charset="-122"/>
+                          <a:cs typeface="Calibri" pitchFamily="34" charset="-120"/>
+                        </a:rPr>
+                        <a:t>42</a:t>
+                      </a:r>
+                      <a:endParaRPr lang="en-US" sz="1100" dirty="0">
+                        <a:latin typeface="Calibri" charset="0"/>
+                        <a:ea typeface="Calibri" charset="0"/>
+                        <a:cs typeface="Calibri" charset="0"/>
+                      </a:endParaRPr>
+                    </a:p>
+                  </a:txBody>
+                  <a:tcPr marL="91440" marR="91440" marT="45720" marB="45720" anchor="ctr">
+                    <a:lnL w="6350" cap="flat" cmpd="sng" algn="ctr">
+                      <a:solidFill>
+                        <a:srgbClr val="E0E0E0"/>
+                      </a:solidFill>
+                      <a:prstDash val="solid"/>
+                      <a:round/>
+                      <a:headEnd type="none" w="med" len="med"/>
+                      <a:tailEnd type="none" w="med" len="med"/>
+                    </a:lnL>
+                    <a:lnR w="6350" cap="flat" cmpd="sng" algn="ctr">
+                      <a:solidFill>
+                        <a:srgbClr val="E0E0E0"/>
+                      </a:solidFill>
+                      <a:prstDash val="solid"/>
+                      <a:round/>
+                      <a:headEnd type="none" w="med" len="med"/>
+                      <a:tailEnd type="none" w="med" len="med"/>
+                    </a:lnR>
+                    <a:lnT w="6350" cap="flat" cmpd="sng" algn="ctr">
+                      <a:solidFill>
+                        <a:srgbClr val="E0E0E0"/>
+                      </a:solidFill>
+                      <a:prstDash val="solid"/>
+                      <a:round/>
+                      <a:headEnd type="none" w="med" len="med"/>
+                      <a:tailEnd type="none" w="med" len="med"/>
+                    </a:lnT>
+                    <a:lnB w="6350" cap="flat" cmpd="sng" algn="ctr">
+                      <a:solidFill>
+                        <a:srgbClr val="E0E0E0"/>
+                      </a:solidFill>
+                      <a:prstDash val="solid"/>
+                      <a:round/>
+                      <a:headEnd type="none" w="med" len="med"/>
+                      <a:tailEnd type="none" w="med" len="med"/>
+                    </a:lnB>
+                  </a:tcPr>
+                </a:tc>
+                <a:tc>
+                  <a:txBody>
+                    <a:bodyPr/>
+                    <a:lstStyle/>
+                    <a:p>
+                      <a:pPr algn="r" indent="0" marL="0">
+                        <a:buNone/>
+                      </a:pPr>
+                      <a:r>
+                        <a:rPr lang="en-US" sz="1100" b="1" dirty="0">
+                          <a:solidFill>
+                            <a:srgbClr val="D32F2F"/>
+                          </a:solidFill>
+                          <a:latin typeface="Calibri" pitchFamily="34" charset="0"/>
+                          <a:ea typeface="Calibri" pitchFamily="34" charset="-122"/>
+                          <a:cs typeface="Calibri" pitchFamily="34" charset="-120"/>
+                        </a:rPr>
+                        <a:t>0</a:t>
+                      </a:r>
+                      <a:endParaRPr lang="en-US" sz="1100" dirty="0">
+                        <a:latin typeface="Calibri" charset="0"/>
+                        <a:ea typeface="Calibri" charset="0"/>
+                        <a:cs typeface="Calibri" charset="0"/>
+                      </a:endParaRPr>
+                    </a:p>
+                  </a:txBody>
+                  <a:tcPr marL="91440" marR="91440" marT="45720" marB="45720" anchor="ctr">
+                    <a:lnL w="6350" cap="flat" cmpd="sng" algn="ctr">
+                      <a:solidFill>
+                        <a:srgbClr val="E0E0E0"/>
+                      </a:solidFill>
+                      <a:prstDash val="solid"/>
+                      <a:round/>
+                      <a:headEnd type="none" w="med" len="med"/>
+                      <a:tailEnd type="none" w="med" len="med"/>
+                    </a:lnL>
+                    <a:lnR w="6350" cap="flat" cmpd="sng" algn="ctr">
+                      <a:solidFill>
+                        <a:srgbClr val="E0E0E0"/>
+                      </a:solidFill>
+                      <a:prstDash val="solid"/>
+                      <a:round/>
+                      <a:headEnd type="none" w="med" len="med"/>
+                      <a:tailEnd type="none" w="med" len="med"/>
+                    </a:lnR>
+                    <a:lnT w="6350" cap="flat" cmpd="sng" algn="ctr">
+                      <a:solidFill>
+                        <a:srgbClr val="E0E0E0"/>
+                      </a:solidFill>
+                      <a:prstDash val="solid"/>
+                      <a:round/>
+                      <a:headEnd type="none" w="med" len="med"/>
+                      <a:tailEnd type="none" w="med" len="med"/>
+                    </a:lnT>
+                    <a:lnB w="6350" cap="flat" cmpd="sng" algn="ctr">
+                      <a:solidFill>
+                        <a:srgbClr val="E0E0E0"/>
+                      </a:solidFill>
+                      <a:prstDash val="solid"/>
+                      <a:round/>
+                      <a:headEnd type="none" w="med" len="med"/>
+                      <a:tailEnd type="none" w="med" len="med"/>
+                    </a:lnB>
+                    <a:solidFill>
+                      <a:srgbClr val="FFCDD2"/>
+                    </a:solidFill>
+                  </a:tcPr>
+                </a:tc>
+              </a:tr>
+              <a:tr h="365760">
+                <a:tc>
+                  <a:txBody>
+                    <a:bodyPr/>
+                    <a:lstStyle/>
+                    <a:p>
+                      <a:pPr indent="0" marL="0">
+                        <a:buNone/>
+                      </a:pPr>
+                      <a:r>
+                        <a:rPr lang="en-US" sz="1100" dirty="0">
+                          <a:solidFill>
+                            <a:srgbClr val="10332F"/>
+                          </a:solidFill>
+                          <a:latin typeface="Calibri" pitchFamily="34" charset="0"/>
+                          <a:ea typeface="Calibri" pitchFamily="34" charset="-122"/>
+                          <a:cs typeface="Calibri" pitchFamily="34" charset="-120"/>
+                        </a:rPr>
+                        <a:t>getorix oyun yarış direksiyonu</a:t>
+                      </a:r>
+                      <a:endParaRPr lang="en-US" sz="1100" dirty="0">
+                        <a:latin typeface="Calibri" charset="0"/>
+                        <a:ea typeface="Calibri" charset="0"/>
+                        <a:cs typeface="Calibri" charset="0"/>
+                      </a:endParaRPr>
+                    </a:p>
+                  </a:txBody>
+                  <a:tcPr marL="91440" marR="91440" marT="45720" marB="45720" anchor="ctr">
+                    <a:lnL w="6350" cap="flat" cmpd="sng" algn="ctr">
+                      <a:solidFill>
+                        <a:srgbClr val="E0E0E0"/>
+                      </a:solidFill>
+                      <a:prstDash val="solid"/>
+                      <a:round/>
+                      <a:headEnd type="none" w="med" len="med"/>
+                      <a:tailEnd type="none" w="med" len="med"/>
+                    </a:lnL>
+                    <a:lnR w="6350" cap="flat" cmpd="sng" algn="ctr">
+                      <a:solidFill>
+                        <a:srgbClr val="E0E0E0"/>
+                      </a:solidFill>
+                      <a:prstDash val="solid"/>
+                      <a:round/>
+                      <a:headEnd type="none" w="med" len="med"/>
+                      <a:tailEnd type="none" w="med" len="med"/>
+                    </a:lnR>
+                    <a:lnT w="6350" cap="flat" cmpd="sng" algn="ctr">
+                      <a:solidFill>
+                        <a:srgbClr val="E0E0E0"/>
+                      </a:solidFill>
+                      <a:prstDash val="solid"/>
+                      <a:round/>
+                      <a:headEnd type="none" w="med" len="med"/>
+                      <a:tailEnd type="none" w="med" len="med"/>
+                    </a:lnT>
+                    <a:lnB w="6350" cap="flat" cmpd="sng" algn="ctr">
+                      <a:solidFill>
+                        <a:srgbClr val="E0E0E0"/>
+                      </a:solidFill>
+                      <a:prstDash val="solid"/>
+                      <a:round/>
+                      <a:headEnd type="none" w="med" len="med"/>
+                      <a:tailEnd type="none" w="med" len="med"/>
+                    </a:lnB>
+                  </a:tcPr>
+                </a:tc>
+                <a:tc>
+                  <a:txBody>
+                    <a:bodyPr/>
+                    <a:lstStyle/>
+                    <a:p>
+                      <a:pPr indent="0" marL="0">
+                        <a:buNone/>
+                      </a:pPr>
+                      <a:r>
+                        <a:rPr lang="en-US" sz="1100" dirty="0">
+                          <a:solidFill>
+                            <a:srgbClr val="10332F"/>
+                          </a:solidFill>
+                          <a:latin typeface="Calibri" pitchFamily="34" charset="0"/>
+                          <a:ea typeface="Calibri" pitchFamily="34" charset="-122"/>
+                          <a:cs typeface="Calibri" pitchFamily="34" charset="-120"/>
+                        </a:rPr>
+                        <a:t>Ürün</a:t>
+                      </a:r>
+                      <a:endParaRPr lang="en-US" sz="1100" dirty="0">
+                        <a:latin typeface="Calibri" charset="0"/>
+                        <a:ea typeface="Calibri" charset="0"/>
+                        <a:cs typeface="Calibri" charset="0"/>
+                      </a:endParaRPr>
+                    </a:p>
+                  </a:txBody>
+                  <a:tcPr marL="91440" marR="91440" marT="45720" marB="45720" anchor="ctr">
+                    <a:lnL w="6350" cap="flat" cmpd="sng" algn="ctr">
+                      <a:solidFill>
+                        <a:srgbClr val="E0E0E0"/>
+                      </a:solidFill>
+                      <a:prstDash val="solid"/>
+                      <a:round/>
+                      <a:headEnd type="none" w="med" len="med"/>
+                      <a:tailEnd type="none" w="med" len="med"/>
+                    </a:lnL>
+                    <a:lnR w="6350" cap="flat" cmpd="sng" algn="ctr">
+                      <a:solidFill>
+                        <a:srgbClr val="E0E0E0"/>
+                      </a:solidFill>
+                      <a:prstDash val="solid"/>
+                      <a:round/>
+                      <a:headEnd type="none" w="med" len="med"/>
+                      <a:tailEnd type="none" w="med" len="med"/>
+                    </a:lnR>
+                    <a:lnT w="6350" cap="flat" cmpd="sng" algn="ctr">
+                      <a:solidFill>
+                        <a:srgbClr val="E0E0E0"/>
+                      </a:solidFill>
+                      <a:prstDash val="solid"/>
+                      <a:round/>
+                      <a:headEnd type="none" w="med" len="med"/>
+                      <a:tailEnd type="none" w="med" len="med"/>
+                    </a:lnT>
+                    <a:lnB w="6350" cap="flat" cmpd="sng" algn="ctr">
+                      <a:solidFill>
+                        <a:srgbClr val="E0E0E0"/>
+                      </a:solidFill>
+                      <a:prstDash val="solid"/>
+                      <a:round/>
+                      <a:headEnd type="none" w="med" len="med"/>
+                      <a:tailEnd type="none" w="med" len="med"/>
+                    </a:lnB>
+                  </a:tcPr>
+                </a:tc>
+                <a:tc>
+                  <a:txBody>
+                    <a:bodyPr/>
+                    <a:lstStyle/>
+                    <a:p>
+                      <a:pPr algn="r" indent="0" marL="0">
+                        <a:buNone/>
+                      </a:pPr>
+                      <a:r>
+                        <a:rPr lang="en-US" sz="1100" dirty="0">
+                          <a:solidFill>
+                            <a:srgbClr val="10332F"/>
+                          </a:solidFill>
+                          <a:latin typeface="Calibri" pitchFamily="34" charset="0"/>
+                          <a:ea typeface="Calibri" pitchFamily="34" charset="-122"/>
+                          <a:cs typeface="Calibri" pitchFamily="34" charset="-120"/>
+                        </a:rPr>
+                        <a:t>41</a:t>
+                      </a:r>
+                      <a:endParaRPr lang="en-US" sz="1100" dirty="0">
+                        <a:latin typeface="Calibri" charset="0"/>
+                        <a:ea typeface="Calibri" charset="0"/>
+                        <a:cs typeface="Calibri" charset="0"/>
+                      </a:endParaRPr>
+                    </a:p>
+                  </a:txBody>
+                  <a:tcPr marL="91440" marR="91440" marT="45720" marB="45720" anchor="ctr">
+                    <a:lnL w="6350" cap="flat" cmpd="sng" algn="ctr">
+                      <a:solidFill>
+                        <a:srgbClr val="E0E0E0"/>
+                      </a:solidFill>
+                      <a:prstDash val="solid"/>
+                      <a:round/>
+                      <a:headEnd type="none" w="med" len="med"/>
+                      <a:tailEnd type="none" w="med" len="med"/>
+                    </a:lnL>
+                    <a:lnR w="6350" cap="flat" cmpd="sng" algn="ctr">
+                      <a:solidFill>
+                        <a:srgbClr val="E0E0E0"/>
+                      </a:solidFill>
+                      <a:prstDash val="solid"/>
+                      <a:round/>
+                      <a:headEnd type="none" w="med" len="med"/>
+                      <a:tailEnd type="none" w="med" len="med"/>
+                    </a:lnR>
+                    <a:lnT w="6350" cap="flat" cmpd="sng" algn="ctr">
+                      <a:solidFill>
+                        <a:srgbClr val="E0E0E0"/>
+                      </a:solidFill>
+                      <a:prstDash val="solid"/>
+                      <a:round/>
+                      <a:headEnd type="none" w="med" len="med"/>
+                      <a:tailEnd type="none" w="med" len="med"/>
+                    </a:lnT>
+                    <a:lnB w="6350" cap="flat" cmpd="sng" algn="ctr">
+                      <a:solidFill>
+                        <a:srgbClr val="E0E0E0"/>
+                      </a:solidFill>
+                      <a:prstDash val="solid"/>
+                      <a:round/>
+                      <a:headEnd type="none" w="med" len="med"/>
+                      <a:tailEnd type="none" w="med" len="med"/>
+                    </a:lnB>
+                  </a:tcPr>
+                </a:tc>
+                <a:tc>
+                  <a:txBody>
+                    <a:bodyPr/>
+                    <a:lstStyle/>
+                    <a:p>
+                      <a:pPr algn="r" indent="0" marL="0">
+                        <a:buNone/>
+                      </a:pPr>
+                      <a:r>
+                        <a:rPr lang="en-US" sz="1100" b="1" dirty="0">
+                          <a:solidFill>
+                            <a:srgbClr val="D32F2F"/>
+                          </a:solidFill>
+                          <a:latin typeface="Calibri" pitchFamily="34" charset="0"/>
+                          <a:ea typeface="Calibri" pitchFamily="34" charset="-122"/>
+                          <a:cs typeface="Calibri" pitchFamily="34" charset="-120"/>
+                        </a:rPr>
+                        <a:t>0</a:t>
+                      </a:r>
+                      <a:endParaRPr lang="en-US" sz="1100" dirty="0">
+                        <a:latin typeface="Calibri" charset="0"/>
+                        <a:ea typeface="Calibri" charset="0"/>
+                        <a:cs typeface="Calibri" charset="0"/>
+                      </a:endParaRPr>
+                    </a:p>
+                  </a:txBody>
+                  <a:tcPr marL="91440" marR="91440" marT="45720" marB="45720" anchor="ctr">
+                    <a:lnL w="6350" cap="flat" cmpd="sng" algn="ctr">
+                      <a:solidFill>
+                        <a:srgbClr val="E0E0E0"/>
+                      </a:solidFill>
+                      <a:prstDash val="solid"/>
+                      <a:round/>
+                      <a:headEnd type="none" w="med" len="med"/>
+                      <a:tailEnd type="none" w="med" len="med"/>
+                    </a:lnL>
+                    <a:lnR w="6350" cap="flat" cmpd="sng" algn="ctr">
+                      <a:solidFill>
+                        <a:srgbClr val="E0E0E0"/>
+                      </a:solidFill>
+                      <a:prstDash val="solid"/>
+                      <a:round/>
+                      <a:headEnd type="none" w="med" len="med"/>
+                      <a:tailEnd type="none" w="med" len="med"/>
+                    </a:lnR>
+                    <a:lnT w="6350" cap="flat" cmpd="sng" algn="ctr">
+                      <a:solidFill>
+                        <a:srgbClr val="E0E0E0"/>
+                      </a:solidFill>
+                      <a:prstDash val="solid"/>
+                      <a:round/>
+                      <a:headEnd type="none" w="med" len="med"/>
+                      <a:tailEnd type="none" w="med" len="med"/>
+                    </a:lnT>
+                    <a:lnB w="6350" cap="flat" cmpd="sng" algn="ctr">
+                      <a:solidFill>
+                        <a:srgbClr val="E0E0E0"/>
+                      </a:solidFill>
+                      <a:prstDash val="solid"/>
+                      <a:round/>
+                      <a:headEnd type="none" w="med" len="med"/>
+                      <a:tailEnd type="none" w="med" len="med"/>
+                    </a:lnB>
+                    <a:solidFill>
+                      <a:srgbClr val="FFCDD2"/>
+                    </a:solidFill>
+                  </a:tcPr>
+                </a:tc>
+              </a:tr>
+              <a:tr h="365760">
+                <a:tc>
+                  <a:txBody>
+                    <a:bodyPr/>
+                    <a:lstStyle/>
+                    <a:p>
+                      <a:pPr indent="0" marL="0">
+                        <a:buNone/>
+                      </a:pPr>
+                      <a:r>
+                        <a:rPr lang="en-US" sz="1100" dirty="0">
+                          <a:solidFill>
+                            <a:srgbClr val="10332F"/>
+                          </a:solidFill>
+                          <a:latin typeface="Calibri" pitchFamily="34" charset="0"/>
+                          <a:ea typeface="Calibri" pitchFamily="34" charset="-122"/>
+                          <a:cs typeface="Calibri" pitchFamily="34" charset="-120"/>
+                        </a:rPr>
+                        <a:t>acton instant print fotoğraf mak.</a:t>
+                      </a:r>
+                      <a:endParaRPr lang="en-US" sz="1100" dirty="0">
+                        <a:latin typeface="Calibri" charset="0"/>
+                        <a:ea typeface="Calibri" charset="0"/>
+                        <a:cs typeface="Calibri" charset="0"/>
+                      </a:endParaRPr>
+                    </a:p>
+                  </a:txBody>
+                  <a:tcPr marL="91440" marR="91440" marT="45720" marB="45720" anchor="ctr">
+                    <a:lnL w="6350" cap="flat" cmpd="sng" algn="ctr">
+                      <a:solidFill>
+                        <a:srgbClr val="E0E0E0"/>
+                      </a:solidFill>
+                      <a:prstDash val="solid"/>
+                      <a:round/>
+                      <a:headEnd type="none" w="med" len="med"/>
+                      <a:tailEnd type="none" w="med" len="med"/>
+                    </a:lnL>
+                    <a:lnR w="6350" cap="flat" cmpd="sng" algn="ctr">
+                      <a:solidFill>
+                        <a:srgbClr val="E0E0E0"/>
+                      </a:solidFill>
+                      <a:prstDash val="solid"/>
+                      <a:round/>
+                      <a:headEnd type="none" w="med" len="med"/>
+                      <a:tailEnd type="none" w="med" len="med"/>
+                    </a:lnR>
+                    <a:lnT w="6350" cap="flat" cmpd="sng" algn="ctr">
+                      <a:solidFill>
+                        <a:srgbClr val="E0E0E0"/>
+                      </a:solidFill>
+                      <a:prstDash val="solid"/>
+                      <a:round/>
+                      <a:headEnd type="none" w="med" len="med"/>
+                      <a:tailEnd type="none" w="med" len="med"/>
+                    </a:lnT>
+                    <a:lnB w="6350" cap="flat" cmpd="sng" algn="ctr">
+                      <a:solidFill>
+                        <a:srgbClr val="E0E0E0"/>
+                      </a:solidFill>
+                      <a:prstDash val="solid"/>
+                      <a:round/>
+                      <a:headEnd type="none" w="med" len="med"/>
+                      <a:tailEnd type="none" w="med" len="med"/>
+                    </a:lnB>
+                  </a:tcPr>
+                </a:tc>
+                <a:tc>
+                  <a:txBody>
+                    <a:bodyPr/>
+                    <a:lstStyle/>
+                    <a:p>
+                      <a:pPr indent="0" marL="0">
+                        <a:buNone/>
+                      </a:pPr>
+                      <a:r>
+                        <a:rPr lang="en-US" sz="1100" dirty="0">
+                          <a:solidFill>
+                            <a:srgbClr val="10332F"/>
+                          </a:solidFill>
+                          <a:latin typeface="Calibri" pitchFamily="34" charset="0"/>
+                          <a:ea typeface="Calibri" pitchFamily="34" charset="-122"/>
+                          <a:cs typeface="Calibri" pitchFamily="34" charset="-120"/>
+                        </a:rPr>
+                        <a:t>Ürün</a:t>
+                      </a:r>
+                      <a:endParaRPr lang="en-US" sz="1100" dirty="0">
+                        <a:latin typeface="Calibri" charset="0"/>
+                        <a:ea typeface="Calibri" charset="0"/>
+                        <a:cs typeface="Calibri" charset="0"/>
+                      </a:endParaRPr>
+                    </a:p>
+                  </a:txBody>
+                  <a:tcPr marL="91440" marR="91440" marT="45720" marB="45720" anchor="ctr">
+                    <a:lnL w="6350" cap="flat" cmpd="sng" algn="ctr">
+                      <a:solidFill>
+                        <a:srgbClr val="E0E0E0"/>
+                      </a:solidFill>
+                      <a:prstDash val="solid"/>
+                      <a:round/>
+                      <a:headEnd type="none" w="med" len="med"/>
+                      <a:tailEnd type="none" w="med" len="med"/>
+                    </a:lnL>
+                    <a:lnR w="6350" cap="flat" cmpd="sng" algn="ctr">
+                      <a:solidFill>
+                        <a:srgbClr val="E0E0E0"/>
+                      </a:solidFill>
+                      <a:prstDash val="solid"/>
+                      <a:round/>
+                      <a:headEnd type="none" w="med" len="med"/>
+                      <a:tailEnd type="none" w="med" len="med"/>
+                    </a:lnR>
+                    <a:lnT w="6350" cap="flat" cmpd="sng" algn="ctr">
+                      <a:solidFill>
+                        <a:srgbClr val="E0E0E0"/>
+                      </a:solidFill>
+                      <a:prstDash val="solid"/>
+                      <a:round/>
+                      <a:headEnd type="none" w="med" len="med"/>
+                      <a:tailEnd type="none" w="med" len="med"/>
+                    </a:lnT>
+                    <a:lnB w="6350" cap="flat" cmpd="sng" algn="ctr">
+                      <a:solidFill>
+                        <a:srgbClr val="E0E0E0"/>
+                      </a:solidFill>
+                      <a:prstDash val="solid"/>
+                      <a:round/>
+                      <a:headEnd type="none" w="med" len="med"/>
+                      <a:tailEnd type="none" w="med" len="med"/>
+                    </a:lnB>
+                  </a:tcPr>
+                </a:tc>
+                <a:tc>
+                  <a:txBody>
+                    <a:bodyPr/>
+                    <a:lstStyle/>
+                    <a:p>
+                      <a:pPr algn="r" indent="0" marL="0">
+                        <a:buNone/>
+                      </a:pPr>
+                      <a:r>
+                        <a:rPr lang="en-US" sz="1100" dirty="0">
+                          <a:solidFill>
+                            <a:srgbClr val="10332F"/>
+                          </a:solidFill>
+                          <a:latin typeface="Calibri" pitchFamily="34" charset="0"/>
+                          <a:ea typeface="Calibri" pitchFamily="34" charset="-122"/>
+                          <a:cs typeface="Calibri" pitchFamily="34" charset="-120"/>
+                        </a:rPr>
+                        <a:t>38</a:t>
+                      </a:r>
+                      <a:endParaRPr lang="en-US" sz="1100" dirty="0">
+                        <a:latin typeface="Calibri" charset="0"/>
+                        <a:ea typeface="Calibri" charset="0"/>
+                        <a:cs typeface="Calibri" charset="0"/>
+                      </a:endParaRPr>
+                    </a:p>
+                  </a:txBody>
+                  <a:tcPr marL="91440" marR="91440" marT="45720" marB="45720" anchor="ctr">
+                    <a:lnL w="6350" cap="flat" cmpd="sng" algn="ctr">
+                      <a:solidFill>
+                        <a:srgbClr val="E0E0E0"/>
+                      </a:solidFill>
+                      <a:prstDash val="solid"/>
+                      <a:round/>
+                      <a:headEnd type="none" w="med" len="med"/>
+                      <a:tailEnd type="none" w="med" len="med"/>
+                    </a:lnL>
+                    <a:lnR w="6350" cap="flat" cmpd="sng" algn="ctr">
+                      <a:solidFill>
+                        <a:srgbClr val="E0E0E0"/>
+                      </a:solidFill>
+                      <a:prstDash val="solid"/>
+                      <a:round/>
+                      <a:headEnd type="none" w="med" len="med"/>
+                      <a:tailEnd type="none" w="med" len="med"/>
+                    </a:lnR>
+                    <a:lnT w="6350" cap="flat" cmpd="sng" algn="ctr">
+                      <a:solidFill>
+                        <a:srgbClr val="E0E0E0"/>
+                      </a:solidFill>
+                      <a:prstDash val="solid"/>
+                      <a:round/>
+                      <a:headEnd type="none" w="med" len="med"/>
+                      <a:tailEnd type="none" w="med" len="med"/>
+                    </a:lnT>
+                    <a:lnB w="6350" cap="flat" cmpd="sng" algn="ctr">
+                      <a:solidFill>
+                        <a:srgbClr val="E0E0E0"/>
+                      </a:solidFill>
+                      <a:prstDash val="solid"/>
+                      <a:round/>
+                      <a:headEnd type="none" w="med" len="med"/>
+                      <a:tailEnd type="none" w="med" len="med"/>
+                    </a:lnB>
+                  </a:tcPr>
+                </a:tc>
+                <a:tc>
+                  <a:txBody>
+                    <a:bodyPr/>
+                    <a:lstStyle/>
+                    <a:p>
+                      <a:pPr algn="r" indent="0" marL="0">
+                        <a:buNone/>
+                      </a:pPr>
+                      <a:r>
+                        <a:rPr lang="en-US" sz="1100" b="1" dirty="0">
+                          <a:solidFill>
+                            <a:srgbClr val="D32F2F"/>
+                          </a:solidFill>
+                          <a:latin typeface="Calibri" pitchFamily="34" charset="0"/>
+                          <a:ea typeface="Calibri" pitchFamily="34" charset="-122"/>
+                          <a:cs typeface="Calibri" pitchFamily="34" charset="-120"/>
+                        </a:rPr>
+                        <a:t>0</a:t>
+                      </a:r>
+                      <a:endParaRPr lang="en-US" sz="1100" dirty="0">
                         <a:latin typeface="Calibri" charset="0"/>
                         <a:ea typeface="Calibri" charset="0"/>
                         <a:cs typeface="Calibri" charset="0"/>
@@ -18179,7 +19275,7 @@
                           <a:ea typeface="Calibri" pitchFamily="34" charset="-122"/>
                           <a:cs typeface="Calibri" pitchFamily="34" charset="-120"/>
                         </a:rPr>
-                        <a:t>fissler serisi</a:t>
+                        <a:t>lumberjack ayakkabı</a:t>
                       </a:r>
                       <a:endParaRPr lang="en-US" sz="1200" dirty="0">
                         <a:latin typeface="Calibri" charset="0"/>
@@ -18244,7 +19340,7 @@
                           <a:ea typeface="Calibri" pitchFamily="34" charset="-122"/>
                           <a:cs typeface="Calibri" pitchFamily="34" charset="-120"/>
                         </a:rPr>
-                        <a:t>1+</a:t>
+                        <a:t>2</a:t>
                       </a:r>
                       <a:endParaRPr lang="en-US" sz="1200" dirty="0">
                         <a:latin typeface="Calibri" charset="0"/>
@@ -18311,7 +19407,7 @@
                           <a:ea typeface="Calibri" pitchFamily="34" charset="-122"/>
                           <a:cs typeface="Calibri" pitchFamily="34" charset="-120"/>
                         </a:rPr>
-                        <a:t>özdilek pike</a:t>
+                        <a:t>tefal tost makinesi</a:t>
                       </a:r>
                       <a:endParaRPr lang="en-US" sz="1200" dirty="0">
                         <a:latin typeface="Calibri" charset="0"/>
@@ -18376,7 +19472,7 @@
                           <a:ea typeface="Calibri" pitchFamily="34" charset="-122"/>
                           <a:cs typeface="Calibri" pitchFamily="34" charset="-120"/>
                         </a:rPr>
-                        <a:t>1</a:t>
+                        <a:t>2</a:t>
                       </a:r>
                       <a:endParaRPr lang="en-US" sz="1200" dirty="0">
                         <a:latin typeface="Calibri" charset="0"/>
@@ -18443,7 +19539,7 @@
                           <a:ea typeface="Calibri" pitchFamily="34" charset="-122"/>
                           <a:cs typeface="Calibri" pitchFamily="34" charset="-120"/>
                         </a:rPr>
-                        <a:t>market ürünleri</a:t>
+                        <a:t>özdilek yorgan</a:t>
                       </a:r>
                       <a:endParaRPr lang="en-US" sz="1200" dirty="0">
                         <a:latin typeface="Calibri" charset="0"/>
@@ -18508,7 +19604,7 @@
                           <a:ea typeface="Calibri" pitchFamily="34" charset="-122"/>
                           <a:cs typeface="Calibri" pitchFamily="34" charset="-120"/>
                         </a:rPr>
-                        <a:t>1+</a:t>
+                        <a:t>2</a:t>
                       </a:r>
                       <a:endParaRPr lang="en-US" sz="1200" dirty="0">
                         <a:latin typeface="Calibri" charset="0"/>
@@ -18871,7 +19967,7 @@
           </p:nvPr>
         </p:nvGraphicFramePr>
         <p:xfrm>
-          <a:off x="7315200" y="1737360"/>
+          <a:off x="7315200" y="1554480"/>
           <a:ext cx="4389120" cy="914400"/>
         </p:xfrm>
         <a:graphic>
@@ -18884,7 +19980,7 @@
                 <a:gridCol w="1097280"/>
                 <a:gridCol w="731520"/>
               </a:tblGrid>
-              <a:tr h="384048">
+              <a:tr h="329184">
                 <a:tc>
                   <a:txBody>
                     <a:bodyPr/>
@@ -18894,7 +19990,7 @@
                         <a:buNone/>
                       </a:pPr>
                       <a:r>
-                        <a:rPr lang="en-US" sz="1100" b="1" dirty="0">
+                        <a:rPr lang="en-US" sz="1050" b="1" dirty="0">
                           <a:solidFill>
                             <a:srgbClr val="10332F"/>
                           </a:solidFill>
@@ -18904,7 +20000,7 @@
                         </a:rPr>
                         <a:t>Marka</a:t>
                       </a:r>
-                      <a:endParaRPr lang="en-US" sz="1100" dirty="0">
+                      <a:endParaRPr lang="en-US" sz="1050" dirty="0">
                         <a:latin typeface="Calibri" charset="0"/>
                         <a:ea typeface="Calibri" charset="0"/>
                         <a:cs typeface="Calibri" charset="0"/>
@@ -18959,7 +20055,7 @@
                         <a:buNone/>
                       </a:pPr>
                       <a:r>
-                        <a:rPr lang="en-US" sz="1100" b="1" dirty="0">
+                        <a:rPr lang="en-US" sz="1050" b="1" dirty="0">
                           <a:solidFill>
                             <a:srgbClr val="10332F"/>
                           </a:solidFill>
@@ -18969,7 +20065,7 @@
                         </a:rPr>
                         <a:t>Oturum</a:t>
                       </a:r>
-                      <a:endParaRPr lang="en-US" sz="1100" dirty="0">
+                      <a:endParaRPr lang="en-US" sz="1050" dirty="0">
                         <a:latin typeface="Calibri" charset="0"/>
                         <a:ea typeface="Calibri" charset="0"/>
                         <a:cs typeface="Calibri" charset="0"/>
@@ -19024,7 +20120,7 @@
                         <a:buNone/>
                       </a:pPr>
                       <a:r>
-                        <a:rPr lang="en-US" sz="1100" b="1" dirty="0">
+                        <a:rPr lang="en-US" sz="1050" b="1" dirty="0">
                           <a:solidFill>
                             <a:srgbClr val="10332F"/>
                           </a:solidFill>
@@ -19034,7 +20130,7 @@
                         </a:rPr>
                         <a:t>Ciro</a:t>
                       </a:r>
-                      <a:endParaRPr lang="en-US" sz="1100" dirty="0">
+                      <a:endParaRPr lang="en-US" sz="1050" dirty="0">
                         <a:latin typeface="Calibri" charset="0"/>
                         <a:ea typeface="Calibri" charset="0"/>
                         <a:cs typeface="Calibri" charset="0"/>
@@ -19089,7 +20185,7 @@
                         <a:buNone/>
                       </a:pPr>
                       <a:r>
-                        <a:rPr lang="en-US" sz="1100" b="1" dirty="0">
+                        <a:rPr lang="en-US" sz="1050" b="1" dirty="0">
                           <a:solidFill>
                             <a:srgbClr val="10332F"/>
                           </a:solidFill>
@@ -19099,7 +20195,7 @@
                         </a:rPr>
                         <a:t>Tx</a:t>
                       </a:r>
-                      <a:endParaRPr lang="en-US" sz="1100" dirty="0">
+                      <a:endParaRPr lang="en-US" sz="1050" dirty="0">
                         <a:latin typeface="Calibri" charset="0"/>
                         <a:ea typeface="Calibri" charset="0"/>
                         <a:cs typeface="Calibri" charset="0"/>
@@ -19146,7 +20242,7 @@
                   </a:tcPr>
                 </a:tc>
               </a:tr>
-              <a:tr h="384048">
+              <a:tr h="329184">
                 <a:tc>
                   <a:txBody>
                     <a:bodyPr/>
@@ -19156,7 +20252,7 @@
                         <a:buNone/>
                       </a:pPr>
                       <a:r>
-                        <a:rPr lang="en-US" sz="1100" dirty="0">
+                        <a:rPr lang="en-US" sz="1050" dirty="0">
                           <a:solidFill>
                             <a:srgbClr val="10332F"/>
                           </a:solidFill>
@@ -19166,7 +20262,7 @@
                         </a:rPr>
                         <a:t>Özdilek</a:t>
                       </a:r>
-                      <a:endParaRPr lang="en-US" sz="1100" dirty="0">
+                      <a:endParaRPr lang="en-US" sz="1050" dirty="0">
                         <a:latin typeface="Calibri" charset="0"/>
                         <a:ea typeface="Calibri" charset="0"/>
                         <a:cs typeface="Calibri" charset="0"/>
@@ -19221,7 +20317,7 @@
                         <a:buNone/>
                       </a:pPr>
                       <a:r>
-                        <a:rPr lang="en-US" sz="1100" dirty="0">
+                        <a:rPr lang="en-US" sz="1050" dirty="0">
                           <a:solidFill>
                             <a:srgbClr val="10332F"/>
                           </a:solidFill>
@@ -19231,7 +20327,7 @@
                         </a:rPr>
                         <a:t>1.823</a:t>
                       </a:r>
-                      <a:endParaRPr lang="en-US" sz="1100" dirty="0">
+                      <a:endParaRPr lang="en-US" sz="1050" dirty="0">
                         <a:latin typeface="Calibri" charset="0"/>
                         <a:ea typeface="Calibri" charset="0"/>
                         <a:cs typeface="Calibri" charset="0"/>
@@ -19286,7 +20382,7 @@
                         <a:buNone/>
                       </a:pPr>
                       <a:r>
-                        <a:rPr lang="en-US" sz="1100" dirty="0">
+                        <a:rPr lang="en-US" sz="1050" dirty="0">
                           <a:solidFill>
                             <a:srgbClr val="10332F"/>
                           </a:solidFill>
@@ -19296,7 +20392,7 @@
                         </a:rPr>
                         <a:t>₺41,7K</a:t>
                       </a:r>
-                      <a:endParaRPr lang="en-US" sz="1100" dirty="0">
+                      <a:endParaRPr lang="en-US" sz="1050" dirty="0">
                         <a:latin typeface="Calibri" charset="0"/>
                         <a:ea typeface="Calibri" charset="0"/>
                         <a:cs typeface="Calibri" charset="0"/>
@@ -19351,7 +20447,7 @@
                         <a:buNone/>
                       </a:pPr>
                       <a:r>
-                        <a:rPr lang="en-US" sz="1100" dirty="0">
+                        <a:rPr lang="en-US" sz="1050" dirty="0">
                           <a:solidFill>
                             <a:srgbClr val="10332F"/>
                           </a:solidFill>
@@ -19361,7 +20457,7 @@
                         </a:rPr>
                         <a:t>12</a:t>
                       </a:r>
-                      <a:endParaRPr lang="en-US" sz="1100" dirty="0">
+                      <a:endParaRPr lang="en-US" sz="1050" dirty="0">
                         <a:latin typeface="Calibri" charset="0"/>
                         <a:ea typeface="Calibri" charset="0"/>
                         <a:cs typeface="Calibri" charset="0"/>
@@ -19408,7 +20504,7 @@
                   </a:tcPr>
                 </a:tc>
               </a:tr>
-              <a:tr h="384048">
+              <a:tr h="329184">
                 <a:tc>
                   <a:txBody>
                     <a:bodyPr/>
@@ -19418,7 +20514,7 @@
                         <a:buNone/>
                       </a:pPr>
                       <a:r>
-                        <a:rPr lang="en-US" sz="1100" dirty="0">
+                        <a:rPr lang="en-US" sz="1050" dirty="0">
                           <a:solidFill>
                             <a:srgbClr val="10332F"/>
                           </a:solidFill>
@@ -19428,7 +20524,7 @@
                         </a:rPr>
                         <a:t>Mavi</a:t>
                       </a:r>
-                      <a:endParaRPr lang="en-US" sz="1100" dirty="0">
+                      <a:endParaRPr lang="en-US" sz="1050" dirty="0">
                         <a:latin typeface="Calibri" charset="0"/>
                         <a:ea typeface="Calibri" charset="0"/>
                         <a:cs typeface="Calibri" charset="0"/>
@@ -19483,7 +20579,7 @@
                         <a:buNone/>
                       </a:pPr>
                       <a:r>
-                        <a:rPr lang="en-US" sz="1100" dirty="0">
+                        <a:rPr lang="en-US" sz="1050" dirty="0">
                           <a:solidFill>
                             <a:srgbClr val="10332F"/>
                           </a:solidFill>
@@ -19493,7 +20589,7 @@
                         </a:rPr>
                         <a:t>1.299</a:t>
                       </a:r>
-                      <a:endParaRPr lang="en-US" sz="1100" dirty="0">
+                      <a:endParaRPr lang="en-US" sz="1050" dirty="0">
                         <a:latin typeface="Calibri" charset="0"/>
                         <a:ea typeface="Calibri" charset="0"/>
                         <a:cs typeface="Calibri" charset="0"/>
@@ -19548,7 +20644,7 @@
                         <a:buNone/>
                       </a:pPr>
                       <a:r>
-                        <a:rPr lang="en-US" sz="1100" dirty="0">
+                        <a:rPr lang="en-US" sz="1050" dirty="0">
                           <a:solidFill>
                             <a:srgbClr val="10332F"/>
                           </a:solidFill>
@@ -19558,7 +20654,7 @@
                         </a:rPr>
                         <a:t>₺13,9K</a:t>
                       </a:r>
-                      <a:endParaRPr lang="en-US" sz="1100" dirty="0">
+                      <a:endParaRPr lang="en-US" sz="1050" dirty="0">
                         <a:latin typeface="Calibri" charset="0"/>
                         <a:ea typeface="Calibri" charset="0"/>
                         <a:cs typeface="Calibri" charset="0"/>
@@ -19613,7 +20709,7 @@
                         <a:buNone/>
                       </a:pPr>
                       <a:r>
-                        <a:rPr lang="en-US" sz="1100" dirty="0">
+                        <a:rPr lang="en-US" sz="1050" dirty="0">
                           <a:solidFill>
                             <a:srgbClr val="10332F"/>
                           </a:solidFill>
@@ -19623,7 +20719,7 @@
                         </a:rPr>
                         <a:t>11</a:t>
                       </a:r>
-                      <a:endParaRPr lang="en-US" sz="1100" dirty="0">
+                      <a:endParaRPr lang="en-US" sz="1050" dirty="0">
                         <a:latin typeface="Calibri" charset="0"/>
                         <a:ea typeface="Calibri" charset="0"/>
                         <a:cs typeface="Calibri" charset="0"/>
@@ -19670,7 +20766,7 @@
                   </a:tcPr>
                 </a:tc>
               </a:tr>
-              <a:tr h="384048">
+              <a:tr h="329184">
                 <a:tc>
                   <a:txBody>
                     <a:bodyPr/>
@@ -19680,7 +20776,7 @@
                         <a:buNone/>
                       </a:pPr>
                       <a:r>
-                        <a:rPr lang="en-US" sz="1100" dirty="0">
+                        <a:rPr lang="en-US" sz="1050" dirty="0">
                           <a:solidFill>
                             <a:srgbClr val="10332F"/>
                           </a:solidFill>
@@ -19690,7 +20786,7 @@
                         </a:rPr>
                         <a:t>Adidas</a:t>
                       </a:r>
-                      <a:endParaRPr lang="en-US" sz="1100" dirty="0">
+                      <a:endParaRPr lang="en-US" sz="1050" dirty="0">
                         <a:latin typeface="Calibri" charset="0"/>
                         <a:ea typeface="Calibri" charset="0"/>
                         <a:cs typeface="Calibri" charset="0"/>
@@ -19745,7 +20841,7 @@
                         <a:buNone/>
                       </a:pPr>
                       <a:r>
-                        <a:rPr lang="en-US" sz="1100" dirty="0">
+                        <a:rPr lang="en-US" sz="1050" dirty="0">
                           <a:solidFill>
                             <a:srgbClr val="10332F"/>
                           </a:solidFill>
@@ -19755,7 +20851,7 @@
                         </a:rPr>
                         <a:t>1.232</a:t>
                       </a:r>
-                      <a:endParaRPr lang="en-US" sz="1100" dirty="0">
+                      <a:endParaRPr lang="en-US" sz="1050" dirty="0">
                         <a:latin typeface="Calibri" charset="0"/>
                         <a:ea typeface="Calibri" charset="0"/>
                         <a:cs typeface="Calibri" charset="0"/>
@@ -19810,7 +20906,7 @@
                         <a:buNone/>
                       </a:pPr>
                       <a:r>
-                        <a:rPr lang="en-US" sz="1100" dirty="0">
+                        <a:rPr lang="en-US" sz="1050" dirty="0">
                           <a:solidFill>
                             <a:srgbClr val="10332F"/>
                           </a:solidFill>
@@ -19820,7 +20916,7 @@
                         </a:rPr>
                         <a:t>₺34,5K</a:t>
                       </a:r>
-                      <a:endParaRPr lang="en-US" sz="1100" dirty="0">
+                      <a:endParaRPr lang="en-US" sz="1050" dirty="0">
                         <a:latin typeface="Calibri" charset="0"/>
                         <a:ea typeface="Calibri" charset="0"/>
                         <a:cs typeface="Calibri" charset="0"/>
@@ -19875,7 +20971,7 @@
                         <a:buNone/>
                       </a:pPr>
                       <a:r>
-                        <a:rPr lang="en-US" sz="1100" dirty="0">
+                        <a:rPr lang="en-US" sz="1050" dirty="0">
                           <a:solidFill>
                             <a:srgbClr val="10332F"/>
                           </a:solidFill>
@@ -19885,7 +20981,7 @@
                         </a:rPr>
                         <a:t>13</a:t>
                       </a:r>
-                      <a:endParaRPr lang="en-US" sz="1100" dirty="0">
+                      <a:endParaRPr lang="en-US" sz="1050" dirty="0">
                         <a:latin typeface="Calibri" charset="0"/>
                         <a:ea typeface="Calibri" charset="0"/>
                         <a:cs typeface="Calibri" charset="0"/>
@@ -19932,7 +21028,7 @@
                   </a:tcPr>
                 </a:tc>
               </a:tr>
-              <a:tr h="384048">
+              <a:tr h="329184">
                 <a:tc>
                   <a:txBody>
                     <a:bodyPr/>
@@ -19942,7 +21038,7 @@
                         <a:buNone/>
                       </a:pPr>
                       <a:r>
-                        <a:rPr lang="en-US" sz="1100" dirty="0">
+                        <a:rPr lang="en-US" sz="1050" dirty="0">
                           <a:solidFill>
                             <a:srgbClr val="10332F"/>
                           </a:solidFill>
@@ -19952,7 +21048,7 @@
                         </a:rPr>
                         <a:t>Skechers</a:t>
                       </a:r>
-                      <a:endParaRPr lang="en-US" sz="1100" dirty="0">
+                      <a:endParaRPr lang="en-US" sz="1050" dirty="0">
                         <a:latin typeface="Calibri" charset="0"/>
                         <a:ea typeface="Calibri" charset="0"/>
                         <a:cs typeface="Calibri" charset="0"/>
@@ -20007,7 +21103,7 @@
                         <a:buNone/>
                       </a:pPr>
                       <a:r>
-                        <a:rPr lang="en-US" sz="1100" dirty="0">
+                        <a:rPr lang="en-US" sz="1050" dirty="0">
                           <a:solidFill>
                             <a:srgbClr val="10332F"/>
                           </a:solidFill>
@@ -20017,7 +21113,7 @@
                         </a:rPr>
                         <a:t>867</a:t>
                       </a:r>
-                      <a:endParaRPr lang="en-US" sz="1100" dirty="0">
+                      <a:endParaRPr lang="en-US" sz="1050" dirty="0">
                         <a:latin typeface="Calibri" charset="0"/>
                         <a:ea typeface="Calibri" charset="0"/>
                         <a:cs typeface="Calibri" charset="0"/>
@@ -20072,7 +21168,7 @@
                         <a:buNone/>
                       </a:pPr>
                       <a:r>
-                        <a:rPr lang="en-US" sz="1100" dirty="0">
+                        <a:rPr lang="en-US" sz="1050" dirty="0">
                           <a:solidFill>
                             <a:srgbClr val="10332F"/>
                           </a:solidFill>
@@ -20082,7 +21178,7 @@
                         </a:rPr>
                         <a:t>₺39,8K</a:t>
                       </a:r>
-                      <a:endParaRPr lang="en-US" sz="1100" dirty="0">
+                      <a:endParaRPr lang="en-US" sz="1050" dirty="0">
                         <a:latin typeface="Calibri" charset="0"/>
                         <a:ea typeface="Calibri" charset="0"/>
                         <a:cs typeface="Calibri" charset="0"/>
@@ -20137,7 +21233,7 @@
                         <a:buNone/>
                       </a:pPr>
                       <a:r>
-                        <a:rPr lang="en-US" sz="1100" dirty="0">
+                        <a:rPr lang="en-US" sz="1050" dirty="0">
                           <a:solidFill>
                             <a:srgbClr val="10332F"/>
                           </a:solidFill>
@@ -20147,7 +21243,7 @@
                         </a:rPr>
                         <a:t>9</a:t>
                       </a:r>
-                      <a:endParaRPr lang="en-US" sz="1100" dirty="0">
+                      <a:endParaRPr lang="en-US" sz="1050" dirty="0">
                         <a:latin typeface="Calibri" charset="0"/>
                         <a:ea typeface="Calibri" charset="0"/>
                         <a:cs typeface="Calibri" charset="0"/>
@@ -20194,7 +21290,7 @@
                   </a:tcPr>
                 </a:tc>
               </a:tr>
-              <a:tr h="384048">
+              <a:tr h="329184">
                 <a:tc>
                   <a:txBody>
                     <a:bodyPr/>
@@ -20204,7 +21300,7 @@
                         <a:buNone/>
                       </a:pPr>
                       <a:r>
-                        <a:rPr lang="en-US" sz="1100" dirty="0">
+                        <a:rPr lang="en-US" sz="1050" dirty="0">
                           <a:solidFill>
                             <a:srgbClr val="10332F"/>
                           </a:solidFill>
@@ -20214,7 +21310,7 @@
                         </a:rPr>
                         <a:t>Philips</a:t>
                       </a:r>
-                      <a:endParaRPr lang="en-US" sz="1100" dirty="0">
+                      <a:endParaRPr lang="en-US" sz="1050" dirty="0">
                         <a:latin typeface="Calibri" charset="0"/>
                         <a:ea typeface="Calibri" charset="0"/>
                         <a:cs typeface="Calibri" charset="0"/>
@@ -20269,7 +21365,7 @@
                         <a:buNone/>
                       </a:pPr>
                       <a:r>
-                        <a:rPr lang="en-US" sz="1100" dirty="0">
+                        <a:rPr lang="en-US" sz="1050" dirty="0">
                           <a:solidFill>
                             <a:srgbClr val="10332F"/>
                           </a:solidFill>
@@ -20279,7 +21375,7 @@
                         </a:rPr>
                         <a:t>847</a:t>
                       </a:r>
-                      <a:endParaRPr lang="en-US" sz="1100" dirty="0">
+                      <a:endParaRPr lang="en-US" sz="1050" dirty="0">
                         <a:latin typeface="Calibri" charset="0"/>
                         <a:ea typeface="Calibri" charset="0"/>
                         <a:cs typeface="Calibri" charset="0"/>
@@ -20334,7 +21430,7 @@
                         <a:buNone/>
                       </a:pPr>
                       <a:r>
-                        <a:rPr lang="en-US" sz="1100" dirty="0">
+                        <a:rPr lang="en-US" sz="1050" dirty="0">
                           <a:solidFill>
                             <a:srgbClr val="10332F"/>
                           </a:solidFill>
@@ -20344,7 +21440,7 @@
                         </a:rPr>
                         <a:t>₺12,7K</a:t>
                       </a:r>
-                      <a:endParaRPr lang="en-US" sz="1100" dirty="0">
+                      <a:endParaRPr lang="en-US" sz="1050" dirty="0">
                         <a:latin typeface="Calibri" charset="0"/>
                         <a:ea typeface="Calibri" charset="0"/>
                         <a:cs typeface="Calibri" charset="0"/>
@@ -20399,7 +21495,7 @@
                         <a:buNone/>
                       </a:pPr>
                       <a:r>
-                        <a:rPr lang="en-US" sz="1100" dirty="0">
+                        <a:rPr lang="en-US" sz="1050" dirty="0">
                           <a:solidFill>
                             <a:srgbClr val="10332F"/>
                           </a:solidFill>
@@ -20409,7 +21505,7 @@
                         </a:rPr>
                         <a:t>2</a:t>
                       </a:r>
-                      <a:endParaRPr lang="en-US" sz="1100" dirty="0">
+                      <a:endParaRPr lang="en-US" sz="1050" dirty="0">
                         <a:latin typeface="Calibri" charset="0"/>
                         <a:ea typeface="Calibri" charset="0"/>
                         <a:cs typeface="Calibri" charset="0"/>
@@ -20456,7 +21552,7 @@
                   </a:tcPr>
                 </a:tc>
               </a:tr>
-              <a:tr h="384048">
+              <a:tr h="329184">
                 <a:tc>
                   <a:txBody>
                     <a:bodyPr/>
@@ -20466,7 +21562,7 @@
                         <a:buNone/>
                       </a:pPr>
                       <a:r>
-                        <a:rPr lang="en-US" sz="1100" dirty="0">
+                        <a:rPr lang="en-US" sz="1050" dirty="0">
                           <a:solidFill>
                             <a:srgbClr val="10332F"/>
                           </a:solidFill>
@@ -20476,7 +21572,7 @@
                         </a:rPr>
                         <a:t>Pierre Cardin</a:t>
                       </a:r>
-                      <a:endParaRPr lang="en-US" sz="1100" dirty="0">
+                      <a:endParaRPr lang="en-US" sz="1050" dirty="0">
                         <a:latin typeface="Calibri" charset="0"/>
                         <a:ea typeface="Calibri" charset="0"/>
                         <a:cs typeface="Calibri" charset="0"/>
@@ -20531,7 +21627,7 @@
                         <a:buNone/>
                       </a:pPr>
                       <a:r>
-                        <a:rPr lang="en-US" sz="1100" dirty="0">
+                        <a:rPr lang="en-US" sz="1050" dirty="0">
                           <a:solidFill>
                             <a:srgbClr val="10332F"/>
                           </a:solidFill>
@@ -20541,7 +21637,7 @@
                         </a:rPr>
                         <a:t>610</a:t>
                       </a:r>
-                      <a:endParaRPr lang="en-US" sz="1100" dirty="0">
+                      <a:endParaRPr lang="en-US" sz="1050" dirty="0">
                         <a:latin typeface="Calibri" charset="0"/>
                         <a:ea typeface="Calibri" charset="0"/>
                         <a:cs typeface="Calibri" charset="0"/>
@@ -20596,7 +21692,7 @@
                         <a:buNone/>
                       </a:pPr>
                       <a:r>
-                        <a:rPr lang="en-US" sz="1100" dirty="0">
+                        <a:rPr lang="en-US" sz="1050" dirty="0">
                           <a:solidFill>
                             <a:srgbClr val="10332F"/>
                           </a:solidFill>
@@ -20606,7 +21702,7 @@
                         </a:rPr>
                         <a:t>₺22,5K</a:t>
                       </a:r>
-                      <a:endParaRPr lang="en-US" sz="1100" dirty="0">
+                      <a:endParaRPr lang="en-US" sz="1050" dirty="0">
                         <a:latin typeface="Calibri" charset="0"/>
                         <a:ea typeface="Calibri" charset="0"/>
                         <a:cs typeface="Calibri" charset="0"/>
@@ -20661,7 +21757,7 @@
                         <a:buNone/>
                       </a:pPr>
                       <a:r>
-                        <a:rPr lang="en-US" sz="1100" dirty="0">
+                        <a:rPr lang="en-US" sz="1050" dirty="0">
                           <a:solidFill>
                             <a:srgbClr val="10332F"/>
                           </a:solidFill>
@@ -20671,7 +21767,1055 @@
                         </a:rPr>
                         <a:t>6</a:t>
                       </a:r>
-                      <a:endParaRPr lang="en-US" sz="1100" dirty="0">
+                      <a:endParaRPr lang="en-US" sz="1050" dirty="0">
+                        <a:latin typeface="Calibri" charset="0"/>
+                        <a:ea typeface="Calibri" charset="0"/>
+                        <a:cs typeface="Calibri" charset="0"/>
+                      </a:endParaRPr>
+                    </a:p>
+                  </a:txBody>
+                  <a:tcPr marL="91440" marR="91440" marT="45720" marB="45720" anchor="ctr">
+                    <a:lnL w="6350" cap="flat" cmpd="sng" algn="ctr">
+                      <a:solidFill>
+                        <a:srgbClr val="E0E0E0"/>
+                      </a:solidFill>
+                      <a:prstDash val="solid"/>
+                      <a:round/>
+                      <a:headEnd type="none" w="med" len="med"/>
+                      <a:tailEnd type="none" w="med" len="med"/>
+                    </a:lnL>
+                    <a:lnR w="6350" cap="flat" cmpd="sng" algn="ctr">
+                      <a:solidFill>
+                        <a:srgbClr val="E0E0E0"/>
+                      </a:solidFill>
+                      <a:prstDash val="solid"/>
+                      <a:round/>
+                      <a:headEnd type="none" w="med" len="med"/>
+                      <a:tailEnd type="none" w="med" len="med"/>
+                    </a:lnR>
+                    <a:lnT w="6350" cap="flat" cmpd="sng" algn="ctr">
+                      <a:solidFill>
+                        <a:srgbClr val="E0E0E0"/>
+                      </a:solidFill>
+                      <a:prstDash val="solid"/>
+                      <a:round/>
+                      <a:headEnd type="none" w="med" len="med"/>
+                      <a:tailEnd type="none" w="med" len="med"/>
+                    </a:lnT>
+                    <a:lnB w="6350" cap="flat" cmpd="sng" algn="ctr">
+                      <a:solidFill>
+                        <a:srgbClr val="E0E0E0"/>
+                      </a:solidFill>
+                      <a:prstDash val="solid"/>
+                      <a:round/>
+                      <a:headEnd type="none" w="med" len="med"/>
+                      <a:tailEnd type="none" w="med" len="med"/>
+                    </a:lnB>
+                  </a:tcPr>
+                </a:tc>
+              </a:tr>
+              <a:tr h="329184">
+                <a:tc>
+                  <a:txBody>
+                    <a:bodyPr/>
+                    <a:lstStyle/>
+                    <a:p>
+                      <a:pPr indent="0" marL="0">
+                        <a:buNone/>
+                      </a:pPr>
+                      <a:r>
+                        <a:rPr lang="en-US" sz="1050" dirty="0">
+                          <a:solidFill>
+                            <a:srgbClr val="10332F"/>
+                          </a:solidFill>
+                          <a:latin typeface="Calibri" pitchFamily="34" charset="0"/>
+                          <a:ea typeface="Calibri" pitchFamily="34" charset="-122"/>
+                          <a:cs typeface="Calibri" pitchFamily="34" charset="-120"/>
+                        </a:rPr>
+                        <a:t>Calvin Klein</a:t>
+                      </a:r>
+                      <a:endParaRPr lang="en-US" sz="1050" dirty="0">
+                        <a:latin typeface="Calibri" charset="0"/>
+                        <a:ea typeface="Calibri" charset="0"/>
+                        <a:cs typeface="Calibri" charset="0"/>
+                      </a:endParaRPr>
+                    </a:p>
+                  </a:txBody>
+                  <a:tcPr marL="91440" marR="91440" marT="45720" marB="45720" anchor="ctr">
+                    <a:lnL w="6350" cap="flat" cmpd="sng" algn="ctr">
+                      <a:solidFill>
+                        <a:srgbClr val="E0E0E0"/>
+                      </a:solidFill>
+                      <a:prstDash val="solid"/>
+                      <a:round/>
+                      <a:headEnd type="none" w="med" len="med"/>
+                      <a:tailEnd type="none" w="med" len="med"/>
+                    </a:lnL>
+                    <a:lnR w="6350" cap="flat" cmpd="sng" algn="ctr">
+                      <a:solidFill>
+                        <a:srgbClr val="E0E0E0"/>
+                      </a:solidFill>
+                      <a:prstDash val="solid"/>
+                      <a:round/>
+                      <a:headEnd type="none" w="med" len="med"/>
+                      <a:tailEnd type="none" w="med" len="med"/>
+                    </a:lnR>
+                    <a:lnT w="6350" cap="flat" cmpd="sng" algn="ctr">
+                      <a:solidFill>
+                        <a:srgbClr val="E0E0E0"/>
+                      </a:solidFill>
+                      <a:prstDash val="solid"/>
+                      <a:round/>
+                      <a:headEnd type="none" w="med" len="med"/>
+                      <a:tailEnd type="none" w="med" len="med"/>
+                    </a:lnT>
+                    <a:lnB w="6350" cap="flat" cmpd="sng" algn="ctr">
+                      <a:solidFill>
+                        <a:srgbClr val="E0E0E0"/>
+                      </a:solidFill>
+                      <a:prstDash val="solid"/>
+                      <a:round/>
+                      <a:headEnd type="none" w="med" len="med"/>
+                      <a:tailEnd type="none" w="med" len="med"/>
+                    </a:lnB>
+                  </a:tcPr>
+                </a:tc>
+                <a:tc>
+                  <a:txBody>
+                    <a:bodyPr/>
+                    <a:lstStyle/>
+                    <a:p>
+                      <a:pPr algn="r" indent="0" marL="0">
+                        <a:buNone/>
+                      </a:pPr>
+                      <a:r>
+                        <a:rPr lang="en-US" sz="1050" dirty="0">
+                          <a:solidFill>
+                            <a:srgbClr val="10332F"/>
+                          </a:solidFill>
+                          <a:latin typeface="Calibri" pitchFamily="34" charset="0"/>
+                          <a:ea typeface="Calibri" pitchFamily="34" charset="-122"/>
+                          <a:cs typeface="Calibri" pitchFamily="34" charset="-120"/>
+                        </a:rPr>
+                        <a:t>588</a:t>
+                      </a:r>
+                      <a:endParaRPr lang="en-US" sz="1050" dirty="0">
+                        <a:latin typeface="Calibri" charset="0"/>
+                        <a:ea typeface="Calibri" charset="0"/>
+                        <a:cs typeface="Calibri" charset="0"/>
+                      </a:endParaRPr>
+                    </a:p>
+                  </a:txBody>
+                  <a:tcPr marL="91440" marR="91440" marT="45720" marB="45720" anchor="ctr">
+                    <a:lnL w="6350" cap="flat" cmpd="sng" algn="ctr">
+                      <a:solidFill>
+                        <a:srgbClr val="E0E0E0"/>
+                      </a:solidFill>
+                      <a:prstDash val="solid"/>
+                      <a:round/>
+                      <a:headEnd type="none" w="med" len="med"/>
+                      <a:tailEnd type="none" w="med" len="med"/>
+                    </a:lnL>
+                    <a:lnR w="6350" cap="flat" cmpd="sng" algn="ctr">
+                      <a:solidFill>
+                        <a:srgbClr val="E0E0E0"/>
+                      </a:solidFill>
+                      <a:prstDash val="solid"/>
+                      <a:round/>
+                      <a:headEnd type="none" w="med" len="med"/>
+                      <a:tailEnd type="none" w="med" len="med"/>
+                    </a:lnR>
+                    <a:lnT w="6350" cap="flat" cmpd="sng" algn="ctr">
+                      <a:solidFill>
+                        <a:srgbClr val="E0E0E0"/>
+                      </a:solidFill>
+                      <a:prstDash val="solid"/>
+                      <a:round/>
+                      <a:headEnd type="none" w="med" len="med"/>
+                      <a:tailEnd type="none" w="med" len="med"/>
+                    </a:lnT>
+                    <a:lnB w="6350" cap="flat" cmpd="sng" algn="ctr">
+                      <a:solidFill>
+                        <a:srgbClr val="E0E0E0"/>
+                      </a:solidFill>
+                      <a:prstDash val="solid"/>
+                      <a:round/>
+                      <a:headEnd type="none" w="med" len="med"/>
+                      <a:tailEnd type="none" w="med" len="med"/>
+                    </a:lnB>
+                  </a:tcPr>
+                </a:tc>
+                <a:tc>
+                  <a:txBody>
+                    <a:bodyPr/>
+                    <a:lstStyle/>
+                    <a:p>
+                      <a:pPr algn="r" indent="0" marL="0">
+                        <a:buNone/>
+                      </a:pPr>
+                      <a:r>
+                        <a:rPr lang="en-US" sz="1050" dirty="0">
+                          <a:solidFill>
+                            <a:srgbClr val="10332F"/>
+                          </a:solidFill>
+                          <a:latin typeface="Calibri" pitchFamily="34" charset="0"/>
+                          <a:ea typeface="Calibri" pitchFamily="34" charset="-122"/>
+                          <a:cs typeface="Calibri" pitchFamily="34" charset="-120"/>
+                        </a:rPr>
+                        <a:t>₺19,7K</a:t>
+                      </a:r>
+                      <a:endParaRPr lang="en-US" sz="1050" dirty="0">
+                        <a:latin typeface="Calibri" charset="0"/>
+                        <a:ea typeface="Calibri" charset="0"/>
+                        <a:cs typeface="Calibri" charset="0"/>
+                      </a:endParaRPr>
+                    </a:p>
+                  </a:txBody>
+                  <a:tcPr marL="91440" marR="91440" marT="45720" marB="45720" anchor="ctr">
+                    <a:lnL w="6350" cap="flat" cmpd="sng" algn="ctr">
+                      <a:solidFill>
+                        <a:srgbClr val="E0E0E0"/>
+                      </a:solidFill>
+                      <a:prstDash val="solid"/>
+                      <a:round/>
+                      <a:headEnd type="none" w="med" len="med"/>
+                      <a:tailEnd type="none" w="med" len="med"/>
+                    </a:lnL>
+                    <a:lnR w="6350" cap="flat" cmpd="sng" algn="ctr">
+                      <a:solidFill>
+                        <a:srgbClr val="E0E0E0"/>
+                      </a:solidFill>
+                      <a:prstDash val="solid"/>
+                      <a:round/>
+                      <a:headEnd type="none" w="med" len="med"/>
+                      <a:tailEnd type="none" w="med" len="med"/>
+                    </a:lnR>
+                    <a:lnT w="6350" cap="flat" cmpd="sng" algn="ctr">
+                      <a:solidFill>
+                        <a:srgbClr val="E0E0E0"/>
+                      </a:solidFill>
+                      <a:prstDash val="solid"/>
+                      <a:round/>
+                      <a:headEnd type="none" w="med" len="med"/>
+                      <a:tailEnd type="none" w="med" len="med"/>
+                    </a:lnT>
+                    <a:lnB w="6350" cap="flat" cmpd="sng" algn="ctr">
+                      <a:solidFill>
+                        <a:srgbClr val="E0E0E0"/>
+                      </a:solidFill>
+                      <a:prstDash val="solid"/>
+                      <a:round/>
+                      <a:headEnd type="none" w="med" len="med"/>
+                      <a:tailEnd type="none" w="med" len="med"/>
+                    </a:lnB>
+                  </a:tcPr>
+                </a:tc>
+                <a:tc>
+                  <a:txBody>
+                    <a:bodyPr/>
+                    <a:lstStyle/>
+                    <a:p>
+                      <a:pPr algn="r" indent="0" marL="0">
+                        <a:buNone/>
+                      </a:pPr>
+                      <a:r>
+                        <a:rPr lang="en-US" sz="1050" dirty="0">
+                          <a:solidFill>
+                            <a:srgbClr val="10332F"/>
+                          </a:solidFill>
+                          <a:latin typeface="Calibri" pitchFamily="34" charset="0"/>
+                          <a:ea typeface="Calibri" pitchFamily="34" charset="-122"/>
+                          <a:cs typeface="Calibri" pitchFamily="34" charset="-120"/>
+                        </a:rPr>
+                        <a:t>4</a:t>
+                      </a:r>
+                      <a:endParaRPr lang="en-US" sz="1050" dirty="0">
+                        <a:latin typeface="Calibri" charset="0"/>
+                        <a:ea typeface="Calibri" charset="0"/>
+                        <a:cs typeface="Calibri" charset="0"/>
+                      </a:endParaRPr>
+                    </a:p>
+                  </a:txBody>
+                  <a:tcPr marL="91440" marR="91440" marT="45720" marB="45720" anchor="ctr">
+                    <a:lnL w="6350" cap="flat" cmpd="sng" algn="ctr">
+                      <a:solidFill>
+                        <a:srgbClr val="E0E0E0"/>
+                      </a:solidFill>
+                      <a:prstDash val="solid"/>
+                      <a:round/>
+                      <a:headEnd type="none" w="med" len="med"/>
+                      <a:tailEnd type="none" w="med" len="med"/>
+                    </a:lnL>
+                    <a:lnR w="6350" cap="flat" cmpd="sng" algn="ctr">
+                      <a:solidFill>
+                        <a:srgbClr val="E0E0E0"/>
+                      </a:solidFill>
+                      <a:prstDash val="solid"/>
+                      <a:round/>
+                      <a:headEnd type="none" w="med" len="med"/>
+                      <a:tailEnd type="none" w="med" len="med"/>
+                    </a:lnR>
+                    <a:lnT w="6350" cap="flat" cmpd="sng" algn="ctr">
+                      <a:solidFill>
+                        <a:srgbClr val="E0E0E0"/>
+                      </a:solidFill>
+                      <a:prstDash val="solid"/>
+                      <a:round/>
+                      <a:headEnd type="none" w="med" len="med"/>
+                      <a:tailEnd type="none" w="med" len="med"/>
+                    </a:lnT>
+                    <a:lnB w="6350" cap="flat" cmpd="sng" algn="ctr">
+                      <a:solidFill>
+                        <a:srgbClr val="E0E0E0"/>
+                      </a:solidFill>
+                      <a:prstDash val="solid"/>
+                      <a:round/>
+                      <a:headEnd type="none" w="med" len="med"/>
+                      <a:tailEnd type="none" w="med" len="med"/>
+                    </a:lnB>
+                  </a:tcPr>
+                </a:tc>
+              </a:tr>
+              <a:tr h="329184">
+                <a:tc>
+                  <a:txBody>
+                    <a:bodyPr/>
+                    <a:lstStyle/>
+                    <a:p>
+                      <a:pPr indent="0" marL="0">
+                        <a:buNone/>
+                      </a:pPr>
+                      <a:r>
+                        <a:rPr lang="en-US" sz="1050" dirty="0">
+                          <a:solidFill>
+                            <a:srgbClr val="10332F"/>
+                          </a:solidFill>
+                          <a:latin typeface="Calibri" pitchFamily="34" charset="0"/>
+                          <a:ea typeface="Calibri" pitchFamily="34" charset="-122"/>
+                          <a:cs typeface="Calibri" pitchFamily="34" charset="-120"/>
+                        </a:rPr>
+                        <a:t>Guess</a:t>
+                      </a:r>
+                      <a:endParaRPr lang="en-US" sz="1050" dirty="0">
+                        <a:latin typeface="Calibri" charset="0"/>
+                        <a:ea typeface="Calibri" charset="0"/>
+                        <a:cs typeface="Calibri" charset="0"/>
+                      </a:endParaRPr>
+                    </a:p>
+                  </a:txBody>
+                  <a:tcPr marL="91440" marR="91440" marT="45720" marB="45720" anchor="ctr">
+                    <a:lnL w="6350" cap="flat" cmpd="sng" algn="ctr">
+                      <a:solidFill>
+                        <a:srgbClr val="E0E0E0"/>
+                      </a:solidFill>
+                      <a:prstDash val="solid"/>
+                      <a:round/>
+                      <a:headEnd type="none" w="med" len="med"/>
+                      <a:tailEnd type="none" w="med" len="med"/>
+                    </a:lnL>
+                    <a:lnR w="6350" cap="flat" cmpd="sng" algn="ctr">
+                      <a:solidFill>
+                        <a:srgbClr val="E0E0E0"/>
+                      </a:solidFill>
+                      <a:prstDash val="solid"/>
+                      <a:round/>
+                      <a:headEnd type="none" w="med" len="med"/>
+                      <a:tailEnd type="none" w="med" len="med"/>
+                    </a:lnR>
+                    <a:lnT w="6350" cap="flat" cmpd="sng" algn="ctr">
+                      <a:solidFill>
+                        <a:srgbClr val="E0E0E0"/>
+                      </a:solidFill>
+                      <a:prstDash val="solid"/>
+                      <a:round/>
+                      <a:headEnd type="none" w="med" len="med"/>
+                      <a:tailEnd type="none" w="med" len="med"/>
+                    </a:lnT>
+                    <a:lnB w="6350" cap="flat" cmpd="sng" algn="ctr">
+                      <a:solidFill>
+                        <a:srgbClr val="E0E0E0"/>
+                      </a:solidFill>
+                      <a:prstDash val="solid"/>
+                      <a:round/>
+                      <a:headEnd type="none" w="med" len="med"/>
+                      <a:tailEnd type="none" w="med" len="med"/>
+                    </a:lnB>
+                  </a:tcPr>
+                </a:tc>
+                <a:tc>
+                  <a:txBody>
+                    <a:bodyPr/>
+                    <a:lstStyle/>
+                    <a:p>
+                      <a:pPr algn="r" indent="0" marL="0">
+                        <a:buNone/>
+                      </a:pPr>
+                      <a:r>
+                        <a:rPr lang="en-US" sz="1050" dirty="0">
+                          <a:solidFill>
+                            <a:srgbClr val="10332F"/>
+                          </a:solidFill>
+                          <a:latin typeface="Calibri" pitchFamily="34" charset="0"/>
+                          <a:ea typeface="Calibri" pitchFamily="34" charset="-122"/>
+                          <a:cs typeface="Calibri" pitchFamily="34" charset="-120"/>
+                        </a:rPr>
+                        <a:t>542</a:t>
+                      </a:r>
+                      <a:endParaRPr lang="en-US" sz="1050" dirty="0">
+                        <a:latin typeface="Calibri" charset="0"/>
+                        <a:ea typeface="Calibri" charset="0"/>
+                        <a:cs typeface="Calibri" charset="0"/>
+                      </a:endParaRPr>
+                    </a:p>
+                  </a:txBody>
+                  <a:tcPr marL="91440" marR="91440" marT="45720" marB="45720" anchor="ctr">
+                    <a:lnL w="6350" cap="flat" cmpd="sng" algn="ctr">
+                      <a:solidFill>
+                        <a:srgbClr val="E0E0E0"/>
+                      </a:solidFill>
+                      <a:prstDash val="solid"/>
+                      <a:round/>
+                      <a:headEnd type="none" w="med" len="med"/>
+                      <a:tailEnd type="none" w="med" len="med"/>
+                    </a:lnL>
+                    <a:lnR w="6350" cap="flat" cmpd="sng" algn="ctr">
+                      <a:solidFill>
+                        <a:srgbClr val="E0E0E0"/>
+                      </a:solidFill>
+                      <a:prstDash val="solid"/>
+                      <a:round/>
+                      <a:headEnd type="none" w="med" len="med"/>
+                      <a:tailEnd type="none" w="med" len="med"/>
+                    </a:lnR>
+                    <a:lnT w="6350" cap="flat" cmpd="sng" algn="ctr">
+                      <a:solidFill>
+                        <a:srgbClr val="E0E0E0"/>
+                      </a:solidFill>
+                      <a:prstDash val="solid"/>
+                      <a:round/>
+                      <a:headEnd type="none" w="med" len="med"/>
+                      <a:tailEnd type="none" w="med" len="med"/>
+                    </a:lnT>
+                    <a:lnB w="6350" cap="flat" cmpd="sng" algn="ctr">
+                      <a:solidFill>
+                        <a:srgbClr val="E0E0E0"/>
+                      </a:solidFill>
+                      <a:prstDash val="solid"/>
+                      <a:round/>
+                      <a:headEnd type="none" w="med" len="med"/>
+                      <a:tailEnd type="none" w="med" len="med"/>
+                    </a:lnB>
+                  </a:tcPr>
+                </a:tc>
+                <a:tc>
+                  <a:txBody>
+                    <a:bodyPr/>
+                    <a:lstStyle/>
+                    <a:p>
+                      <a:pPr algn="r" indent="0" marL="0">
+                        <a:buNone/>
+                      </a:pPr>
+                      <a:r>
+                        <a:rPr lang="en-US" sz="1050" dirty="0">
+                          <a:solidFill>
+                            <a:srgbClr val="10332F"/>
+                          </a:solidFill>
+                          <a:latin typeface="Calibri" pitchFamily="34" charset="0"/>
+                          <a:ea typeface="Calibri" pitchFamily="34" charset="-122"/>
+                          <a:cs typeface="Calibri" pitchFamily="34" charset="-120"/>
+                        </a:rPr>
+                        <a:t>₺6,8K</a:t>
+                      </a:r>
+                      <a:endParaRPr lang="en-US" sz="1050" dirty="0">
+                        <a:latin typeface="Calibri" charset="0"/>
+                        <a:ea typeface="Calibri" charset="0"/>
+                        <a:cs typeface="Calibri" charset="0"/>
+                      </a:endParaRPr>
+                    </a:p>
+                  </a:txBody>
+                  <a:tcPr marL="91440" marR="91440" marT="45720" marB="45720" anchor="ctr">
+                    <a:lnL w="6350" cap="flat" cmpd="sng" algn="ctr">
+                      <a:solidFill>
+                        <a:srgbClr val="E0E0E0"/>
+                      </a:solidFill>
+                      <a:prstDash val="solid"/>
+                      <a:round/>
+                      <a:headEnd type="none" w="med" len="med"/>
+                      <a:tailEnd type="none" w="med" len="med"/>
+                    </a:lnL>
+                    <a:lnR w="6350" cap="flat" cmpd="sng" algn="ctr">
+                      <a:solidFill>
+                        <a:srgbClr val="E0E0E0"/>
+                      </a:solidFill>
+                      <a:prstDash val="solid"/>
+                      <a:round/>
+                      <a:headEnd type="none" w="med" len="med"/>
+                      <a:tailEnd type="none" w="med" len="med"/>
+                    </a:lnR>
+                    <a:lnT w="6350" cap="flat" cmpd="sng" algn="ctr">
+                      <a:solidFill>
+                        <a:srgbClr val="E0E0E0"/>
+                      </a:solidFill>
+                      <a:prstDash val="solid"/>
+                      <a:round/>
+                      <a:headEnd type="none" w="med" len="med"/>
+                      <a:tailEnd type="none" w="med" len="med"/>
+                    </a:lnT>
+                    <a:lnB w="6350" cap="flat" cmpd="sng" algn="ctr">
+                      <a:solidFill>
+                        <a:srgbClr val="E0E0E0"/>
+                      </a:solidFill>
+                      <a:prstDash val="solid"/>
+                      <a:round/>
+                      <a:headEnd type="none" w="med" len="med"/>
+                      <a:tailEnd type="none" w="med" len="med"/>
+                    </a:lnB>
+                  </a:tcPr>
+                </a:tc>
+                <a:tc>
+                  <a:txBody>
+                    <a:bodyPr/>
+                    <a:lstStyle/>
+                    <a:p>
+                      <a:pPr algn="r" indent="0" marL="0">
+                        <a:buNone/>
+                      </a:pPr>
+                      <a:r>
+                        <a:rPr lang="en-US" sz="1050" dirty="0">
+                          <a:solidFill>
+                            <a:srgbClr val="10332F"/>
+                          </a:solidFill>
+                          <a:latin typeface="Calibri" pitchFamily="34" charset="0"/>
+                          <a:ea typeface="Calibri" pitchFamily="34" charset="-122"/>
+                          <a:cs typeface="Calibri" pitchFamily="34" charset="-120"/>
+                        </a:rPr>
+                        <a:t>2</a:t>
+                      </a:r>
+                      <a:endParaRPr lang="en-US" sz="1050" dirty="0">
+                        <a:latin typeface="Calibri" charset="0"/>
+                        <a:ea typeface="Calibri" charset="0"/>
+                        <a:cs typeface="Calibri" charset="0"/>
+                      </a:endParaRPr>
+                    </a:p>
+                  </a:txBody>
+                  <a:tcPr marL="91440" marR="91440" marT="45720" marB="45720" anchor="ctr">
+                    <a:lnL w="6350" cap="flat" cmpd="sng" algn="ctr">
+                      <a:solidFill>
+                        <a:srgbClr val="E0E0E0"/>
+                      </a:solidFill>
+                      <a:prstDash val="solid"/>
+                      <a:round/>
+                      <a:headEnd type="none" w="med" len="med"/>
+                      <a:tailEnd type="none" w="med" len="med"/>
+                    </a:lnL>
+                    <a:lnR w="6350" cap="flat" cmpd="sng" algn="ctr">
+                      <a:solidFill>
+                        <a:srgbClr val="E0E0E0"/>
+                      </a:solidFill>
+                      <a:prstDash val="solid"/>
+                      <a:round/>
+                      <a:headEnd type="none" w="med" len="med"/>
+                      <a:tailEnd type="none" w="med" len="med"/>
+                    </a:lnR>
+                    <a:lnT w="6350" cap="flat" cmpd="sng" algn="ctr">
+                      <a:solidFill>
+                        <a:srgbClr val="E0E0E0"/>
+                      </a:solidFill>
+                      <a:prstDash val="solid"/>
+                      <a:round/>
+                      <a:headEnd type="none" w="med" len="med"/>
+                      <a:tailEnd type="none" w="med" len="med"/>
+                    </a:lnT>
+                    <a:lnB w="6350" cap="flat" cmpd="sng" algn="ctr">
+                      <a:solidFill>
+                        <a:srgbClr val="E0E0E0"/>
+                      </a:solidFill>
+                      <a:prstDash val="solid"/>
+                      <a:round/>
+                      <a:headEnd type="none" w="med" len="med"/>
+                      <a:tailEnd type="none" w="med" len="med"/>
+                    </a:lnB>
+                  </a:tcPr>
+                </a:tc>
+              </a:tr>
+              <a:tr h="329184">
+                <a:tc>
+                  <a:txBody>
+                    <a:bodyPr/>
+                    <a:lstStyle/>
+                    <a:p>
+                      <a:pPr indent="0" marL="0">
+                        <a:buNone/>
+                      </a:pPr>
+                      <a:r>
+                        <a:rPr lang="en-US" sz="1050" dirty="0">
+                          <a:solidFill>
+                            <a:srgbClr val="10332F"/>
+                          </a:solidFill>
+                          <a:latin typeface="Calibri" pitchFamily="34" charset="0"/>
+                          <a:ea typeface="Calibri" pitchFamily="34" charset="-122"/>
+                          <a:cs typeface="Calibri" pitchFamily="34" charset="-120"/>
+                        </a:rPr>
+                        <a:t>Koton</a:t>
+                      </a:r>
+                      <a:endParaRPr lang="en-US" sz="1050" dirty="0">
+                        <a:latin typeface="Calibri" charset="0"/>
+                        <a:ea typeface="Calibri" charset="0"/>
+                        <a:cs typeface="Calibri" charset="0"/>
+                      </a:endParaRPr>
+                    </a:p>
+                  </a:txBody>
+                  <a:tcPr marL="91440" marR="91440" marT="45720" marB="45720" anchor="ctr">
+                    <a:lnL w="6350" cap="flat" cmpd="sng" algn="ctr">
+                      <a:solidFill>
+                        <a:srgbClr val="E0E0E0"/>
+                      </a:solidFill>
+                      <a:prstDash val="solid"/>
+                      <a:round/>
+                      <a:headEnd type="none" w="med" len="med"/>
+                      <a:tailEnd type="none" w="med" len="med"/>
+                    </a:lnL>
+                    <a:lnR w="6350" cap="flat" cmpd="sng" algn="ctr">
+                      <a:solidFill>
+                        <a:srgbClr val="E0E0E0"/>
+                      </a:solidFill>
+                      <a:prstDash val="solid"/>
+                      <a:round/>
+                      <a:headEnd type="none" w="med" len="med"/>
+                      <a:tailEnd type="none" w="med" len="med"/>
+                    </a:lnR>
+                    <a:lnT w="6350" cap="flat" cmpd="sng" algn="ctr">
+                      <a:solidFill>
+                        <a:srgbClr val="E0E0E0"/>
+                      </a:solidFill>
+                      <a:prstDash val="solid"/>
+                      <a:round/>
+                      <a:headEnd type="none" w="med" len="med"/>
+                      <a:tailEnd type="none" w="med" len="med"/>
+                    </a:lnT>
+                    <a:lnB w="6350" cap="flat" cmpd="sng" algn="ctr">
+                      <a:solidFill>
+                        <a:srgbClr val="E0E0E0"/>
+                      </a:solidFill>
+                      <a:prstDash val="solid"/>
+                      <a:round/>
+                      <a:headEnd type="none" w="med" len="med"/>
+                      <a:tailEnd type="none" w="med" len="med"/>
+                    </a:lnB>
+                  </a:tcPr>
+                </a:tc>
+                <a:tc>
+                  <a:txBody>
+                    <a:bodyPr/>
+                    <a:lstStyle/>
+                    <a:p>
+                      <a:pPr algn="r" indent="0" marL="0">
+                        <a:buNone/>
+                      </a:pPr>
+                      <a:r>
+                        <a:rPr lang="en-US" sz="1050" dirty="0">
+                          <a:solidFill>
+                            <a:srgbClr val="10332F"/>
+                          </a:solidFill>
+                          <a:latin typeface="Calibri" pitchFamily="34" charset="0"/>
+                          <a:ea typeface="Calibri" pitchFamily="34" charset="-122"/>
+                          <a:cs typeface="Calibri" pitchFamily="34" charset="-120"/>
+                        </a:rPr>
+                        <a:t>472</a:t>
+                      </a:r>
+                      <a:endParaRPr lang="en-US" sz="1050" dirty="0">
+                        <a:latin typeface="Calibri" charset="0"/>
+                        <a:ea typeface="Calibri" charset="0"/>
+                        <a:cs typeface="Calibri" charset="0"/>
+                      </a:endParaRPr>
+                    </a:p>
+                  </a:txBody>
+                  <a:tcPr marL="91440" marR="91440" marT="45720" marB="45720" anchor="ctr">
+                    <a:lnL w="6350" cap="flat" cmpd="sng" algn="ctr">
+                      <a:solidFill>
+                        <a:srgbClr val="E0E0E0"/>
+                      </a:solidFill>
+                      <a:prstDash val="solid"/>
+                      <a:round/>
+                      <a:headEnd type="none" w="med" len="med"/>
+                      <a:tailEnd type="none" w="med" len="med"/>
+                    </a:lnL>
+                    <a:lnR w="6350" cap="flat" cmpd="sng" algn="ctr">
+                      <a:solidFill>
+                        <a:srgbClr val="E0E0E0"/>
+                      </a:solidFill>
+                      <a:prstDash val="solid"/>
+                      <a:round/>
+                      <a:headEnd type="none" w="med" len="med"/>
+                      <a:tailEnd type="none" w="med" len="med"/>
+                    </a:lnR>
+                    <a:lnT w="6350" cap="flat" cmpd="sng" algn="ctr">
+                      <a:solidFill>
+                        <a:srgbClr val="E0E0E0"/>
+                      </a:solidFill>
+                      <a:prstDash val="solid"/>
+                      <a:round/>
+                      <a:headEnd type="none" w="med" len="med"/>
+                      <a:tailEnd type="none" w="med" len="med"/>
+                    </a:lnT>
+                    <a:lnB w="6350" cap="flat" cmpd="sng" algn="ctr">
+                      <a:solidFill>
+                        <a:srgbClr val="E0E0E0"/>
+                      </a:solidFill>
+                      <a:prstDash val="solid"/>
+                      <a:round/>
+                      <a:headEnd type="none" w="med" len="med"/>
+                      <a:tailEnd type="none" w="med" len="med"/>
+                    </a:lnB>
+                  </a:tcPr>
+                </a:tc>
+                <a:tc>
+                  <a:txBody>
+                    <a:bodyPr/>
+                    <a:lstStyle/>
+                    <a:p>
+                      <a:pPr algn="r" indent="0" marL="0">
+                        <a:buNone/>
+                      </a:pPr>
+                      <a:r>
+                        <a:rPr lang="en-US" sz="1050" dirty="0">
+                          <a:solidFill>
+                            <a:srgbClr val="10332F"/>
+                          </a:solidFill>
+                          <a:latin typeface="Calibri" pitchFamily="34" charset="0"/>
+                          <a:ea typeface="Calibri" pitchFamily="34" charset="-122"/>
+                          <a:cs typeface="Calibri" pitchFamily="34" charset="-120"/>
+                        </a:rPr>
+                        <a:t>₺4,8K</a:t>
+                      </a:r>
+                      <a:endParaRPr lang="en-US" sz="1050" dirty="0">
+                        <a:latin typeface="Calibri" charset="0"/>
+                        <a:ea typeface="Calibri" charset="0"/>
+                        <a:cs typeface="Calibri" charset="0"/>
+                      </a:endParaRPr>
+                    </a:p>
+                  </a:txBody>
+                  <a:tcPr marL="91440" marR="91440" marT="45720" marB="45720" anchor="ctr">
+                    <a:lnL w="6350" cap="flat" cmpd="sng" algn="ctr">
+                      <a:solidFill>
+                        <a:srgbClr val="E0E0E0"/>
+                      </a:solidFill>
+                      <a:prstDash val="solid"/>
+                      <a:round/>
+                      <a:headEnd type="none" w="med" len="med"/>
+                      <a:tailEnd type="none" w="med" len="med"/>
+                    </a:lnL>
+                    <a:lnR w="6350" cap="flat" cmpd="sng" algn="ctr">
+                      <a:solidFill>
+                        <a:srgbClr val="E0E0E0"/>
+                      </a:solidFill>
+                      <a:prstDash val="solid"/>
+                      <a:round/>
+                      <a:headEnd type="none" w="med" len="med"/>
+                      <a:tailEnd type="none" w="med" len="med"/>
+                    </a:lnR>
+                    <a:lnT w="6350" cap="flat" cmpd="sng" algn="ctr">
+                      <a:solidFill>
+                        <a:srgbClr val="E0E0E0"/>
+                      </a:solidFill>
+                      <a:prstDash val="solid"/>
+                      <a:round/>
+                      <a:headEnd type="none" w="med" len="med"/>
+                      <a:tailEnd type="none" w="med" len="med"/>
+                    </a:lnT>
+                    <a:lnB w="6350" cap="flat" cmpd="sng" algn="ctr">
+                      <a:solidFill>
+                        <a:srgbClr val="E0E0E0"/>
+                      </a:solidFill>
+                      <a:prstDash val="solid"/>
+                      <a:round/>
+                      <a:headEnd type="none" w="med" len="med"/>
+                      <a:tailEnd type="none" w="med" len="med"/>
+                    </a:lnB>
+                  </a:tcPr>
+                </a:tc>
+                <a:tc>
+                  <a:txBody>
+                    <a:bodyPr/>
+                    <a:lstStyle/>
+                    <a:p>
+                      <a:pPr algn="r" indent="0" marL="0">
+                        <a:buNone/>
+                      </a:pPr>
+                      <a:r>
+                        <a:rPr lang="en-US" sz="1050" dirty="0">
+                          <a:solidFill>
+                            <a:srgbClr val="10332F"/>
+                          </a:solidFill>
+                          <a:latin typeface="Calibri" pitchFamily="34" charset="0"/>
+                          <a:ea typeface="Calibri" pitchFamily="34" charset="-122"/>
+                          <a:cs typeface="Calibri" pitchFamily="34" charset="-120"/>
+                        </a:rPr>
+                        <a:t>4</a:t>
+                      </a:r>
+                      <a:endParaRPr lang="en-US" sz="1050" dirty="0">
+                        <a:latin typeface="Calibri" charset="0"/>
+                        <a:ea typeface="Calibri" charset="0"/>
+                        <a:cs typeface="Calibri" charset="0"/>
+                      </a:endParaRPr>
+                    </a:p>
+                  </a:txBody>
+                  <a:tcPr marL="91440" marR="91440" marT="45720" marB="45720" anchor="ctr">
+                    <a:lnL w="6350" cap="flat" cmpd="sng" algn="ctr">
+                      <a:solidFill>
+                        <a:srgbClr val="E0E0E0"/>
+                      </a:solidFill>
+                      <a:prstDash val="solid"/>
+                      <a:round/>
+                      <a:headEnd type="none" w="med" len="med"/>
+                      <a:tailEnd type="none" w="med" len="med"/>
+                    </a:lnL>
+                    <a:lnR w="6350" cap="flat" cmpd="sng" algn="ctr">
+                      <a:solidFill>
+                        <a:srgbClr val="E0E0E0"/>
+                      </a:solidFill>
+                      <a:prstDash val="solid"/>
+                      <a:round/>
+                      <a:headEnd type="none" w="med" len="med"/>
+                      <a:tailEnd type="none" w="med" len="med"/>
+                    </a:lnR>
+                    <a:lnT w="6350" cap="flat" cmpd="sng" algn="ctr">
+                      <a:solidFill>
+                        <a:srgbClr val="E0E0E0"/>
+                      </a:solidFill>
+                      <a:prstDash val="solid"/>
+                      <a:round/>
+                      <a:headEnd type="none" w="med" len="med"/>
+                      <a:tailEnd type="none" w="med" len="med"/>
+                    </a:lnT>
+                    <a:lnB w="6350" cap="flat" cmpd="sng" algn="ctr">
+                      <a:solidFill>
+                        <a:srgbClr val="E0E0E0"/>
+                      </a:solidFill>
+                      <a:prstDash val="solid"/>
+                      <a:round/>
+                      <a:headEnd type="none" w="med" len="med"/>
+                      <a:tailEnd type="none" w="med" len="med"/>
+                    </a:lnB>
+                  </a:tcPr>
+                </a:tc>
+              </a:tr>
+              <a:tr h="329184">
+                <a:tc>
+                  <a:txBody>
+                    <a:bodyPr/>
+                    <a:lstStyle/>
+                    <a:p>
+                      <a:pPr indent="0" marL="0">
+                        <a:buNone/>
+                      </a:pPr>
+                      <a:r>
+                        <a:rPr lang="en-US" sz="1050" dirty="0">
+                          <a:solidFill>
+                            <a:srgbClr val="10332F"/>
+                          </a:solidFill>
+                          <a:latin typeface="Calibri" pitchFamily="34" charset="0"/>
+                          <a:ea typeface="Calibri" pitchFamily="34" charset="-122"/>
+                          <a:cs typeface="Calibri" pitchFamily="34" charset="-120"/>
+                        </a:rPr>
+                        <a:t>Merrell</a:t>
+                      </a:r>
+                      <a:endParaRPr lang="en-US" sz="1050" dirty="0">
+                        <a:latin typeface="Calibri" charset="0"/>
+                        <a:ea typeface="Calibri" charset="0"/>
+                        <a:cs typeface="Calibri" charset="0"/>
+                      </a:endParaRPr>
+                    </a:p>
+                  </a:txBody>
+                  <a:tcPr marL="91440" marR="91440" marT="45720" marB="45720" anchor="ctr">
+                    <a:lnL w="6350" cap="flat" cmpd="sng" algn="ctr">
+                      <a:solidFill>
+                        <a:srgbClr val="E0E0E0"/>
+                      </a:solidFill>
+                      <a:prstDash val="solid"/>
+                      <a:round/>
+                      <a:headEnd type="none" w="med" len="med"/>
+                      <a:tailEnd type="none" w="med" len="med"/>
+                    </a:lnL>
+                    <a:lnR w="6350" cap="flat" cmpd="sng" algn="ctr">
+                      <a:solidFill>
+                        <a:srgbClr val="E0E0E0"/>
+                      </a:solidFill>
+                      <a:prstDash val="solid"/>
+                      <a:round/>
+                      <a:headEnd type="none" w="med" len="med"/>
+                      <a:tailEnd type="none" w="med" len="med"/>
+                    </a:lnR>
+                    <a:lnT w="6350" cap="flat" cmpd="sng" algn="ctr">
+                      <a:solidFill>
+                        <a:srgbClr val="E0E0E0"/>
+                      </a:solidFill>
+                      <a:prstDash val="solid"/>
+                      <a:round/>
+                      <a:headEnd type="none" w="med" len="med"/>
+                      <a:tailEnd type="none" w="med" len="med"/>
+                    </a:lnT>
+                    <a:lnB w="6350" cap="flat" cmpd="sng" algn="ctr">
+                      <a:solidFill>
+                        <a:srgbClr val="E0E0E0"/>
+                      </a:solidFill>
+                      <a:prstDash val="solid"/>
+                      <a:round/>
+                      <a:headEnd type="none" w="med" len="med"/>
+                      <a:tailEnd type="none" w="med" len="med"/>
+                    </a:lnB>
+                  </a:tcPr>
+                </a:tc>
+                <a:tc>
+                  <a:txBody>
+                    <a:bodyPr/>
+                    <a:lstStyle/>
+                    <a:p>
+                      <a:pPr algn="r" indent="0" marL="0">
+                        <a:buNone/>
+                      </a:pPr>
+                      <a:r>
+                        <a:rPr lang="en-US" sz="1050" dirty="0">
+                          <a:solidFill>
+                            <a:srgbClr val="10332F"/>
+                          </a:solidFill>
+                          <a:latin typeface="Calibri" pitchFamily="34" charset="0"/>
+                          <a:ea typeface="Calibri" pitchFamily="34" charset="-122"/>
+                          <a:cs typeface="Calibri" pitchFamily="34" charset="-120"/>
+                        </a:rPr>
+                        <a:t>454</a:t>
+                      </a:r>
+                      <a:endParaRPr lang="en-US" sz="1050" dirty="0">
+                        <a:latin typeface="Calibri" charset="0"/>
+                        <a:ea typeface="Calibri" charset="0"/>
+                        <a:cs typeface="Calibri" charset="0"/>
+                      </a:endParaRPr>
+                    </a:p>
+                  </a:txBody>
+                  <a:tcPr marL="91440" marR="91440" marT="45720" marB="45720" anchor="ctr">
+                    <a:lnL w="6350" cap="flat" cmpd="sng" algn="ctr">
+                      <a:solidFill>
+                        <a:srgbClr val="E0E0E0"/>
+                      </a:solidFill>
+                      <a:prstDash val="solid"/>
+                      <a:round/>
+                      <a:headEnd type="none" w="med" len="med"/>
+                      <a:tailEnd type="none" w="med" len="med"/>
+                    </a:lnL>
+                    <a:lnR w="6350" cap="flat" cmpd="sng" algn="ctr">
+                      <a:solidFill>
+                        <a:srgbClr val="E0E0E0"/>
+                      </a:solidFill>
+                      <a:prstDash val="solid"/>
+                      <a:round/>
+                      <a:headEnd type="none" w="med" len="med"/>
+                      <a:tailEnd type="none" w="med" len="med"/>
+                    </a:lnR>
+                    <a:lnT w="6350" cap="flat" cmpd="sng" algn="ctr">
+                      <a:solidFill>
+                        <a:srgbClr val="E0E0E0"/>
+                      </a:solidFill>
+                      <a:prstDash val="solid"/>
+                      <a:round/>
+                      <a:headEnd type="none" w="med" len="med"/>
+                      <a:tailEnd type="none" w="med" len="med"/>
+                    </a:lnT>
+                    <a:lnB w="6350" cap="flat" cmpd="sng" algn="ctr">
+                      <a:solidFill>
+                        <a:srgbClr val="E0E0E0"/>
+                      </a:solidFill>
+                      <a:prstDash val="solid"/>
+                      <a:round/>
+                      <a:headEnd type="none" w="med" len="med"/>
+                      <a:tailEnd type="none" w="med" len="med"/>
+                    </a:lnB>
+                  </a:tcPr>
+                </a:tc>
+                <a:tc>
+                  <a:txBody>
+                    <a:bodyPr/>
+                    <a:lstStyle/>
+                    <a:p>
+                      <a:pPr algn="r" indent="0" marL="0">
+                        <a:buNone/>
+                      </a:pPr>
+                      <a:r>
+                        <a:rPr lang="en-US" sz="1050" dirty="0">
+                          <a:solidFill>
+                            <a:srgbClr val="10332F"/>
+                          </a:solidFill>
+                          <a:latin typeface="Calibri" pitchFamily="34" charset="0"/>
+                          <a:ea typeface="Calibri" pitchFamily="34" charset="-122"/>
+                          <a:cs typeface="Calibri" pitchFamily="34" charset="-120"/>
+                        </a:rPr>
+                        <a:t>₺22,6K</a:t>
+                      </a:r>
+                      <a:endParaRPr lang="en-US" sz="1050" dirty="0">
+                        <a:latin typeface="Calibri" charset="0"/>
+                        <a:ea typeface="Calibri" charset="0"/>
+                        <a:cs typeface="Calibri" charset="0"/>
+                      </a:endParaRPr>
+                    </a:p>
+                  </a:txBody>
+                  <a:tcPr marL="91440" marR="91440" marT="45720" marB="45720" anchor="ctr">
+                    <a:lnL w="6350" cap="flat" cmpd="sng" algn="ctr">
+                      <a:solidFill>
+                        <a:srgbClr val="E0E0E0"/>
+                      </a:solidFill>
+                      <a:prstDash val="solid"/>
+                      <a:round/>
+                      <a:headEnd type="none" w="med" len="med"/>
+                      <a:tailEnd type="none" w="med" len="med"/>
+                    </a:lnL>
+                    <a:lnR w="6350" cap="flat" cmpd="sng" algn="ctr">
+                      <a:solidFill>
+                        <a:srgbClr val="E0E0E0"/>
+                      </a:solidFill>
+                      <a:prstDash val="solid"/>
+                      <a:round/>
+                      <a:headEnd type="none" w="med" len="med"/>
+                      <a:tailEnd type="none" w="med" len="med"/>
+                    </a:lnR>
+                    <a:lnT w="6350" cap="flat" cmpd="sng" algn="ctr">
+                      <a:solidFill>
+                        <a:srgbClr val="E0E0E0"/>
+                      </a:solidFill>
+                      <a:prstDash val="solid"/>
+                      <a:round/>
+                      <a:headEnd type="none" w="med" len="med"/>
+                      <a:tailEnd type="none" w="med" len="med"/>
+                    </a:lnT>
+                    <a:lnB w="6350" cap="flat" cmpd="sng" algn="ctr">
+                      <a:solidFill>
+                        <a:srgbClr val="E0E0E0"/>
+                      </a:solidFill>
+                      <a:prstDash val="solid"/>
+                      <a:round/>
+                      <a:headEnd type="none" w="med" len="med"/>
+                      <a:tailEnd type="none" w="med" len="med"/>
+                    </a:lnB>
+                  </a:tcPr>
+                </a:tc>
+                <a:tc>
+                  <a:txBody>
+                    <a:bodyPr/>
+                    <a:lstStyle/>
+                    <a:p>
+                      <a:pPr algn="r" indent="0" marL="0">
+                        <a:buNone/>
+                      </a:pPr>
+                      <a:r>
+                        <a:rPr lang="en-US" sz="1050" dirty="0">
+                          <a:solidFill>
+                            <a:srgbClr val="10332F"/>
+                          </a:solidFill>
+                          <a:latin typeface="Calibri" pitchFamily="34" charset="0"/>
+                          <a:ea typeface="Calibri" pitchFamily="34" charset="-122"/>
+                          <a:cs typeface="Calibri" pitchFamily="34" charset="-120"/>
+                        </a:rPr>
+                        <a:t>4</a:t>
+                      </a:r>
+                      <a:endParaRPr lang="en-US" sz="1050" dirty="0">
                         <a:latin typeface="Calibri" charset="0"/>
                         <a:ea typeface="Calibri" charset="0"/>
                         <a:cs typeface="Calibri" charset="0"/>

</xml_diff>

<commit_message>
sunum slayt 5: chart altına aylık metrik tablosu (AI Oturum / Ciro / Transaction)
Slayt 5 yeniden düzenlendi: bar/line chart küçültülüp altına ay-ay Oturum, Ciro ve
Transaction tablosu eklendi (teal başlık). Başlık "Aylık AI'dan gelen trafik & ciro".
deck.html + standalone + build-pptx.js + PPTX güncellendi.

Co-Authored-By: Claude Opus 4.8 <noreply@anthropic.com>
</commit_message>
<xml_diff>
--- a/sunum/Ozdilekteyim-AI-Trafik-Analizi-Sunum.pptx
+++ b/sunum/Ozdilekteyim-AI-Trafik-Analizi-Sunum.pptx
@@ -493,7 +493,7 @@
           <a:lstStyle/>
           <a:p>
             <a:pPr>
-              <a:defRPr sz="1000" b="0" i="0" u="none" strike="noStrike">
+              <a:defRPr sz="900" b="0" i="0" u="none" strike="noStrike">
                 <a:solidFill>
                   <a:srgbClr val="4A4A4A"/>
                 </a:solidFill>
@@ -14015,7 +14015,7 @@
                 <a:ea typeface="Calibri" pitchFamily="34" charset="-122"/>
                 <a:cs typeface="Calibri" pitchFamily="34" charset="-120"/>
               </a:rPr>
-              <a:t>Kasım 2025 – Haziran 2026 döneminde yapay zeka kaynaklı (ağırlıkla ChatGPT) referral trafiğinin özeti.</a:t>
+              <a:t>Kasım 2025 – Haziran 2026 döneminde yapay zeka kaynaklı (ağırlıkla ChatGPT) referral trafiğinin özeti gösterilmektedir.</a:t>
             </a:r>
             <a:endParaRPr lang="en-US" sz="1300" dirty="0"/>
           </a:p>
@@ -14821,7 +14821,7 @@
                 <a:ea typeface="Calibri" pitchFamily="34" charset="-122"/>
                 <a:cs typeface="Calibri" pitchFamily="34" charset="-120"/>
               </a:rPr>
-              <a:t>Aylık AI trafik </a:t>
+              <a:t>Aylık AI'dan gelen </a:t>
             </a:r>
             <a:pPr algn="l" indent="0" marL="0">
               <a:buNone/>
@@ -14838,7 +14838,7 @@
                 <a:ea typeface="Calibri" pitchFamily="34" charset="-122"/>
                 <a:cs typeface="Calibri" pitchFamily="34" charset="-120"/>
               </a:rPr>
-              <a:t>eğrisi</a:t>
+              <a:t>trafik &amp; ciro</a:t>
             </a:r>
             <a:endParaRPr lang="en-US" sz="3000" dirty="0"/>
           </a:p>
@@ -14851,8 +14851,8 @@
           <p:nvPr/>
         </p:nvGraphicFramePr>
         <p:xfrm>
-          <a:off x="457200" y="1554480"/>
-          <a:ext cx="11247120" cy="3291840"/>
+          <a:off x="457200" y="1417320"/>
+          <a:ext cx="11247120" cy="2331720"/>
         </p:xfrm>
         <a:graphic xmlns:a="http://schemas.openxmlformats.org/drawingml/2006/main">
           <a:graphicData uri="http://schemas.openxmlformats.org/drawingml/2006/chart">
@@ -14860,16 +14860,2417 @@
           </a:graphicData>
         </a:graphic>
       </p:graphicFrame>
+      <p:graphicFrame>
+        <p:nvGraphicFramePr>
+          <p:cNvPr id="6" name="Table 0"/>
+          <p:cNvGraphicFramePr>
+            <a:graphicFrameLocks noGrp="1"/>
+          </p:cNvGraphicFramePr>
+          <p:nvPr>
+            <p:extLst>
+              <p:ext uri="{D42A27DB-BD31-4B8C-83A1-F6EECF244321}">
+                <p14:modId xmlns:p14="http://schemas.microsoft.com/office/powerpoint/2010/main" val="1579011935"/>
+              </p:ext>
+            </p:extLst>
+          </p:nvPr>
+        </p:nvGraphicFramePr>
+        <p:xfrm>
+          <a:off x="457200" y="3977640"/>
+          <a:ext cx="11247120" cy="914400"/>
+        </p:xfrm>
+        <a:graphic>
+          <a:graphicData uri="http://schemas.openxmlformats.org/drawingml/2006/table">
+            <a:tbl>
+              <a:tblPr/>
+              <a:tblGrid>
+                <a:gridCol w="1554480"/>
+                <a:gridCol w="1211580"/>
+                <a:gridCol w="1211580"/>
+                <a:gridCol w="1211580"/>
+                <a:gridCol w="1211580"/>
+                <a:gridCol w="1211580"/>
+                <a:gridCol w="1211580"/>
+                <a:gridCol w="1211580"/>
+                <a:gridCol w="1211580"/>
+              </a:tblGrid>
+              <a:tr h="384048">
+                <a:tc>
+                  <a:txBody>
+                    <a:bodyPr/>
+                    <a:lstStyle/>
+                    <a:p>
+                      <a:pPr indent="0" marL="0">
+                        <a:buNone/>
+                      </a:pPr>
+                      <a:endParaRPr lang="en-US" sz="1100" dirty="0">
+                        <a:latin typeface="Calibri" charset="0"/>
+                        <a:ea typeface="Calibri" charset="0"/>
+                        <a:cs typeface="Calibri" charset="0"/>
+                      </a:endParaRPr>
+                    </a:p>
+                  </a:txBody>
+                  <a:tcPr marL="91440" marR="91440" marT="45720" marB="45720" anchor="ctr">
+                    <a:lnL w="6350" cap="flat" cmpd="sng" algn="ctr">
+                      <a:solidFill>
+                        <a:srgbClr val="E0E0E0"/>
+                      </a:solidFill>
+                      <a:prstDash val="solid"/>
+                      <a:round/>
+                      <a:headEnd type="none" w="med" len="med"/>
+                      <a:tailEnd type="none" w="med" len="med"/>
+                    </a:lnL>
+                    <a:lnR w="6350" cap="flat" cmpd="sng" algn="ctr">
+                      <a:solidFill>
+                        <a:srgbClr val="E0E0E0"/>
+                      </a:solidFill>
+                      <a:prstDash val="solid"/>
+                      <a:round/>
+                      <a:headEnd type="none" w="med" len="med"/>
+                      <a:tailEnd type="none" w="med" len="med"/>
+                    </a:lnR>
+                    <a:lnT w="6350" cap="flat" cmpd="sng" algn="ctr">
+                      <a:solidFill>
+                        <a:srgbClr val="E0E0E0"/>
+                      </a:solidFill>
+                      <a:prstDash val="solid"/>
+                      <a:round/>
+                      <a:headEnd type="none" w="med" len="med"/>
+                      <a:tailEnd type="none" w="med" len="med"/>
+                    </a:lnT>
+                    <a:lnB w="6350" cap="flat" cmpd="sng" algn="ctr">
+                      <a:solidFill>
+                        <a:srgbClr val="E0E0E0"/>
+                      </a:solidFill>
+                      <a:prstDash val="solid"/>
+                      <a:round/>
+                      <a:headEnd type="none" w="med" len="med"/>
+                      <a:tailEnd type="none" w="med" len="med"/>
+                    </a:lnB>
+                    <a:solidFill>
+                      <a:srgbClr val="10332F"/>
+                    </a:solidFill>
+                  </a:tcPr>
+                </a:tc>
+                <a:tc>
+                  <a:txBody>
+                    <a:bodyPr/>
+                    <a:lstStyle/>
+                    <a:p>
+                      <a:pPr algn="ctr" indent="0" marL="0">
+                        <a:buNone/>
+                      </a:pPr>
+                      <a:r>
+                        <a:rPr lang="en-US" sz="1000" b="1" dirty="0">
+                          <a:solidFill>
+                            <a:srgbClr val="FFFFFF"/>
+                          </a:solidFill>
+                          <a:latin typeface="Calibri" pitchFamily="34" charset="0"/>
+                          <a:ea typeface="Calibri" pitchFamily="34" charset="-122"/>
+                          <a:cs typeface="Calibri" pitchFamily="34" charset="-120"/>
+                        </a:rPr>
+                        <a:t>Kas 25</a:t>
+                      </a:r>
+                      <a:endParaRPr lang="en-US" sz="1000" dirty="0">
+                        <a:latin typeface="Calibri" charset="0"/>
+                        <a:ea typeface="Calibri" charset="0"/>
+                        <a:cs typeface="Calibri" charset="0"/>
+                      </a:endParaRPr>
+                    </a:p>
+                  </a:txBody>
+                  <a:tcPr marL="91440" marR="91440" marT="45720" marB="45720" anchor="ctr">
+                    <a:lnL w="6350" cap="flat" cmpd="sng" algn="ctr">
+                      <a:solidFill>
+                        <a:srgbClr val="E0E0E0"/>
+                      </a:solidFill>
+                      <a:prstDash val="solid"/>
+                      <a:round/>
+                      <a:headEnd type="none" w="med" len="med"/>
+                      <a:tailEnd type="none" w="med" len="med"/>
+                    </a:lnL>
+                    <a:lnR w="6350" cap="flat" cmpd="sng" algn="ctr">
+                      <a:solidFill>
+                        <a:srgbClr val="E0E0E0"/>
+                      </a:solidFill>
+                      <a:prstDash val="solid"/>
+                      <a:round/>
+                      <a:headEnd type="none" w="med" len="med"/>
+                      <a:tailEnd type="none" w="med" len="med"/>
+                    </a:lnR>
+                    <a:lnT w="6350" cap="flat" cmpd="sng" algn="ctr">
+                      <a:solidFill>
+                        <a:srgbClr val="E0E0E0"/>
+                      </a:solidFill>
+                      <a:prstDash val="solid"/>
+                      <a:round/>
+                      <a:headEnd type="none" w="med" len="med"/>
+                      <a:tailEnd type="none" w="med" len="med"/>
+                    </a:lnT>
+                    <a:lnB w="6350" cap="flat" cmpd="sng" algn="ctr">
+                      <a:solidFill>
+                        <a:srgbClr val="E0E0E0"/>
+                      </a:solidFill>
+                      <a:prstDash val="solid"/>
+                      <a:round/>
+                      <a:headEnd type="none" w="med" len="med"/>
+                      <a:tailEnd type="none" w="med" len="med"/>
+                    </a:lnB>
+                    <a:solidFill>
+                      <a:srgbClr val="10332F"/>
+                    </a:solidFill>
+                  </a:tcPr>
+                </a:tc>
+                <a:tc>
+                  <a:txBody>
+                    <a:bodyPr/>
+                    <a:lstStyle/>
+                    <a:p>
+                      <a:pPr algn="ctr" indent="0" marL="0">
+                        <a:buNone/>
+                      </a:pPr>
+                      <a:r>
+                        <a:rPr lang="en-US" sz="1000" b="1" dirty="0">
+                          <a:solidFill>
+                            <a:srgbClr val="FFFFFF"/>
+                          </a:solidFill>
+                          <a:latin typeface="Calibri" pitchFamily="34" charset="0"/>
+                          <a:ea typeface="Calibri" pitchFamily="34" charset="-122"/>
+                          <a:cs typeface="Calibri" pitchFamily="34" charset="-120"/>
+                        </a:rPr>
+                        <a:t>Ara 25</a:t>
+                      </a:r>
+                      <a:endParaRPr lang="en-US" sz="1000" dirty="0">
+                        <a:latin typeface="Calibri" charset="0"/>
+                        <a:ea typeface="Calibri" charset="0"/>
+                        <a:cs typeface="Calibri" charset="0"/>
+                      </a:endParaRPr>
+                    </a:p>
+                  </a:txBody>
+                  <a:tcPr marL="91440" marR="91440" marT="45720" marB="45720" anchor="ctr">
+                    <a:lnL w="6350" cap="flat" cmpd="sng" algn="ctr">
+                      <a:solidFill>
+                        <a:srgbClr val="E0E0E0"/>
+                      </a:solidFill>
+                      <a:prstDash val="solid"/>
+                      <a:round/>
+                      <a:headEnd type="none" w="med" len="med"/>
+                      <a:tailEnd type="none" w="med" len="med"/>
+                    </a:lnL>
+                    <a:lnR w="6350" cap="flat" cmpd="sng" algn="ctr">
+                      <a:solidFill>
+                        <a:srgbClr val="E0E0E0"/>
+                      </a:solidFill>
+                      <a:prstDash val="solid"/>
+                      <a:round/>
+                      <a:headEnd type="none" w="med" len="med"/>
+                      <a:tailEnd type="none" w="med" len="med"/>
+                    </a:lnR>
+                    <a:lnT w="6350" cap="flat" cmpd="sng" algn="ctr">
+                      <a:solidFill>
+                        <a:srgbClr val="E0E0E0"/>
+                      </a:solidFill>
+                      <a:prstDash val="solid"/>
+                      <a:round/>
+                      <a:headEnd type="none" w="med" len="med"/>
+                      <a:tailEnd type="none" w="med" len="med"/>
+                    </a:lnT>
+                    <a:lnB w="6350" cap="flat" cmpd="sng" algn="ctr">
+                      <a:solidFill>
+                        <a:srgbClr val="E0E0E0"/>
+                      </a:solidFill>
+                      <a:prstDash val="solid"/>
+                      <a:round/>
+                      <a:headEnd type="none" w="med" len="med"/>
+                      <a:tailEnd type="none" w="med" len="med"/>
+                    </a:lnB>
+                    <a:solidFill>
+                      <a:srgbClr val="10332F"/>
+                    </a:solidFill>
+                  </a:tcPr>
+                </a:tc>
+                <a:tc>
+                  <a:txBody>
+                    <a:bodyPr/>
+                    <a:lstStyle/>
+                    <a:p>
+                      <a:pPr algn="ctr" indent="0" marL="0">
+                        <a:buNone/>
+                      </a:pPr>
+                      <a:r>
+                        <a:rPr lang="en-US" sz="1000" b="1" dirty="0">
+                          <a:solidFill>
+                            <a:srgbClr val="FFFFFF"/>
+                          </a:solidFill>
+                          <a:latin typeface="Calibri" pitchFamily="34" charset="0"/>
+                          <a:ea typeface="Calibri" pitchFamily="34" charset="-122"/>
+                          <a:cs typeface="Calibri" pitchFamily="34" charset="-120"/>
+                        </a:rPr>
+                        <a:t>Oca 26</a:t>
+                      </a:r>
+                      <a:endParaRPr lang="en-US" sz="1000" dirty="0">
+                        <a:latin typeface="Calibri" charset="0"/>
+                        <a:ea typeface="Calibri" charset="0"/>
+                        <a:cs typeface="Calibri" charset="0"/>
+                      </a:endParaRPr>
+                    </a:p>
+                  </a:txBody>
+                  <a:tcPr marL="91440" marR="91440" marT="45720" marB="45720" anchor="ctr">
+                    <a:lnL w="6350" cap="flat" cmpd="sng" algn="ctr">
+                      <a:solidFill>
+                        <a:srgbClr val="E0E0E0"/>
+                      </a:solidFill>
+                      <a:prstDash val="solid"/>
+                      <a:round/>
+                      <a:headEnd type="none" w="med" len="med"/>
+                      <a:tailEnd type="none" w="med" len="med"/>
+                    </a:lnL>
+                    <a:lnR w="6350" cap="flat" cmpd="sng" algn="ctr">
+                      <a:solidFill>
+                        <a:srgbClr val="E0E0E0"/>
+                      </a:solidFill>
+                      <a:prstDash val="solid"/>
+                      <a:round/>
+                      <a:headEnd type="none" w="med" len="med"/>
+                      <a:tailEnd type="none" w="med" len="med"/>
+                    </a:lnR>
+                    <a:lnT w="6350" cap="flat" cmpd="sng" algn="ctr">
+                      <a:solidFill>
+                        <a:srgbClr val="E0E0E0"/>
+                      </a:solidFill>
+                      <a:prstDash val="solid"/>
+                      <a:round/>
+                      <a:headEnd type="none" w="med" len="med"/>
+                      <a:tailEnd type="none" w="med" len="med"/>
+                    </a:lnT>
+                    <a:lnB w="6350" cap="flat" cmpd="sng" algn="ctr">
+                      <a:solidFill>
+                        <a:srgbClr val="E0E0E0"/>
+                      </a:solidFill>
+                      <a:prstDash val="solid"/>
+                      <a:round/>
+                      <a:headEnd type="none" w="med" len="med"/>
+                      <a:tailEnd type="none" w="med" len="med"/>
+                    </a:lnB>
+                    <a:solidFill>
+                      <a:srgbClr val="10332F"/>
+                    </a:solidFill>
+                  </a:tcPr>
+                </a:tc>
+                <a:tc>
+                  <a:txBody>
+                    <a:bodyPr/>
+                    <a:lstStyle/>
+                    <a:p>
+                      <a:pPr algn="ctr" indent="0" marL="0">
+                        <a:buNone/>
+                      </a:pPr>
+                      <a:r>
+                        <a:rPr lang="en-US" sz="1000" b="1" dirty="0">
+                          <a:solidFill>
+                            <a:srgbClr val="FFFFFF"/>
+                          </a:solidFill>
+                          <a:latin typeface="Calibri" pitchFamily="34" charset="0"/>
+                          <a:ea typeface="Calibri" pitchFamily="34" charset="-122"/>
+                          <a:cs typeface="Calibri" pitchFamily="34" charset="-120"/>
+                        </a:rPr>
+                        <a:t>Şub 26</a:t>
+                      </a:r>
+                      <a:endParaRPr lang="en-US" sz="1000" dirty="0">
+                        <a:latin typeface="Calibri" charset="0"/>
+                        <a:ea typeface="Calibri" charset="0"/>
+                        <a:cs typeface="Calibri" charset="0"/>
+                      </a:endParaRPr>
+                    </a:p>
+                  </a:txBody>
+                  <a:tcPr marL="91440" marR="91440" marT="45720" marB="45720" anchor="ctr">
+                    <a:lnL w="6350" cap="flat" cmpd="sng" algn="ctr">
+                      <a:solidFill>
+                        <a:srgbClr val="E0E0E0"/>
+                      </a:solidFill>
+                      <a:prstDash val="solid"/>
+                      <a:round/>
+                      <a:headEnd type="none" w="med" len="med"/>
+                      <a:tailEnd type="none" w="med" len="med"/>
+                    </a:lnL>
+                    <a:lnR w="6350" cap="flat" cmpd="sng" algn="ctr">
+                      <a:solidFill>
+                        <a:srgbClr val="E0E0E0"/>
+                      </a:solidFill>
+                      <a:prstDash val="solid"/>
+                      <a:round/>
+                      <a:headEnd type="none" w="med" len="med"/>
+                      <a:tailEnd type="none" w="med" len="med"/>
+                    </a:lnR>
+                    <a:lnT w="6350" cap="flat" cmpd="sng" algn="ctr">
+                      <a:solidFill>
+                        <a:srgbClr val="E0E0E0"/>
+                      </a:solidFill>
+                      <a:prstDash val="solid"/>
+                      <a:round/>
+                      <a:headEnd type="none" w="med" len="med"/>
+                      <a:tailEnd type="none" w="med" len="med"/>
+                    </a:lnT>
+                    <a:lnB w="6350" cap="flat" cmpd="sng" algn="ctr">
+                      <a:solidFill>
+                        <a:srgbClr val="E0E0E0"/>
+                      </a:solidFill>
+                      <a:prstDash val="solid"/>
+                      <a:round/>
+                      <a:headEnd type="none" w="med" len="med"/>
+                      <a:tailEnd type="none" w="med" len="med"/>
+                    </a:lnB>
+                    <a:solidFill>
+                      <a:srgbClr val="10332F"/>
+                    </a:solidFill>
+                  </a:tcPr>
+                </a:tc>
+                <a:tc>
+                  <a:txBody>
+                    <a:bodyPr/>
+                    <a:lstStyle/>
+                    <a:p>
+                      <a:pPr algn="ctr" indent="0" marL="0">
+                        <a:buNone/>
+                      </a:pPr>
+                      <a:r>
+                        <a:rPr lang="en-US" sz="1000" b="1" dirty="0">
+                          <a:solidFill>
+                            <a:srgbClr val="FFFFFF"/>
+                          </a:solidFill>
+                          <a:latin typeface="Calibri" pitchFamily="34" charset="0"/>
+                          <a:ea typeface="Calibri" pitchFamily="34" charset="-122"/>
+                          <a:cs typeface="Calibri" pitchFamily="34" charset="-120"/>
+                        </a:rPr>
+                        <a:t>Mar 26</a:t>
+                      </a:r>
+                      <a:endParaRPr lang="en-US" sz="1000" dirty="0">
+                        <a:latin typeface="Calibri" charset="0"/>
+                        <a:ea typeface="Calibri" charset="0"/>
+                        <a:cs typeface="Calibri" charset="0"/>
+                      </a:endParaRPr>
+                    </a:p>
+                  </a:txBody>
+                  <a:tcPr marL="91440" marR="91440" marT="45720" marB="45720" anchor="ctr">
+                    <a:lnL w="6350" cap="flat" cmpd="sng" algn="ctr">
+                      <a:solidFill>
+                        <a:srgbClr val="E0E0E0"/>
+                      </a:solidFill>
+                      <a:prstDash val="solid"/>
+                      <a:round/>
+                      <a:headEnd type="none" w="med" len="med"/>
+                      <a:tailEnd type="none" w="med" len="med"/>
+                    </a:lnL>
+                    <a:lnR w="6350" cap="flat" cmpd="sng" algn="ctr">
+                      <a:solidFill>
+                        <a:srgbClr val="E0E0E0"/>
+                      </a:solidFill>
+                      <a:prstDash val="solid"/>
+                      <a:round/>
+                      <a:headEnd type="none" w="med" len="med"/>
+                      <a:tailEnd type="none" w="med" len="med"/>
+                    </a:lnR>
+                    <a:lnT w="6350" cap="flat" cmpd="sng" algn="ctr">
+                      <a:solidFill>
+                        <a:srgbClr val="E0E0E0"/>
+                      </a:solidFill>
+                      <a:prstDash val="solid"/>
+                      <a:round/>
+                      <a:headEnd type="none" w="med" len="med"/>
+                      <a:tailEnd type="none" w="med" len="med"/>
+                    </a:lnT>
+                    <a:lnB w="6350" cap="flat" cmpd="sng" algn="ctr">
+                      <a:solidFill>
+                        <a:srgbClr val="E0E0E0"/>
+                      </a:solidFill>
+                      <a:prstDash val="solid"/>
+                      <a:round/>
+                      <a:headEnd type="none" w="med" len="med"/>
+                      <a:tailEnd type="none" w="med" len="med"/>
+                    </a:lnB>
+                    <a:solidFill>
+                      <a:srgbClr val="10332F"/>
+                    </a:solidFill>
+                  </a:tcPr>
+                </a:tc>
+                <a:tc>
+                  <a:txBody>
+                    <a:bodyPr/>
+                    <a:lstStyle/>
+                    <a:p>
+                      <a:pPr algn="ctr" indent="0" marL="0">
+                        <a:buNone/>
+                      </a:pPr>
+                      <a:r>
+                        <a:rPr lang="en-US" sz="1000" b="1" dirty="0">
+                          <a:solidFill>
+                            <a:srgbClr val="FFFFFF"/>
+                          </a:solidFill>
+                          <a:latin typeface="Calibri" pitchFamily="34" charset="0"/>
+                          <a:ea typeface="Calibri" pitchFamily="34" charset="-122"/>
+                          <a:cs typeface="Calibri" pitchFamily="34" charset="-120"/>
+                        </a:rPr>
+                        <a:t>Nis 26</a:t>
+                      </a:r>
+                      <a:endParaRPr lang="en-US" sz="1000" dirty="0">
+                        <a:latin typeface="Calibri" charset="0"/>
+                        <a:ea typeface="Calibri" charset="0"/>
+                        <a:cs typeface="Calibri" charset="0"/>
+                      </a:endParaRPr>
+                    </a:p>
+                  </a:txBody>
+                  <a:tcPr marL="91440" marR="91440" marT="45720" marB="45720" anchor="ctr">
+                    <a:lnL w="6350" cap="flat" cmpd="sng" algn="ctr">
+                      <a:solidFill>
+                        <a:srgbClr val="E0E0E0"/>
+                      </a:solidFill>
+                      <a:prstDash val="solid"/>
+                      <a:round/>
+                      <a:headEnd type="none" w="med" len="med"/>
+                      <a:tailEnd type="none" w="med" len="med"/>
+                    </a:lnL>
+                    <a:lnR w="6350" cap="flat" cmpd="sng" algn="ctr">
+                      <a:solidFill>
+                        <a:srgbClr val="E0E0E0"/>
+                      </a:solidFill>
+                      <a:prstDash val="solid"/>
+                      <a:round/>
+                      <a:headEnd type="none" w="med" len="med"/>
+                      <a:tailEnd type="none" w="med" len="med"/>
+                    </a:lnR>
+                    <a:lnT w="6350" cap="flat" cmpd="sng" algn="ctr">
+                      <a:solidFill>
+                        <a:srgbClr val="E0E0E0"/>
+                      </a:solidFill>
+                      <a:prstDash val="solid"/>
+                      <a:round/>
+                      <a:headEnd type="none" w="med" len="med"/>
+                      <a:tailEnd type="none" w="med" len="med"/>
+                    </a:lnT>
+                    <a:lnB w="6350" cap="flat" cmpd="sng" algn="ctr">
+                      <a:solidFill>
+                        <a:srgbClr val="E0E0E0"/>
+                      </a:solidFill>
+                      <a:prstDash val="solid"/>
+                      <a:round/>
+                      <a:headEnd type="none" w="med" len="med"/>
+                      <a:tailEnd type="none" w="med" len="med"/>
+                    </a:lnB>
+                    <a:solidFill>
+                      <a:srgbClr val="10332F"/>
+                    </a:solidFill>
+                  </a:tcPr>
+                </a:tc>
+                <a:tc>
+                  <a:txBody>
+                    <a:bodyPr/>
+                    <a:lstStyle/>
+                    <a:p>
+                      <a:pPr algn="ctr" indent="0" marL="0">
+                        <a:buNone/>
+                      </a:pPr>
+                      <a:r>
+                        <a:rPr lang="en-US" sz="1000" b="1" dirty="0">
+                          <a:solidFill>
+                            <a:srgbClr val="FFFFFF"/>
+                          </a:solidFill>
+                          <a:latin typeface="Calibri" pitchFamily="34" charset="0"/>
+                          <a:ea typeface="Calibri" pitchFamily="34" charset="-122"/>
+                          <a:cs typeface="Calibri" pitchFamily="34" charset="-120"/>
+                        </a:rPr>
+                        <a:t>May 26</a:t>
+                      </a:r>
+                      <a:endParaRPr lang="en-US" sz="1000" dirty="0">
+                        <a:latin typeface="Calibri" charset="0"/>
+                        <a:ea typeface="Calibri" charset="0"/>
+                        <a:cs typeface="Calibri" charset="0"/>
+                      </a:endParaRPr>
+                    </a:p>
+                  </a:txBody>
+                  <a:tcPr marL="91440" marR="91440" marT="45720" marB="45720" anchor="ctr">
+                    <a:lnL w="6350" cap="flat" cmpd="sng" algn="ctr">
+                      <a:solidFill>
+                        <a:srgbClr val="E0E0E0"/>
+                      </a:solidFill>
+                      <a:prstDash val="solid"/>
+                      <a:round/>
+                      <a:headEnd type="none" w="med" len="med"/>
+                      <a:tailEnd type="none" w="med" len="med"/>
+                    </a:lnL>
+                    <a:lnR w="6350" cap="flat" cmpd="sng" algn="ctr">
+                      <a:solidFill>
+                        <a:srgbClr val="E0E0E0"/>
+                      </a:solidFill>
+                      <a:prstDash val="solid"/>
+                      <a:round/>
+                      <a:headEnd type="none" w="med" len="med"/>
+                      <a:tailEnd type="none" w="med" len="med"/>
+                    </a:lnR>
+                    <a:lnT w="6350" cap="flat" cmpd="sng" algn="ctr">
+                      <a:solidFill>
+                        <a:srgbClr val="E0E0E0"/>
+                      </a:solidFill>
+                      <a:prstDash val="solid"/>
+                      <a:round/>
+                      <a:headEnd type="none" w="med" len="med"/>
+                      <a:tailEnd type="none" w="med" len="med"/>
+                    </a:lnT>
+                    <a:lnB w="6350" cap="flat" cmpd="sng" algn="ctr">
+                      <a:solidFill>
+                        <a:srgbClr val="E0E0E0"/>
+                      </a:solidFill>
+                      <a:prstDash val="solid"/>
+                      <a:round/>
+                      <a:headEnd type="none" w="med" len="med"/>
+                      <a:tailEnd type="none" w="med" len="med"/>
+                    </a:lnB>
+                    <a:solidFill>
+                      <a:srgbClr val="10332F"/>
+                    </a:solidFill>
+                  </a:tcPr>
+                </a:tc>
+                <a:tc>
+                  <a:txBody>
+                    <a:bodyPr/>
+                    <a:lstStyle/>
+                    <a:p>
+                      <a:pPr algn="ctr" indent="0" marL="0">
+                        <a:buNone/>
+                      </a:pPr>
+                      <a:r>
+                        <a:rPr lang="en-US" sz="1000" b="1" dirty="0">
+                          <a:solidFill>
+                            <a:srgbClr val="FFFFFF"/>
+                          </a:solidFill>
+                          <a:latin typeface="Calibri" pitchFamily="34" charset="0"/>
+                          <a:ea typeface="Calibri" pitchFamily="34" charset="-122"/>
+                          <a:cs typeface="Calibri" pitchFamily="34" charset="-120"/>
+                        </a:rPr>
+                        <a:t>Haz 26</a:t>
+                      </a:r>
+                      <a:endParaRPr lang="en-US" sz="1000" dirty="0">
+                        <a:latin typeface="Calibri" charset="0"/>
+                        <a:ea typeface="Calibri" charset="0"/>
+                        <a:cs typeface="Calibri" charset="0"/>
+                      </a:endParaRPr>
+                    </a:p>
+                  </a:txBody>
+                  <a:tcPr marL="91440" marR="91440" marT="45720" marB="45720" anchor="ctr">
+                    <a:lnL w="6350" cap="flat" cmpd="sng" algn="ctr">
+                      <a:solidFill>
+                        <a:srgbClr val="E0E0E0"/>
+                      </a:solidFill>
+                      <a:prstDash val="solid"/>
+                      <a:round/>
+                      <a:headEnd type="none" w="med" len="med"/>
+                      <a:tailEnd type="none" w="med" len="med"/>
+                    </a:lnL>
+                    <a:lnR w="6350" cap="flat" cmpd="sng" algn="ctr">
+                      <a:solidFill>
+                        <a:srgbClr val="E0E0E0"/>
+                      </a:solidFill>
+                      <a:prstDash val="solid"/>
+                      <a:round/>
+                      <a:headEnd type="none" w="med" len="med"/>
+                      <a:tailEnd type="none" w="med" len="med"/>
+                    </a:lnR>
+                    <a:lnT w="6350" cap="flat" cmpd="sng" algn="ctr">
+                      <a:solidFill>
+                        <a:srgbClr val="E0E0E0"/>
+                      </a:solidFill>
+                      <a:prstDash val="solid"/>
+                      <a:round/>
+                      <a:headEnd type="none" w="med" len="med"/>
+                      <a:tailEnd type="none" w="med" len="med"/>
+                    </a:lnT>
+                    <a:lnB w="6350" cap="flat" cmpd="sng" algn="ctr">
+                      <a:solidFill>
+                        <a:srgbClr val="E0E0E0"/>
+                      </a:solidFill>
+                      <a:prstDash val="solid"/>
+                      <a:round/>
+                      <a:headEnd type="none" w="med" len="med"/>
+                      <a:tailEnd type="none" w="med" len="med"/>
+                    </a:lnB>
+                    <a:solidFill>
+                      <a:srgbClr val="10332F"/>
+                    </a:solidFill>
+                  </a:tcPr>
+                </a:tc>
+              </a:tr>
+              <a:tr h="384048">
+                <a:tc>
+                  <a:txBody>
+                    <a:bodyPr/>
+                    <a:lstStyle/>
+                    <a:p>
+                      <a:pPr indent="0" marL="0">
+                        <a:buNone/>
+                      </a:pPr>
+                      <a:r>
+                        <a:rPr lang="en-US" sz="1100" b="1" dirty="0">
+                          <a:solidFill>
+                            <a:srgbClr val="E85F36"/>
+                          </a:solidFill>
+                          <a:latin typeface="Calibri" pitchFamily="34" charset="0"/>
+                          <a:ea typeface="Calibri" pitchFamily="34" charset="-122"/>
+                          <a:cs typeface="Calibri" pitchFamily="34" charset="-120"/>
+                        </a:rPr>
+                        <a:t>AI Oturum</a:t>
+                      </a:r>
+                      <a:endParaRPr lang="en-US" sz="1100" dirty="0">
+                        <a:latin typeface="Calibri" charset="0"/>
+                        <a:ea typeface="Calibri" charset="0"/>
+                        <a:cs typeface="Calibri" charset="0"/>
+                      </a:endParaRPr>
+                    </a:p>
+                  </a:txBody>
+                  <a:tcPr marL="91440" marR="91440" marT="45720" marB="45720" anchor="ctr">
+                    <a:lnL w="6350" cap="flat" cmpd="sng" algn="ctr">
+                      <a:solidFill>
+                        <a:srgbClr val="E0E0E0"/>
+                      </a:solidFill>
+                      <a:prstDash val="solid"/>
+                      <a:round/>
+                      <a:headEnd type="none" w="med" len="med"/>
+                      <a:tailEnd type="none" w="med" len="med"/>
+                    </a:lnL>
+                    <a:lnR w="6350" cap="flat" cmpd="sng" algn="ctr">
+                      <a:solidFill>
+                        <a:srgbClr val="E0E0E0"/>
+                      </a:solidFill>
+                      <a:prstDash val="solid"/>
+                      <a:round/>
+                      <a:headEnd type="none" w="med" len="med"/>
+                      <a:tailEnd type="none" w="med" len="med"/>
+                    </a:lnR>
+                    <a:lnT w="6350" cap="flat" cmpd="sng" algn="ctr">
+                      <a:solidFill>
+                        <a:srgbClr val="E0E0E0"/>
+                      </a:solidFill>
+                      <a:prstDash val="solid"/>
+                      <a:round/>
+                      <a:headEnd type="none" w="med" len="med"/>
+                      <a:tailEnd type="none" w="med" len="med"/>
+                    </a:lnT>
+                    <a:lnB w="6350" cap="flat" cmpd="sng" algn="ctr">
+                      <a:solidFill>
+                        <a:srgbClr val="E0E0E0"/>
+                      </a:solidFill>
+                      <a:prstDash val="solid"/>
+                      <a:round/>
+                      <a:headEnd type="none" w="med" len="med"/>
+                      <a:tailEnd type="none" w="med" len="med"/>
+                    </a:lnB>
+                  </a:tcPr>
+                </a:tc>
+                <a:tc>
+                  <a:txBody>
+                    <a:bodyPr/>
+                    <a:lstStyle/>
+                    <a:p>
+                      <a:pPr algn="ctr" indent="0" marL="0">
+                        <a:buNone/>
+                      </a:pPr>
+                      <a:r>
+                        <a:rPr lang="en-US" sz="1100" dirty="0">
+                          <a:solidFill>
+                            <a:srgbClr val="10332F"/>
+                          </a:solidFill>
+                          <a:latin typeface="Calibri" pitchFamily="34" charset="0"/>
+                          <a:ea typeface="Calibri" pitchFamily="34" charset="-122"/>
+                          <a:cs typeface="Calibri" pitchFamily="34" charset="-120"/>
+                        </a:rPr>
+                        <a:t>5.264</a:t>
+                      </a:r>
+                      <a:endParaRPr lang="en-US" sz="1100" dirty="0">
+                        <a:latin typeface="Calibri" charset="0"/>
+                        <a:ea typeface="Calibri" charset="0"/>
+                        <a:cs typeface="Calibri" charset="0"/>
+                      </a:endParaRPr>
+                    </a:p>
+                  </a:txBody>
+                  <a:tcPr marL="91440" marR="91440" marT="45720" marB="45720" anchor="ctr">
+                    <a:lnL w="6350" cap="flat" cmpd="sng" algn="ctr">
+                      <a:solidFill>
+                        <a:srgbClr val="E0E0E0"/>
+                      </a:solidFill>
+                      <a:prstDash val="solid"/>
+                      <a:round/>
+                      <a:headEnd type="none" w="med" len="med"/>
+                      <a:tailEnd type="none" w="med" len="med"/>
+                    </a:lnL>
+                    <a:lnR w="6350" cap="flat" cmpd="sng" algn="ctr">
+                      <a:solidFill>
+                        <a:srgbClr val="E0E0E0"/>
+                      </a:solidFill>
+                      <a:prstDash val="solid"/>
+                      <a:round/>
+                      <a:headEnd type="none" w="med" len="med"/>
+                      <a:tailEnd type="none" w="med" len="med"/>
+                    </a:lnR>
+                    <a:lnT w="6350" cap="flat" cmpd="sng" algn="ctr">
+                      <a:solidFill>
+                        <a:srgbClr val="E0E0E0"/>
+                      </a:solidFill>
+                      <a:prstDash val="solid"/>
+                      <a:round/>
+                      <a:headEnd type="none" w="med" len="med"/>
+                      <a:tailEnd type="none" w="med" len="med"/>
+                    </a:lnT>
+                    <a:lnB w="6350" cap="flat" cmpd="sng" algn="ctr">
+                      <a:solidFill>
+                        <a:srgbClr val="E0E0E0"/>
+                      </a:solidFill>
+                      <a:prstDash val="solid"/>
+                      <a:round/>
+                      <a:headEnd type="none" w="med" len="med"/>
+                      <a:tailEnd type="none" w="med" len="med"/>
+                    </a:lnB>
+                  </a:tcPr>
+                </a:tc>
+                <a:tc>
+                  <a:txBody>
+                    <a:bodyPr/>
+                    <a:lstStyle/>
+                    <a:p>
+                      <a:pPr algn="ctr" indent="0" marL="0">
+                        <a:buNone/>
+                      </a:pPr>
+                      <a:r>
+                        <a:rPr lang="en-US" sz="1100" dirty="0">
+                          <a:solidFill>
+                            <a:srgbClr val="10332F"/>
+                          </a:solidFill>
+                          <a:latin typeface="Calibri" pitchFamily="34" charset="0"/>
+                          <a:ea typeface="Calibri" pitchFamily="34" charset="-122"/>
+                          <a:cs typeface="Calibri" pitchFamily="34" charset="-120"/>
+                        </a:rPr>
+                        <a:t>4.000</a:t>
+                      </a:r>
+                      <a:endParaRPr lang="en-US" sz="1100" dirty="0">
+                        <a:latin typeface="Calibri" charset="0"/>
+                        <a:ea typeface="Calibri" charset="0"/>
+                        <a:cs typeface="Calibri" charset="0"/>
+                      </a:endParaRPr>
+                    </a:p>
+                  </a:txBody>
+                  <a:tcPr marL="91440" marR="91440" marT="45720" marB="45720" anchor="ctr">
+                    <a:lnL w="6350" cap="flat" cmpd="sng" algn="ctr">
+                      <a:solidFill>
+                        <a:srgbClr val="E0E0E0"/>
+                      </a:solidFill>
+                      <a:prstDash val="solid"/>
+                      <a:round/>
+                      <a:headEnd type="none" w="med" len="med"/>
+                      <a:tailEnd type="none" w="med" len="med"/>
+                    </a:lnL>
+                    <a:lnR w="6350" cap="flat" cmpd="sng" algn="ctr">
+                      <a:solidFill>
+                        <a:srgbClr val="E0E0E0"/>
+                      </a:solidFill>
+                      <a:prstDash val="solid"/>
+                      <a:round/>
+                      <a:headEnd type="none" w="med" len="med"/>
+                      <a:tailEnd type="none" w="med" len="med"/>
+                    </a:lnR>
+                    <a:lnT w="6350" cap="flat" cmpd="sng" algn="ctr">
+                      <a:solidFill>
+                        <a:srgbClr val="E0E0E0"/>
+                      </a:solidFill>
+                      <a:prstDash val="solid"/>
+                      <a:round/>
+                      <a:headEnd type="none" w="med" len="med"/>
+                      <a:tailEnd type="none" w="med" len="med"/>
+                    </a:lnT>
+                    <a:lnB w="6350" cap="flat" cmpd="sng" algn="ctr">
+                      <a:solidFill>
+                        <a:srgbClr val="E0E0E0"/>
+                      </a:solidFill>
+                      <a:prstDash val="solid"/>
+                      <a:round/>
+                      <a:headEnd type="none" w="med" len="med"/>
+                      <a:tailEnd type="none" w="med" len="med"/>
+                    </a:lnB>
+                  </a:tcPr>
+                </a:tc>
+                <a:tc>
+                  <a:txBody>
+                    <a:bodyPr/>
+                    <a:lstStyle/>
+                    <a:p>
+                      <a:pPr algn="ctr" indent="0" marL="0">
+                        <a:buNone/>
+                      </a:pPr>
+                      <a:r>
+                        <a:rPr lang="en-US" sz="1100" dirty="0">
+                          <a:solidFill>
+                            <a:srgbClr val="10332F"/>
+                          </a:solidFill>
+                          <a:latin typeface="Calibri" pitchFamily="34" charset="0"/>
+                          <a:ea typeface="Calibri" pitchFamily="34" charset="-122"/>
+                          <a:cs typeface="Calibri" pitchFamily="34" charset="-120"/>
+                        </a:rPr>
+                        <a:t>4.703</a:t>
+                      </a:r>
+                      <a:endParaRPr lang="en-US" sz="1100" dirty="0">
+                        <a:latin typeface="Calibri" charset="0"/>
+                        <a:ea typeface="Calibri" charset="0"/>
+                        <a:cs typeface="Calibri" charset="0"/>
+                      </a:endParaRPr>
+                    </a:p>
+                  </a:txBody>
+                  <a:tcPr marL="91440" marR="91440" marT="45720" marB="45720" anchor="ctr">
+                    <a:lnL w="6350" cap="flat" cmpd="sng" algn="ctr">
+                      <a:solidFill>
+                        <a:srgbClr val="E0E0E0"/>
+                      </a:solidFill>
+                      <a:prstDash val="solid"/>
+                      <a:round/>
+                      <a:headEnd type="none" w="med" len="med"/>
+                      <a:tailEnd type="none" w="med" len="med"/>
+                    </a:lnL>
+                    <a:lnR w="6350" cap="flat" cmpd="sng" algn="ctr">
+                      <a:solidFill>
+                        <a:srgbClr val="E0E0E0"/>
+                      </a:solidFill>
+                      <a:prstDash val="solid"/>
+                      <a:round/>
+                      <a:headEnd type="none" w="med" len="med"/>
+                      <a:tailEnd type="none" w="med" len="med"/>
+                    </a:lnR>
+                    <a:lnT w="6350" cap="flat" cmpd="sng" algn="ctr">
+                      <a:solidFill>
+                        <a:srgbClr val="E0E0E0"/>
+                      </a:solidFill>
+                      <a:prstDash val="solid"/>
+                      <a:round/>
+                      <a:headEnd type="none" w="med" len="med"/>
+                      <a:tailEnd type="none" w="med" len="med"/>
+                    </a:lnT>
+                    <a:lnB w="6350" cap="flat" cmpd="sng" algn="ctr">
+                      <a:solidFill>
+                        <a:srgbClr val="E0E0E0"/>
+                      </a:solidFill>
+                      <a:prstDash val="solid"/>
+                      <a:round/>
+                      <a:headEnd type="none" w="med" len="med"/>
+                      <a:tailEnd type="none" w="med" len="med"/>
+                    </a:lnB>
+                  </a:tcPr>
+                </a:tc>
+                <a:tc>
+                  <a:txBody>
+                    <a:bodyPr/>
+                    <a:lstStyle/>
+                    <a:p>
+                      <a:pPr algn="ctr" indent="0" marL="0">
+                        <a:buNone/>
+                      </a:pPr>
+                      <a:r>
+                        <a:rPr lang="en-US" sz="1100" dirty="0">
+                          <a:solidFill>
+                            <a:srgbClr val="10332F"/>
+                          </a:solidFill>
+                          <a:latin typeface="Calibri" pitchFamily="34" charset="0"/>
+                          <a:ea typeface="Calibri" pitchFamily="34" charset="-122"/>
+                          <a:cs typeface="Calibri" pitchFamily="34" charset="-120"/>
+                        </a:rPr>
+                        <a:t>3.578</a:t>
+                      </a:r>
+                      <a:endParaRPr lang="en-US" sz="1100" dirty="0">
+                        <a:latin typeface="Calibri" charset="0"/>
+                        <a:ea typeface="Calibri" charset="0"/>
+                        <a:cs typeface="Calibri" charset="0"/>
+                      </a:endParaRPr>
+                    </a:p>
+                  </a:txBody>
+                  <a:tcPr marL="91440" marR="91440" marT="45720" marB="45720" anchor="ctr">
+                    <a:lnL w="6350" cap="flat" cmpd="sng" algn="ctr">
+                      <a:solidFill>
+                        <a:srgbClr val="E0E0E0"/>
+                      </a:solidFill>
+                      <a:prstDash val="solid"/>
+                      <a:round/>
+                      <a:headEnd type="none" w="med" len="med"/>
+                      <a:tailEnd type="none" w="med" len="med"/>
+                    </a:lnL>
+                    <a:lnR w="6350" cap="flat" cmpd="sng" algn="ctr">
+                      <a:solidFill>
+                        <a:srgbClr val="E0E0E0"/>
+                      </a:solidFill>
+                      <a:prstDash val="solid"/>
+                      <a:round/>
+                      <a:headEnd type="none" w="med" len="med"/>
+                      <a:tailEnd type="none" w="med" len="med"/>
+                    </a:lnR>
+                    <a:lnT w="6350" cap="flat" cmpd="sng" algn="ctr">
+                      <a:solidFill>
+                        <a:srgbClr val="E0E0E0"/>
+                      </a:solidFill>
+                      <a:prstDash val="solid"/>
+                      <a:round/>
+                      <a:headEnd type="none" w="med" len="med"/>
+                      <a:tailEnd type="none" w="med" len="med"/>
+                    </a:lnT>
+                    <a:lnB w="6350" cap="flat" cmpd="sng" algn="ctr">
+                      <a:solidFill>
+                        <a:srgbClr val="E0E0E0"/>
+                      </a:solidFill>
+                      <a:prstDash val="solid"/>
+                      <a:round/>
+                      <a:headEnd type="none" w="med" len="med"/>
+                      <a:tailEnd type="none" w="med" len="med"/>
+                    </a:lnB>
+                  </a:tcPr>
+                </a:tc>
+                <a:tc>
+                  <a:txBody>
+                    <a:bodyPr/>
+                    <a:lstStyle/>
+                    <a:p>
+                      <a:pPr algn="ctr" indent="0" marL="0">
+                        <a:buNone/>
+                      </a:pPr>
+                      <a:r>
+                        <a:rPr lang="en-US" sz="1100" dirty="0">
+                          <a:solidFill>
+                            <a:srgbClr val="10332F"/>
+                          </a:solidFill>
+                          <a:latin typeface="Calibri" pitchFamily="34" charset="0"/>
+                          <a:ea typeface="Calibri" pitchFamily="34" charset="-122"/>
+                          <a:cs typeface="Calibri" pitchFamily="34" charset="-120"/>
+                        </a:rPr>
+                        <a:t>4.762</a:t>
+                      </a:r>
+                      <a:endParaRPr lang="en-US" sz="1100" dirty="0">
+                        <a:latin typeface="Calibri" charset="0"/>
+                        <a:ea typeface="Calibri" charset="0"/>
+                        <a:cs typeface="Calibri" charset="0"/>
+                      </a:endParaRPr>
+                    </a:p>
+                  </a:txBody>
+                  <a:tcPr marL="91440" marR="91440" marT="45720" marB="45720" anchor="ctr">
+                    <a:lnL w="6350" cap="flat" cmpd="sng" algn="ctr">
+                      <a:solidFill>
+                        <a:srgbClr val="E0E0E0"/>
+                      </a:solidFill>
+                      <a:prstDash val="solid"/>
+                      <a:round/>
+                      <a:headEnd type="none" w="med" len="med"/>
+                      <a:tailEnd type="none" w="med" len="med"/>
+                    </a:lnL>
+                    <a:lnR w="6350" cap="flat" cmpd="sng" algn="ctr">
+                      <a:solidFill>
+                        <a:srgbClr val="E0E0E0"/>
+                      </a:solidFill>
+                      <a:prstDash val="solid"/>
+                      <a:round/>
+                      <a:headEnd type="none" w="med" len="med"/>
+                      <a:tailEnd type="none" w="med" len="med"/>
+                    </a:lnR>
+                    <a:lnT w="6350" cap="flat" cmpd="sng" algn="ctr">
+                      <a:solidFill>
+                        <a:srgbClr val="E0E0E0"/>
+                      </a:solidFill>
+                      <a:prstDash val="solid"/>
+                      <a:round/>
+                      <a:headEnd type="none" w="med" len="med"/>
+                      <a:tailEnd type="none" w="med" len="med"/>
+                    </a:lnT>
+                    <a:lnB w="6350" cap="flat" cmpd="sng" algn="ctr">
+                      <a:solidFill>
+                        <a:srgbClr val="E0E0E0"/>
+                      </a:solidFill>
+                      <a:prstDash val="solid"/>
+                      <a:round/>
+                      <a:headEnd type="none" w="med" len="med"/>
+                      <a:tailEnd type="none" w="med" len="med"/>
+                    </a:lnB>
+                  </a:tcPr>
+                </a:tc>
+                <a:tc>
+                  <a:txBody>
+                    <a:bodyPr/>
+                    <a:lstStyle/>
+                    <a:p>
+                      <a:pPr algn="ctr" indent="0" marL="0">
+                        <a:buNone/>
+                      </a:pPr>
+                      <a:r>
+                        <a:rPr lang="en-US" sz="1100" dirty="0">
+                          <a:solidFill>
+                            <a:srgbClr val="10332F"/>
+                          </a:solidFill>
+                          <a:latin typeface="Calibri" pitchFamily="34" charset="0"/>
+                          <a:ea typeface="Calibri" pitchFamily="34" charset="-122"/>
+                          <a:cs typeface="Calibri" pitchFamily="34" charset="-120"/>
+                        </a:rPr>
+                        <a:t>4.988</a:t>
+                      </a:r>
+                      <a:endParaRPr lang="en-US" sz="1100" dirty="0">
+                        <a:latin typeface="Calibri" charset="0"/>
+                        <a:ea typeface="Calibri" charset="0"/>
+                        <a:cs typeface="Calibri" charset="0"/>
+                      </a:endParaRPr>
+                    </a:p>
+                  </a:txBody>
+                  <a:tcPr marL="91440" marR="91440" marT="45720" marB="45720" anchor="ctr">
+                    <a:lnL w="6350" cap="flat" cmpd="sng" algn="ctr">
+                      <a:solidFill>
+                        <a:srgbClr val="E0E0E0"/>
+                      </a:solidFill>
+                      <a:prstDash val="solid"/>
+                      <a:round/>
+                      <a:headEnd type="none" w="med" len="med"/>
+                      <a:tailEnd type="none" w="med" len="med"/>
+                    </a:lnL>
+                    <a:lnR w="6350" cap="flat" cmpd="sng" algn="ctr">
+                      <a:solidFill>
+                        <a:srgbClr val="E0E0E0"/>
+                      </a:solidFill>
+                      <a:prstDash val="solid"/>
+                      <a:round/>
+                      <a:headEnd type="none" w="med" len="med"/>
+                      <a:tailEnd type="none" w="med" len="med"/>
+                    </a:lnR>
+                    <a:lnT w="6350" cap="flat" cmpd="sng" algn="ctr">
+                      <a:solidFill>
+                        <a:srgbClr val="E0E0E0"/>
+                      </a:solidFill>
+                      <a:prstDash val="solid"/>
+                      <a:round/>
+                      <a:headEnd type="none" w="med" len="med"/>
+                      <a:tailEnd type="none" w="med" len="med"/>
+                    </a:lnT>
+                    <a:lnB w="6350" cap="flat" cmpd="sng" algn="ctr">
+                      <a:solidFill>
+                        <a:srgbClr val="E0E0E0"/>
+                      </a:solidFill>
+                      <a:prstDash val="solid"/>
+                      <a:round/>
+                      <a:headEnd type="none" w="med" len="med"/>
+                      <a:tailEnd type="none" w="med" len="med"/>
+                    </a:lnB>
+                  </a:tcPr>
+                </a:tc>
+                <a:tc>
+                  <a:txBody>
+                    <a:bodyPr/>
+                    <a:lstStyle/>
+                    <a:p>
+                      <a:pPr algn="ctr" indent="0" marL="0">
+                        <a:buNone/>
+                      </a:pPr>
+                      <a:r>
+                        <a:rPr lang="en-US" sz="1100" dirty="0">
+                          <a:solidFill>
+                            <a:srgbClr val="10332F"/>
+                          </a:solidFill>
+                          <a:latin typeface="Calibri" pitchFamily="34" charset="0"/>
+                          <a:ea typeface="Calibri" pitchFamily="34" charset="-122"/>
+                          <a:cs typeface="Calibri" pitchFamily="34" charset="-120"/>
+                        </a:rPr>
+                        <a:t>7.575</a:t>
+                      </a:r>
+                      <a:endParaRPr lang="en-US" sz="1100" dirty="0">
+                        <a:latin typeface="Calibri" charset="0"/>
+                        <a:ea typeface="Calibri" charset="0"/>
+                        <a:cs typeface="Calibri" charset="0"/>
+                      </a:endParaRPr>
+                    </a:p>
+                  </a:txBody>
+                  <a:tcPr marL="91440" marR="91440" marT="45720" marB="45720" anchor="ctr">
+                    <a:lnL w="6350" cap="flat" cmpd="sng" algn="ctr">
+                      <a:solidFill>
+                        <a:srgbClr val="E0E0E0"/>
+                      </a:solidFill>
+                      <a:prstDash val="solid"/>
+                      <a:round/>
+                      <a:headEnd type="none" w="med" len="med"/>
+                      <a:tailEnd type="none" w="med" len="med"/>
+                    </a:lnL>
+                    <a:lnR w="6350" cap="flat" cmpd="sng" algn="ctr">
+                      <a:solidFill>
+                        <a:srgbClr val="E0E0E0"/>
+                      </a:solidFill>
+                      <a:prstDash val="solid"/>
+                      <a:round/>
+                      <a:headEnd type="none" w="med" len="med"/>
+                      <a:tailEnd type="none" w="med" len="med"/>
+                    </a:lnR>
+                    <a:lnT w="6350" cap="flat" cmpd="sng" algn="ctr">
+                      <a:solidFill>
+                        <a:srgbClr val="E0E0E0"/>
+                      </a:solidFill>
+                      <a:prstDash val="solid"/>
+                      <a:round/>
+                      <a:headEnd type="none" w="med" len="med"/>
+                      <a:tailEnd type="none" w="med" len="med"/>
+                    </a:lnT>
+                    <a:lnB w="6350" cap="flat" cmpd="sng" algn="ctr">
+                      <a:solidFill>
+                        <a:srgbClr val="E0E0E0"/>
+                      </a:solidFill>
+                      <a:prstDash val="solid"/>
+                      <a:round/>
+                      <a:headEnd type="none" w="med" len="med"/>
+                      <a:tailEnd type="none" w="med" len="med"/>
+                    </a:lnB>
+                  </a:tcPr>
+                </a:tc>
+                <a:tc>
+                  <a:txBody>
+                    <a:bodyPr/>
+                    <a:lstStyle/>
+                    <a:p>
+                      <a:pPr algn="ctr" indent="0" marL="0">
+                        <a:buNone/>
+                      </a:pPr>
+                      <a:r>
+                        <a:rPr lang="en-US" sz="1100" dirty="0">
+                          <a:solidFill>
+                            <a:srgbClr val="10332F"/>
+                          </a:solidFill>
+                          <a:latin typeface="Calibri" pitchFamily="34" charset="0"/>
+                          <a:ea typeface="Calibri" pitchFamily="34" charset="-122"/>
+                          <a:cs typeface="Calibri" pitchFamily="34" charset="-120"/>
+                        </a:rPr>
+                        <a:t>3.367</a:t>
+                      </a:r>
+                      <a:endParaRPr lang="en-US" sz="1100" dirty="0">
+                        <a:latin typeface="Calibri" charset="0"/>
+                        <a:ea typeface="Calibri" charset="0"/>
+                        <a:cs typeface="Calibri" charset="0"/>
+                      </a:endParaRPr>
+                    </a:p>
+                  </a:txBody>
+                  <a:tcPr marL="91440" marR="91440" marT="45720" marB="45720" anchor="ctr">
+                    <a:lnL w="6350" cap="flat" cmpd="sng" algn="ctr">
+                      <a:solidFill>
+                        <a:srgbClr val="E0E0E0"/>
+                      </a:solidFill>
+                      <a:prstDash val="solid"/>
+                      <a:round/>
+                      <a:headEnd type="none" w="med" len="med"/>
+                      <a:tailEnd type="none" w="med" len="med"/>
+                    </a:lnL>
+                    <a:lnR w="6350" cap="flat" cmpd="sng" algn="ctr">
+                      <a:solidFill>
+                        <a:srgbClr val="E0E0E0"/>
+                      </a:solidFill>
+                      <a:prstDash val="solid"/>
+                      <a:round/>
+                      <a:headEnd type="none" w="med" len="med"/>
+                      <a:tailEnd type="none" w="med" len="med"/>
+                    </a:lnR>
+                    <a:lnT w="6350" cap="flat" cmpd="sng" algn="ctr">
+                      <a:solidFill>
+                        <a:srgbClr val="E0E0E0"/>
+                      </a:solidFill>
+                      <a:prstDash val="solid"/>
+                      <a:round/>
+                      <a:headEnd type="none" w="med" len="med"/>
+                      <a:tailEnd type="none" w="med" len="med"/>
+                    </a:lnT>
+                    <a:lnB w="6350" cap="flat" cmpd="sng" algn="ctr">
+                      <a:solidFill>
+                        <a:srgbClr val="E0E0E0"/>
+                      </a:solidFill>
+                      <a:prstDash val="solid"/>
+                      <a:round/>
+                      <a:headEnd type="none" w="med" len="med"/>
+                      <a:tailEnd type="none" w="med" len="med"/>
+                    </a:lnB>
+                  </a:tcPr>
+                </a:tc>
+              </a:tr>
+              <a:tr h="384048">
+                <a:tc>
+                  <a:txBody>
+                    <a:bodyPr/>
+                    <a:lstStyle/>
+                    <a:p>
+                      <a:pPr indent="0" marL="0">
+                        <a:buNone/>
+                      </a:pPr>
+                      <a:r>
+                        <a:rPr lang="en-US" sz="1100" b="1" dirty="0">
+                          <a:solidFill>
+                            <a:srgbClr val="2E7D32"/>
+                          </a:solidFill>
+                          <a:latin typeface="Calibri" pitchFamily="34" charset="0"/>
+                          <a:ea typeface="Calibri" pitchFamily="34" charset="-122"/>
+                          <a:cs typeface="Calibri" pitchFamily="34" charset="-120"/>
+                        </a:rPr>
+                        <a:t>Ciro</a:t>
+                      </a:r>
+                      <a:endParaRPr lang="en-US" sz="1100" dirty="0">
+                        <a:latin typeface="Calibri" charset="0"/>
+                        <a:ea typeface="Calibri" charset="0"/>
+                        <a:cs typeface="Calibri" charset="0"/>
+                      </a:endParaRPr>
+                    </a:p>
+                  </a:txBody>
+                  <a:tcPr marL="91440" marR="91440" marT="45720" marB="45720" anchor="ctr">
+                    <a:lnL w="6350" cap="flat" cmpd="sng" algn="ctr">
+                      <a:solidFill>
+                        <a:srgbClr val="E0E0E0"/>
+                      </a:solidFill>
+                      <a:prstDash val="solid"/>
+                      <a:round/>
+                      <a:headEnd type="none" w="med" len="med"/>
+                      <a:tailEnd type="none" w="med" len="med"/>
+                    </a:lnL>
+                    <a:lnR w="6350" cap="flat" cmpd="sng" algn="ctr">
+                      <a:solidFill>
+                        <a:srgbClr val="E0E0E0"/>
+                      </a:solidFill>
+                      <a:prstDash val="solid"/>
+                      <a:round/>
+                      <a:headEnd type="none" w="med" len="med"/>
+                      <a:tailEnd type="none" w="med" len="med"/>
+                    </a:lnR>
+                    <a:lnT w="6350" cap="flat" cmpd="sng" algn="ctr">
+                      <a:solidFill>
+                        <a:srgbClr val="E0E0E0"/>
+                      </a:solidFill>
+                      <a:prstDash val="solid"/>
+                      <a:round/>
+                      <a:headEnd type="none" w="med" len="med"/>
+                      <a:tailEnd type="none" w="med" len="med"/>
+                    </a:lnT>
+                    <a:lnB w="6350" cap="flat" cmpd="sng" algn="ctr">
+                      <a:solidFill>
+                        <a:srgbClr val="E0E0E0"/>
+                      </a:solidFill>
+                      <a:prstDash val="solid"/>
+                      <a:round/>
+                      <a:headEnd type="none" w="med" len="med"/>
+                      <a:tailEnd type="none" w="med" len="med"/>
+                    </a:lnB>
+                  </a:tcPr>
+                </a:tc>
+                <a:tc>
+                  <a:txBody>
+                    <a:bodyPr/>
+                    <a:lstStyle/>
+                    <a:p>
+                      <a:pPr algn="ctr" indent="0" marL="0">
+                        <a:buNone/>
+                      </a:pPr>
+                      <a:r>
+                        <a:rPr lang="en-US" sz="1100" dirty="0">
+                          <a:solidFill>
+                            <a:srgbClr val="10332F"/>
+                          </a:solidFill>
+                          <a:latin typeface="Calibri" pitchFamily="34" charset="0"/>
+                          <a:ea typeface="Calibri" pitchFamily="34" charset="-122"/>
+                          <a:cs typeface="Calibri" pitchFamily="34" charset="-120"/>
+                        </a:rPr>
+                        <a:t>₺139K</a:t>
+                      </a:r>
+                      <a:endParaRPr lang="en-US" sz="1100" dirty="0">
+                        <a:latin typeface="Calibri" charset="0"/>
+                        <a:ea typeface="Calibri" charset="0"/>
+                        <a:cs typeface="Calibri" charset="0"/>
+                      </a:endParaRPr>
+                    </a:p>
+                  </a:txBody>
+                  <a:tcPr marL="91440" marR="91440" marT="45720" marB="45720" anchor="ctr">
+                    <a:lnL w="6350" cap="flat" cmpd="sng" algn="ctr">
+                      <a:solidFill>
+                        <a:srgbClr val="E0E0E0"/>
+                      </a:solidFill>
+                      <a:prstDash val="solid"/>
+                      <a:round/>
+                      <a:headEnd type="none" w="med" len="med"/>
+                      <a:tailEnd type="none" w="med" len="med"/>
+                    </a:lnL>
+                    <a:lnR w="6350" cap="flat" cmpd="sng" algn="ctr">
+                      <a:solidFill>
+                        <a:srgbClr val="E0E0E0"/>
+                      </a:solidFill>
+                      <a:prstDash val="solid"/>
+                      <a:round/>
+                      <a:headEnd type="none" w="med" len="med"/>
+                      <a:tailEnd type="none" w="med" len="med"/>
+                    </a:lnR>
+                    <a:lnT w="6350" cap="flat" cmpd="sng" algn="ctr">
+                      <a:solidFill>
+                        <a:srgbClr val="E0E0E0"/>
+                      </a:solidFill>
+                      <a:prstDash val="solid"/>
+                      <a:round/>
+                      <a:headEnd type="none" w="med" len="med"/>
+                      <a:tailEnd type="none" w="med" len="med"/>
+                    </a:lnT>
+                    <a:lnB w="6350" cap="flat" cmpd="sng" algn="ctr">
+                      <a:solidFill>
+                        <a:srgbClr val="E0E0E0"/>
+                      </a:solidFill>
+                      <a:prstDash val="solid"/>
+                      <a:round/>
+                      <a:headEnd type="none" w="med" len="med"/>
+                      <a:tailEnd type="none" w="med" len="med"/>
+                    </a:lnB>
+                  </a:tcPr>
+                </a:tc>
+                <a:tc>
+                  <a:txBody>
+                    <a:bodyPr/>
+                    <a:lstStyle/>
+                    <a:p>
+                      <a:pPr algn="ctr" indent="0" marL="0">
+                        <a:buNone/>
+                      </a:pPr>
+                      <a:r>
+                        <a:rPr lang="en-US" sz="1100" dirty="0">
+                          <a:solidFill>
+                            <a:srgbClr val="10332F"/>
+                          </a:solidFill>
+                          <a:latin typeface="Calibri" pitchFamily="34" charset="0"/>
+                          <a:ea typeface="Calibri" pitchFamily="34" charset="-122"/>
+                          <a:cs typeface="Calibri" pitchFamily="34" charset="-120"/>
+                        </a:rPr>
+                        <a:t>₺47K</a:t>
+                      </a:r>
+                      <a:endParaRPr lang="en-US" sz="1100" dirty="0">
+                        <a:latin typeface="Calibri" charset="0"/>
+                        <a:ea typeface="Calibri" charset="0"/>
+                        <a:cs typeface="Calibri" charset="0"/>
+                      </a:endParaRPr>
+                    </a:p>
+                  </a:txBody>
+                  <a:tcPr marL="91440" marR="91440" marT="45720" marB="45720" anchor="ctr">
+                    <a:lnL w="6350" cap="flat" cmpd="sng" algn="ctr">
+                      <a:solidFill>
+                        <a:srgbClr val="E0E0E0"/>
+                      </a:solidFill>
+                      <a:prstDash val="solid"/>
+                      <a:round/>
+                      <a:headEnd type="none" w="med" len="med"/>
+                      <a:tailEnd type="none" w="med" len="med"/>
+                    </a:lnL>
+                    <a:lnR w="6350" cap="flat" cmpd="sng" algn="ctr">
+                      <a:solidFill>
+                        <a:srgbClr val="E0E0E0"/>
+                      </a:solidFill>
+                      <a:prstDash val="solid"/>
+                      <a:round/>
+                      <a:headEnd type="none" w="med" len="med"/>
+                      <a:tailEnd type="none" w="med" len="med"/>
+                    </a:lnR>
+                    <a:lnT w="6350" cap="flat" cmpd="sng" algn="ctr">
+                      <a:solidFill>
+                        <a:srgbClr val="E0E0E0"/>
+                      </a:solidFill>
+                      <a:prstDash val="solid"/>
+                      <a:round/>
+                      <a:headEnd type="none" w="med" len="med"/>
+                      <a:tailEnd type="none" w="med" len="med"/>
+                    </a:lnT>
+                    <a:lnB w="6350" cap="flat" cmpd="sng" algn="ctr">
+                      <a:solidFill>
+                        <a:srgbClr val="E0E0E0"/>
+                      </a:solidFill>
+                      <a:prstDash val="solid"/>
+                      <a:round/>
+                      <a:headEnd type="none" w="med" len="med"/>
+                      <a:tailEnd type="none" w="med" len="med"/>
+                    </a:lnB>
+                  </a:tcPr>
+                </a:tc>
+                <a:tc>
+                  <a:txBody>
+                    <a:bodyPr/>
+                    <a:lstStyle/>
+                    <a:p>
+                      <a:pPr algn="ctr" indent="0" marL="0">
+                        <a:buNone/>
+                      </a:pPr>
+                      <a:r>
+                        <a:rPr lang="en-US" sz="1100" dirty="0">
+                          <a:solidFill>
+                            <a:srgbClr val="10332F"/>
+                          </a:solidFill>
+                          <a:latin typeface="Calibri" pitchFamily="34" charset="0"/>
+                          <a:ea typeface="Calibri" pitchFamily="34" charset="-122"/>
+                          <a:cs typeface="Calibri" pitchFamily="34" charset="-120"/>
+                        </a:rPr>
+                        <a:t>₺38K</a:t>
+                      </a:r>
+                      <a:endParaRPr lang="en-US" sz="1100" dirty="0">
+                        <a:latin typeface="Calibri" charset="0"/>
+                        <a:ea typeface="Calibri" charset="0"/>
+                        <a:cs typeface="Calibri" charset="0"/>
+                      </a:endParaRPr>
+                    </a:p>
+                  </a:txBody>
+                  <a:tcPr marL="91440" marR="91440" marT="45720" marB="45720" anchor="ctr">
+                    <a:lnL w="6350" cap="flat" cmpd="sng" algn="ctr">
+                      <a:solidFill>
+                        <a:srgbClr val="E0E0E0"/>
+                      </a:solidFill>
+                      <a:prstDash val="solid"/>
+                      <a:round/>
+                      <a:headEnd type="none" w="med" len="med"/>
+                      <a:tailEnd type="none" w="med" len="med"/>
+                    </a:lnL>
+                    <a:lnR w="6350" cap="flat" cmpd="sng" algn="ctr">
+                      <a:solidFill>
+                        <a:srgbClr val="E0E0E0"/>
+                      </a:solidFill>
+                      <a:prstDash val="solid"/>
+                      <a:round/>
+                      <a:headEnd type="none" w="med" len="med"/>
+                      <a:tailEnd type="none" w="med" len="med"/>
+                    </a:lnR>
+                    <a:lnT w="6350" cap="flat" cmpd="sng" algn="ctr">
+                      <a:solidFill>
+                        <a:srgbClr val="E0E0E0"/>
+                      </a:solidFill>
+                      <a:prstDash val="solid"/>
+                      <a:round/>
+                      <a:headEnd type="none" w="med" len="med"/>
+                      <a:tailEnd type="none" w="med" len="med"/>
+                    </a:lnT>
+                    <a:lnB w="6350" cap="flat" cmpd="sng" algn="ctr">
+                      <a:solidFill>
+                        <a:srgbClr val="E0E0E0"/>
+                      </a:solidFill>
+                      <a:prstDash val="solid"/>
+                      <a:round/>
+                      <a:headEnd type="none" w="med" len="med"/>
+                      <a:tailEnd type="none" w="med" len="med"/>
+                    </a:lnB>
+                  </a:tcPr>
+                </a:tc>
+                <a:tc>
+                  <a:txBody>
+                    <a:bodyPr/>
+                    <a:lstStyle/>
+                    <a:p>
+                      <a:pPr algn="ctr" indent="0" marL="0">
+                        <a:buNone/>
+                      </a:pPr>
+                      <a:r>
+                        <a:rPr lang="en-US" sz="1100" dirty="0">
+                          <a:solidFill>
+                            <a:srgbClr val="10332F"/>
+                          </a:solidFill>
+                          <a:latin typeface="Calibri" pitchFamily="34" charset="0"/>
+                          <a:ea typeface="Calibri" pitchFamily="34" charset="-122"/>
+                          <a:cs typeface="Calibri" pitchFamily="34" charset="-120"/>
+                        </a:rPr>
+                        <a:t>₺56K</a:t>
+                      </a:r>
+                      <a:endParaRPr lang="en-US" sz="1100" dirty="0">
+                        <a:latin typeface="Calibri" charset="0"/>
+                        <a:ea typeface="Calibri" charset="0"/>
+                        <a:cs typeface="Calibri" charset="0"/>
+                      </a:endParaRPr>
+                    </a:p>
+                  </a:txBody>
+                  <a:tcPr marL="91440" marR="91440" marT="45720" marB="45720" anchor="ctr">
+                    <a:lnL w="6350" cap="flat" cmpd="sng" algn="ctr">
+                      <a:solidFill>
+                        <a:srgbClr val="E0E0E0"/>
+                      </a:solidFill>
+                      <a:prstDash val="solid"/>
+                      <a:round/>
+                      <a:headEnd type="none" w="med" len="med"/>
+                      <a:tailEnd type="none" w="med" len="med"/>
+                    </a:lnL>
+                    <a:lnR w="6350" cap="flat" cmpd="sng" algn="ctr">
+                      <a:solidFill>
+                        <a:srgbClr val="E0E0E0"/>
+                      </a:solidFill>
+                      <a:prstDash val="solid"/>
+                      <a:round/>
+                      <a:headEnd type="none" w="med" len="med"/>
+                      <a:tailEnd type="none" w="med" len="med"/>
+                    </a:lnR>
+                    <a:lnT w="6350" cap="flat" cmpd="sng" algn="ctr">
+                      <a:solidFill>
+                        <a:srgbClr val="E0E0E0"/>
+                      </a:solidFill>
+                      <a:prstDash val="solid"/>
+                      <a:round/>
+                      <a:headEnd type="none" w="med" len="med"/>
+                      <a:tailEnd type="none" w="med" len="med"/>
+                    </a:lnT>
+                    <a:lnB w="6350" cap="flat" cmpd="sng" algn="ctr">
+                      <a:solidFill>
+                        <a:srgbClr val="E0E0E0"/>
+                      </a:solidFill>
+                      <a:prstDash val="solid"/>
+                      <a:round/>
+                      <a:headEnd type="none" w="med" len="med"/>
+                      <a:tailEnd type="none" w="med" len="med"/>
+                    </a:lnB>
+                  </a:tcPr>
+                </a:tc>
+                <a:tc>
+                  <a:txBody>
+                    <a:bodyPr/>
+                    <a:lstStyle/>
+                    <a:p>
+                      <a:pPr algn="ctr" indent="0" marL="0">
+                        <a:buNone/>
+                      </a:pPr>
+                      <a:r>
+                        <a:rPr lang="en-US" sz="1100" dirty="0">
+                          <a:solidFill>
+                            <a:srgbClr val="10332F"/>
+                          </a:solidFill>
+                          <a:latin typeface="Calibri" pitchFamily="34" charset="0"/>
+                          <a:ea typeface="Calibri" pitchFamily="34" charset="-122"/>
+                          <a:cs typeface="Calibri" pitchFamily="34" charset="-120"/>
+                        </a:rPr>
+                        <a:t>₺65K</a:t>
+                      </a:r>
+                      <a:endParaRPr lang="en-US" sz="1100" dirty="0">
+                        <a:latin typeface="Calibri" charset="0"/>
+                        <a:ea typeface="Calibri" charset="0"/>
+                        <a:cs typeface="Calibri" charset="0"/>
+                      </a:endParaRPr>
+                    </a:p>
+                  </a:txBody>
+                  <a:tcPr marL="91440" marR="91440" marT="45720" marB="45720" anchor="ctr">
+                    <a:lnL w="6350" cap="flat" cmpd="sng" algn="ctr">
+                      <a:solidFill>
+                        <a:srgbClr val="E0E0E0"/>
+                      </a:solidFill>
+                      <a:prstDash val="solid"/>
+                      <a:round/>
+                      <a:headEnd type="none" w="med" len="med"/>
+                      <a:tailEnd type="none" w="med" len="med"/>
+                    </a:lnL>
+                    <a:lnR w="6350" cap="flat" cmpd="sng" algn="ctr">
+                      <a:solidFill>
+                        <a:srgbClr val="E0E0E0"/>
+                      </a:solidFill>
+                      <a:prstDash val="solid"/>
+                      <a:round/>
+                      <a:headEnd type="none" w="med" len="med"/>
+                      <a:tailEnd type="none" w="med" len="med"/>
+                    </a:lnR>
+                    <a:lnT w="6350" cap="flat" cmpd="sng" algn="ctr">
+                      <a:solidFill>
+                        <a:srgbClr val="E0E0E0"/>
+                      </a:solidFill>
+                      <a:prstDash val="solid"/>
+                      <a:round/>
+                      <a:headEnd type="none" w="med" len="med"/>
+                      <a:tailEnd type="none" w="med" len="med"/>
+                    </a:lnT>
+                    <a:lnB w="6350" cap="flat" cmpd="sng" algn="ctr">
+                      <a:solidFill>
+                        <a:srgbClr val="E0E0E0"/>
+                      </a:solidFill>
+                      <a:prstDash val="solid"/>
+                      <a:round/>
+                      <a:headEnd type="none" w="med" len="med"/>
+                      <a:tailEnd type="none" w="med" len="med"/>
+                    </a:lnB>
+                  </a:tcPr>
+                </a:tc>
+                <a:tc>
+                  <a:txBody>
+                    <a:bodyPr/>
+                    <a:lstStyle/>
+                    <a:p>
+                      <a:pPr algn="ctr" indent="0" marL="0">
+                        <a:buNone/>
+                      </a:pPr>
+                      <a:r>
+                        <a:rPr lang="en-US" sz="1100" dirty="0">
+                          <a:solidFill>
+                            <a:srgbClr val="10332F"/>
+                          </a:solidFill>
+                          <a:latin typeface="Calibri" pitchFamily="34" charset="0"/>
+                          <a:ea typeface="Calibri" pitchFamily="34" charset="-122"/>
+                          <a:cs typeface="Calibri" pitchFamily="34" charset="-120"/>
+                        </a:rPr>
+                        <a:t>₺90K</a:t>
+                      </a:r>
+                      <a:endParaRPr lang="en-US" sz="1100" dirty="0">
+                        <a:latin typeface="Calibri" charset="0"/>
+                        <a:ea typeface="Calibri" charset="0"/>
+                        <a:cs typeface="Calibri" charset="0"/>
+                      </a:endParaRPr>
+                    </a:p>
+                  </a:txBody>
+                  <a:tcPr marL="91440" marR="91440" marT="45720" marB="45720" anchor="ctr">
+                    <a:lnL w="6350" cap="flat" cmpd="sng" algn="ctr">
+                      <a:solidFill>
+                        <a:srgbClr val="E0E0E0"/>
+                      </a:solidFill>
+                      <a:prstDash val="solid"/>
+                      <a:round/>
+                      <a:headEnd type="none" w="med" len="med"/>
+                      <a:tailEnd type="none" w="med" len="med"/>
+                    </a:lnL>
+                    <a:lnR w="6350" cap="flat" cmpd="sng" algn="ctr">
+                      <a:solidFill>
+                        <a:srgbClr val="E0E0E0"/>
+                      </a:solidFill>
+                      <a:prstDash val="solid"/>
+                      <a:round/>
+                      <a:headEnd type="none" w="med" len="med"/>
+                      <a:tailEnd type="none" w="med" len="med"/>
+                    </a:lnR>
+                    <a:lnT w="6350" cap="flat" cmpd="sng" algn="ctr">
+                      <a:solidFill>
+                        <a:srgbClr val="E0E0E0"/>
+                      </a:solidFill>
+                      <a:prstDash val="solid"/>
+                      <a:round/>
+                      <a:headEnd type="none" w="med" len="med"/>
+                      <a:tailEnd type="none" w="med" len="med"/>
+                    </a:lnT>
+                    <a:lnB w="6350" cap="flat" cmpd="sng" algn="ctr">
+                      <a:solidFill>
+                        <a:srgbClr val="E0E0E0"/>
+                      </a:solidFill>
+                      <a:prstDash val="solid"/>
+                      <a:round/>
+                      <a:headEnd type="none" w="med" len="med"/>
+                      <a:tailEnd type="none" w="med" len="med"/>
+                    </a:lnB>
+                  </a:tcPr>
+                </a:tc>
+                <a:tc>
+                  <a:txBody>
+                    <a:bodyPr/>
+                    <a:lstStyle/>
+                    <a:p>
+                      <a:pPr algn="ctr" indent="0" marL="0">
+                        <a:buNone/>
+                      </a:pPr>
+                      <a:r>
+                        <a:rPr lang="en-US" sz="1100" dirty="0">
+                          <a:solidFill>
+                            <a:srgbClr val="10332F"/>
+                          </a:solidFill>
+                          <a:latin typeface="Calibri" pitchFamily="34" charset="0"/>
+                          <a:ea typeface="Calibri" pitchFamily="34" charset="-122"/>
+                          <a:cs typeface="Calibri" pitchFamily="34" charset="-120"/>
+                        </a:rPr>
+                        <a:t>₺122K</a:t>
+                      </a:r>
+                      <a:endParaRPr lang="en-US" sz="1100" dirty="0">
+                        <a:latin typeface="Calibri" charset="0"/>
+                        <a:ea typeface="Calibri" charset="0"/>
+                        <a:cs typeface="Calibri" charset="0"/>
+                      </a:endParaRPr>
+                    </a:p>
+                  </a:txBody>
+                  <a:tcPr marL="91440" marR="91440" marT="45720" marB="45720" anchor="ctr">
+                    <a:lnL w="6350" cap="flat" cmpd="sng" algn="ctr">
+                      <a:solidFill>
+                        <a:srgbClr val="E0E0E0"/>
+                      </a:solidFill>
+                      <a:prstDash val="solid"/>
+                      <a:round/>
+                      <a:headEnd type="none" w="med" len="med"/>
+                      <a:tailEnd type="none" w="med" len="med"/>
+                    </a:lnL>
+                    <a:lnR w="6350" cap="flat" cmpd="sng" algn="ctr">
+                      <a:solidFill>
+                        <a:srgbClr val="E0E0E0"/>
+                      </a:solidFill>
+                      <a:prstDash val="solid"/>
+                      <a:round/>
+                      <a:headEnd type="none" w="med" len="med"/>
+                      <a:tailEnd type="none" w="med" len="med"/>
+                    </a:lnR>
+                    <a:lnT w="6350" cap="flat" cmpd="sng" algn="ctr">
+                      <a:solidFill>
+                        <a:srgbClr val="E0E0E0"/>
+                      </a:solidFill>
+                      <a:prstDash val="solid"/>
+                      <a:round/>
+                      <a:headEnd type="none" w="med" len="med"/>
+                      <a:tailEnd type="none" w="med" len="med"/>
+                    </a:lnT>
+                    <a:lnB w="6350" cap="flat" cmpd="sng" algn="ctr">
+                      <a:solidFill>
+                        <a:srgbClr val="E0E0E0"/>
+                      </a:solidFill>
+                      <a:prstDash val="solid"/>
+                      <a:round/>
+                      <a:headEnd type="none" w="med" len="med"/>
+                      <a:tailEnd type="none" w="med" len="med"/>
+                    </a:lnB>
+                  </a:tcPr>
+                </a:tc>
+                <a:tc>
+                  <a:txBody>
+                    <a:bodyPr/>
+                    <a:lstStyle/>
+                    <a:p>
+                      <a:pPr algn="ctr" indent="0" marL="0">
+                        <a:buNone/>
+                      </a:pPr>
+                      <a:r>
+                        <a:rPr lang="en-US" sz="1100" dirty="0">
+                          <a:solidFill>
+                            <a:srgbClr val="10332F"/>
+                          </a:solidFill>
+                          <a:latin typeface="Calibri" pitchFamily="34" charset="0"/>
+                          <a:ea typeface="Calibri" pitchFamily="34" charset="-122"/>
+                          <a:cs typeface="Calibri" pitchFamily="34" charset="-120"/>
+                        </a:rPr>
+                        <a:t>₺82K</a:t>
+                      </a:r>
+                      <a:endParaRPr lang="en-US" sz="1100" dirty="0">
+                        <a:latin typeface="Calibri" charset="0"/>
+                        <a:ea typeface="Calibri" charset="0"/>
+                        <a:cs typeface="Calibri" charset="0"/>
+                      </a:endParaRPr>
+                    </a:p>
+                  </a:txBody>
+                  <a:tcPr marL="91440" marR="91440" marT="45720" marB="45720" anchor="ctr">
+                    <a:lnL w="6350" cap="flat" cmpd="sng" algn="ctr">
+                      <a:solidFill>
+                        <a:srgbClr val="E0E0E0"/>
+                      </a:solidFill>
+                      <a:prstDash val="solid"/>
+                      <a:round/>
+                      <a:headEnd type="none" w="med" len="med"/>
+                      <a:tailEnd type="none" w="med" len="med"/>
+                    </a:lnL>
+                    <a:lnR w="6350" cap="flat" cmpd="sng" algn="ctr">
+                      <a:solidFill>
+                        <a:srgbClr val="E0E0E0"/>
+                      </a:solidFill>
+                      <a:prstDash val="solid"/>
+                      <a:round/>
+                      <a:headEnd type="none" w="med" len="med"/>
+                      <a:tailEnd type="none" w="med" len="med"/>
+                    </a:lnR>
+                    <a:lnT w="6350" cap="flat" cmpd="sng" algn="ctr">
+                      <a:solidFill>
+                        <a:srgbClr val="E0E0E0"/>
+                      </a:solidFill>
+                      <a:prstDash val="solid"/>
+                      <a:round/>
+                      <a:headEnd type="none" w="med" len="med"/>
+                      <a:tailEnd type="none" w="med" len="med"/>
+                    </a:lnT>
+                    <a:lnB w="6350" cap="flat" cmpd="sng" algn="ctr">
+                      <a:solidFill>
+                        <a:srgbClr val="E0E0E0"/>
+                      </a:solidFill>
+                      <a:prstDash val="solid"/>
+                      <a:round/>
+                      <a:headEnd type="none" w="med" len="med"/>
+                      <a:tailEnd type="none" w="med" len="med"/>
+                    </a:lnB>
+                  </a:tcPr>
+                </a:tc>
+              </a:tr>
+              <a:tr h="384048">
+                <a:tc>
+                  <a:txBody>
+                    <a:bodyPr/>
+                    <a:lstStyle/>
+                    <a:p>
+                      <a:pPr indent="0" marL="0">
+                        <a:buNone/>
+                      </a:pPr>
+                      <a:r>
+                        <a:rPr lang="en-US" sz="1100" b="1" dirty="0">
+                          <a:solidFill>
+                            <a:srgbClr val="1565C0"/>
+                          </a:solidFill>
+                          <a:latin typeface="Calibri" pitchFamily="34" charset="0"/>
+                          <a:ea typeface="Calibri" pitchFamily="34" charset="-122"/>
+                          <a:cs typeface="Calibri" pitchFamily="34" charset="-120"/>
+                        </a:rPr>
+                        <a:t>Transaction</a:t>
+                      </a:r>
+                      <a:endParaRPr lang="en-US" sz="1100" dirty="0">
+                        <a:latin typeface="Calibri" charset="0"/>
+                        <a:ea typeface="Calibri" charset="0"/>
+                        <a:cs typeface="Calibri" charset="0"/>
+                      </a:endParaRPr>
+                    </a:p>
+                  </a:txBody>
+                  <a:tcPr marL="91440" marR="91440" marT="45720" marB="45720" anchor="ctr">
+                    <a:lnL w="6350" cap="flat" cmpd="sng" algn="ctr">
+                      <a:solidFill>
+                        <a:srgbClr val="E0E0E0"/>
+                      </a:solidFill>
+                      <a:prstDash val="solid"/>
+                      <a:round/>
+                      <a:headEnd type="none" w="med" len="med"/>
+                      <a:tailEnd type="none" w="med" len="med"/>
+                    </a:lnL>
+                    <a:lnR w="6350" cap="flat" cmpd="sng" algn="ctr">
+                      <a:solidFill>
+                        <a:srgbClr val="E0E0E0"/>
+                      </a:solidFill>
+                      <a:prstDash val="solid"/>
+                      <a:round/>
+                      <a:headEnd type="none" w="med" len="med"/>
+                      <a:tailEnd type="none" w="med" len="med"/>
+                    </a:lnR>
+                    <a:lnT w="6350" cap="flat" cmpd="sng" algn="ctr">
+                      <a:solidFill>
+                        <a:srgbClr val="E0E0E0"/>
+                      </a:solidFill>
+                      <a:prstDash val="solid"/>
+                      <a:round/>
+                      <a:headEnd type="none" w="med" len="med"/>
+                      <a:tailEnd type="none" w="med" len="med"/>
+                    </a:lnT>
+                    <a:lnB w="6350" cap="flat" cmpd="sng" algn="ctr">
+                      <a:solidFill>
+                        <a:srgbClr val="E0E0E0"/>
+                      </a:solidFill>
+                      <a:prstDash val="solid"/>
+                      <a:round/>
+                      <a:headEnd type="none" w="med" len="med"/>
+                      <a:tailEnd type="none" w="med" len="med"/>
+                    </a:lnB>
+                  </a:tcPr>
+                </a:tc>
+                <a:tc>
+                  <a:txBody>
+                    <a:bodyPr/>
+                    <a:lstStyle/>
+                    <a:p>
+                      <a:pPr algn="ctr" indent="0" marL="0">
+                        <a:buNone/>
+                      </a:pPr>
+                      <a:r>
+                        <a:rPr lang="en-US" sz="1100" dirty="0">
+                          <a:solidFill>
+                            <a:srgbClr val="10332F"/>
+                          </a:solidFill>
+                          <a:latin typeface="Calibri" pitchFamily="34" charset="0"/>
+                          <a:ea typeface="Calibri" pitchFamily="34" charset="-122"/>
+                          <a:cs typeface="Calibri" pitchFamily="34" charset="-120"/>
+                        </a:rPr>
+                        <a:t>33</a:t>
+                      </a:r>
+                      <a:endParaRPr lang="en-US" sz="1100" dirty="0">
+                        <a:latin typeface="Calibri" charset="0"/>
+                        <a:ea typeface="Calibri" charset="0"/>
+                        <a:cs typeface="Calibri" charset="0"/>
+                      </a:endParaRPr>
+                    </a:p>
+                  </a:txBody>
+                  <a:tcPr marL="91440" marR="91440" marT="45720" marB="45720" anchor="ctr">
+                    <a:lnL w="6350" cap="flat" cmpd="sng" algn="ctr">
+                      <a:solidFill>
+                        <a:srgbClr val="E0E0E0"/>
+                      </a:solidFill>
+                      <a:prstDash val="solid"/>
+                      <a:round/>
+                      <a:headEnd type="none" w="med" len="med"/>
+                      <a:tailEnd type="none" w="med" len="med"/>
+                    </a:lnL>
+                    <a:lnR w="6350" cap="flat" cmpd="sng" algn="ctr">
+                      <a:solidFill>
+                        <a:srgbClr val="E0E0E0"/>
+                      </a:solidFill>
+                      <a:prstDash val="solid"/>
+                      <a:round/>
+                      <a:headEnd type="none" w="med" len="med"/>
+                      <a:tailEnd type="none" w="med" len="med"/>
+                    </a:lnR>
+                    <a:lnT w="6350" cap="flat" cmpd="sng" algn="ctr">
+                      <a:solidFill>
+                        <a:srgbClr val="E0E0E0"/>
+                      </a:solidFill>
+                      <a:prstDash val="solid"/>
+                      <a:round/>
+                      <a:headEnd type="none" w="med" len="med"/>
+                      <a:tailEnd type="none" w="med" len="med"/>
+                    </a:lnT>
+                    <a:lnB w="6350" cap="flat" cmpd="sng" algn="ctr">
+                      <a:solidFill>
+                        <a:srgbClr val="E0E0E0"/>
+                      </a:solidFill>
+                      <a:prstDash val="solid"/>
+                      <a:round/>
+                      <a:headEnd type="none" w="med" len="med"/>
+                      <a:tailEnd type="none" w="med" len="med"/>
+                    </a:lnB>
+                  </a:tcPr>
+                </a:tc>
+                <a:tc>
+                  <a:txBody>
+                    <a:bodyPr/>
+                    <a:lstStyle/>
+                    <a:p>
+                      <a:pPr algn="ctr" indent="0" marL="0">
+                        <a:buNone/>
+                      </a:pPr>
+                      <a:r>
+                        <a:rPr lang="en-US" sz="1100" dirty="0">
+                          <a:solidFill>
+                            <a:srgbClr val="10332F"/>
+                          </a:solidFill>
+                          <a:latin typeface="Calibri" pitchFamily="34" charset="0"/>
+                          <a:ea typeface="Calibri" pitchFamily="34" charset="-122"/>
+                          <a:cs typeface="Calibri" pitchFamily="34" charset="-120"/>
+                        </a:rPr>
+                        <a:t>26</a:t>
+                      </a:r>
+                      <a:endParaRPr lang="en-US" sz="1100" dirty="0">
+                        <a:latin typeface="Calibri" charset="0"/>
+                        <a:ea typeface="Calibri" charset="0"/>
+                        <a:cs typeface="Calibri" charset="0"/>
+                      </a:endParaRPr>
+                    </a:p>
+                  </a:txBody>
+                  <a:tcPr marL="91440" marR="91440" marT="45720" marB="45720" anchor="ctr">
+                    <a:lnL w="6350" cap="flat" cmpd="sng" algn="ctr">
+                      <a:solidFill>
+                        <a:srgbClr val="E0E0E0"/>
+                      </a:solidFill>
+                      <a:prstDash val="solid"/>
+                      <a:round/>
+                      <a:headEnd type="none" w="med" len="med"/>
+                      <a:tailEnd type="none" w="med" len="med"/>
+                    </a:lnL>
+                    <a:lnR w="6350" cap="flat" cmpd="sng" algn="ctr">
+                      <a:solidFill>
+                        <a:srgbClr val="E0E0E0"/>
+                      </a:solidFill>
+                      <a:prstDash val="solid"/>
+                      <a:round/>
+                      <a:headEnd type="none" w="med" len="med"/>
+                      <a:tailEnd type="none" w="med" len="med"/>
+                    </a:lnR>
+                    <a:lnT w="6350" cap="flat" cmpd="sng" algn="ctr">
+                      <a:solidFill>
+                        <a:srgbClr val="E0E0E0"/>
+                      </a:solidFill>
+                      <a:prstDash val="solid"/>
+                      <a:round/>
+                      <a:headEnd type="none" w="med" len="med"/>
+                      <a:tailEnd type="none" w="med" len="med"/>
+                    </a:lnT>
+                    <a:lnB w="6350" cap="flat" cmpd="sng" algn="ctr">
+                      <a:solidFill>
+                        <a:srgbClr val="E0E0E0"/>
+                      </a:solidFill>
+                      <a:prstDash val="solid"/>
+                      <a:round/>
+                      <a:headEnd type="none" w="med" len="med"/>
+                      <a:tailEnd type="none" w="med" len="med"/>
+                    </a:lnB>
+                  </a:tcPr>
+                </a:tc>
+                <a:tc>
+                  <a:txBody>
+                    <a:bodyPr/>
+                    <a:lstStyle/>
+                    <a:p>
+                      <a:pPr algn="ctr" indent="0" marL="0">
+                        <a:buNone/>
+                      </a:pPr>
+                      <a:r>
+                        <a:rPr lang="en-US" sz="1100" dirty="0">
+                          <a:solidFill>
+                            <a:srgbClr val="10332F"/>
+                          </a:solidFill>
+                          <a:latin typeface="Calibri" pitchFamily="34" charset="0"/>
+                          <a:ea typeface="Calibri" pitchFamily="34" charset="-122"/>
+                          <a:cs typeface="Calibri" pitchFamily="34" charset="-120"/>
+                        </a:rPr>
+                        <a:t>15</a:t>
+                      </a:r>
+                      <a:endParaRPr lang="en-US" sz="1100" dirty="0">
+                        <a:latin typeface="Calibri" charset="0"/>
+                        <a:ea typeface="Calibri" charset="0"/>
+                        <a:cs typeface="Calibri" charset="0"/>
+                      </a:endParaRPr>
+                    </a:p>
+                  </a:txBody>
+                  <a:tcPr marL="91440" marR="91440" marT="45720" marB="45720" anchor="ctr">
+                    <a:lnL w="6350" cap="flat" cmpd="sng" algn="ctr">
+                      <a:solidFill>
+                        <a:srgbClr val="E0E0E0"/>
+                      </a:solidFill>
+                      <a:prstDash val="solid"/>
+                      <a:round/>
+                      <a:headEnd type="none" w="med" len="med"/>
+                      <a:tailEnd type="none" w="med" len="med"/>
+                    </a:lnL>
+                    <a:lnR w="6350" cap="flat" cmpd="sng" algn="ctr">
+                      <a:solidFill>
+                        <a:srgbClr val="E0E0E0"/>
+                      </a:solidFill>
+                      <a:prstDash val="solid"/>
+                      <a:round/>
+                      <a:headEnd type="none" w="med" len="med"/>
+                      <a:tailEnd type="none" w="med" len="med"/>
+                    </a:lnR>
+                    <a:lnT w="6350" cap="flat" cmpd="sng" algn="ctr">
+                      <a:solidFill>
+                        <a:srgbClr val="E0E0E0"/>
+                      </a:solidFill>
+                      <a:prstDash val="solid"/>
+                      <a:round/>
+                      <a:headEnd type="none" w="med" len="med"/>
+                      <a:tailEnd type="none" w="med" len="med"/>
+                    </a:lnT>
+                    <a:lnB w="6350" cap="flat" cmpd="sng" algn="ctr">
+                      <a:solidFill>
+                        <a:srgbClr val="E0E0E0"/>
+                      </a:solidFill>
+                      <a:prstDash val="solid"/>
+                      <a:round/>
+                      <a:headEnd type="none" w="med" len="med"/>
+                      <a:tailEnd type="none" w="med" len="med"/>
+                    </a:lnB>
+                  </a:tcPr>
+                </a:tc>
+                <a:tc>
+                  <a:txBody>
+                    <a:bodyPr/>
+                    <a:lstStyle/>
+                    <a:p>
+                      <a:pPr algn="ctr" indent="0" marL="0">
+                        <a:buNone/>
+                      </a:pPr>
+                      <a:r>
+                        <a:rPr lang="en-US" sz="1100" dirty="0">
+                          <a:solidFill>
+                            <a:srgbClr val="10332F"/>
+                          </a:solidFill>
+                          <a:latin typeface="Calibri" pitchFamily="34" charset="0"/>
+                          <a:ea typeface="Calibri" pitchFamily="34" charset="-122"/>
+                          <a:cs typeface="Calibri" pitchFamily="34" charset="-120"/>
+                        </a:rPr>
+                        <a:t>19</a:t>
+                      </a:r>
+                      <a:endParaRPr lang="en-US" sz="1100" dirty="0">
+                        <a:latin typeface="Calibri" charset="0"/>
+                        <a:ea typeface="Calibri" charset="0"/>
+                        <a:cs typeface="Calibri" charset="0"/>
+                      </a:endParaRPr>
+                    </a:p>
+                  </a:txBody>
+                  <a:tcPr marL="91440" marR="91440" marT="45720" marB="45720" anchor="ctr">
+                    <a:lnL w="6350" cap="flat" cmpd="sng" algn="ctr">
+                      <a:solidFill>
+                        <a:srgbClr val="E0E0E0"/>
+                      </a:solidFill>
+                      <a:prstDash val="solid"/>
+                      <a:round/>
+                      <a:headEnd type="none" w="med" len="med"/>
+                      <a:tailEnd type="none" w="med" len="med"/>
+                    </a:lnL>
+                    <a:lnR w="6350" cap="flat" cmpd="sng" algn="ctr">
+                      <a:solidFill>
+                        <a:srgbClr val="E0E0E0"/>
+                      </a:solidFill>
+                      <a:prstDash val="solid"/>
+                      <a:round/>
+                      <a:headEnd type="none" w="med" len="med"/>
+                      <a:tailEnd type="none" w="med" len="med"/>
+                    </a:lnR>
+                    <a:lnT w="6350" cap="flat" cmpd="sng" algn="ctr">
+                      <a:solidFill>
+                        <a:srgbClr val="E0E0E0"/>
+                      </a:solidFill>
+                      <a:prstDash val="solid"/>
+                      <a:round/>
+                      <a:headEnd type="none" w="med" len="med"/>
+                      <a:tailEnd type="none" w="med" len="med"/>
+                    </a:lnT>
+                    <a:lnB w="6350" cap="flat" cmpd="sng" algn="ctr">
+                      <a:solidFill>
+                        <a:srgbClr val="E0E0E0"/>
+                      </a:solidFill>
+                      <a:prstDash val="solid"/>
+                      <a:round/>
+                      <a:headEnd type="none" w="med" len="med"/>
+                      <a:tailEnd type="none" w="med" len="med"/>
+                    </a:lnB>
+                  </a:tcPr>
+                </a:tc>
+                <a:tc>
+                  <a:txBody>
+                    <a:bodyPr/>
+                    <a:lstStyle/>
+                    <a:p>
+                      <a:pPr algn="ctr" indent="0" marL="0">
+                        <a:buNone/>
+                      </a:pPr>
+                      <a:r>
+                        <a:rPr lang="en-US" sz="1100" dirty="0">
+                          <a:solidFill>
+                            <a:srgbClr val="10332F"/>
+                          </a:solidFill>
+                          <a:latin typeface="Calibri" pitchFamily="34" charset="0"/>
+                          <a:ea typeface="Calibri" pitchFamily="34" charset="-122"/>
+                          <a:cs typeface="Calibri" pitchFamily="34" charset="-120"/>
+                        </a:rPr>
+                        <a:t>30</a:t>
+                      </a:r>
+                      <a:endParaRPr lang="en-US" sz="1100" dirty="0">
+                        <a:latin typeface="Calibri" charset="0"/>
+                        <a:ea typeface="Calibri" charset="0"/>
+                        <a:cs typeface="Calibri" charset="0"/>
+                      </a:endParaRPr>
+                    </a:p>
+                  </a:txBody>
+                  <a:tcPr marL="91440" marR="91440" marT="45720" marB="45720" anchor="ctr">
+                    <a:lnL w="6350" cap="flat" cmpd="sng" algn="ctr">
+                      <a:solidFill>
+                        <a:srgbClr val="E0E0E0"/>
+                      </a:solidFill>
+                      <a:prstDash val="solid"/>
+                      <a:round/>
+                      <a:headEnd type="none" w="med" len="med"/>
+                      <a:tailEnd type="none" w="med" len="med"/>
+                    </a:lnL>
+                    <a:lnR w="6350" cap="flat" cmpd="sng" algn="ctr">
+                      <a:solidFill>
+                        <a:srgbClr val="E0E0E0"/>
+                      </a:solidFill>
+                      <a:prstDash val="solid"/>
+                      <a:round/>
+                      <a:headEnd type="none" w="med" len="med"/>
+                      <a:tailEnd type="none" w="med" len="med"/>
+                    </a:lnR>
+                    <a:lnT w="6350" cap="flat" cmpd="sng" algn="ctr">
+                      <a:solidFill>
+                        <a:srgbClr val="E0E0E0"/>
+                      </a:solidFill>
+                      <a:prstDash val="solid"/>
+                      <a:round/>
+                      <a:headEnd type="none" w="med" len="med"/>
+                      <a:tailEnd type="none" w="med" len="med"/>
+                    </a:lnT>
+                    <a:lnB w="6350" cap="flat" cmpd="sng" algn="ctr">
+                      <a:solidFill>
+                        <a:srgbClr val="E0E0E0"/>
+                      </a:solidFill>
+                      <a:prstDash val="solid"/>
+                      <a:round/>
+                      <a:headEnd type="none" w="med" len="med"/>
+                      <a:tailEnd type="none" w="med" len="med"/>
+                    </a:lnB>
+                  </a:tcPr>
+                </a:tc>
+                <a:tc>
+                  <a:txBody>
+                    <a:bodyPr/>
+                    <a:lstStyle/>
+                    <a:p>
+                      <a:pPr algn="ctr" indent="0" marL="0">
+                        <a:buNone/>
+                      </a:pPr>
+                      <a:r>
+                        <a:rPr lang="en-US" sz="1100" dirty="0">
+                          <a:solidFill>
+                            <a:srgbClr val="10332F"/>
+                          </a:solidFill>
+                          <a:latin typeface="Calibri" pitchFamily="34" charset="0"/>
+                          <a:ea typeface="Calibri" pitchFamily="34" charset="-122"/>
+                          <a:cs typeface="Calibri" pitchFamily="34" charset="-120"/>
+                        </a:rPr>
+                        <a:t>44</a:t>
+                      </a:r>
+                      <a:endParaRPr lang="en-US" sz="1100" dirty="0">
+                        <a:latin typeface="Calibri" charset="0"/>
+                        <a:ea typeface="Calibri" charset="0"/>
+                        <a:cs typeface="Calibri" charset="0"/>
+                      </a:endParaRPr>
+                    </a:p>
+                  </a:txBody>
+                  <a:tcPr marL="91440" marR="91440" marT="45720" marB="45720" anchor="ctr">
+                    <a:lnL w="6350" cap="flat" cmpd="sng" algn="ctr">
+                      <a:solidFill>
+                        <a:srgbClr val="E0E0E0"/>
+                      </a:solidFill>
+                      <a:prstDash val="solid"/>
+                      <a:round/>
+                      <a:headEnd type="none" w="med" len="med"/>
+                      <a:tailEnd type="none" w="med" len="med"/>
+                    </a:lnL>
+                    <a:lnR w="6350" cap="flat" cmpd="sng" algn="ctr">
+                      <a:solidFill>
+                        <a:srgbClr val="E0E0E0"/>
+                      </a:solidFill>
+                      <a:prstDash val="solid"/>
+                      <a:round/>
+                      <a:headEnd type="none" w="med" len="med"/>
+                      <a:tailEnd type="none" w="med" len="med"/>
+                    </a:lnR>
+                    <a:lnT w="6350" cap="flat" cmpd="sng" algn="ctr">
+                      <a:solidFill>
+                        <a:srgbClr val="E0E0E0"/>
+                      </a:solidFill>
+                      <a:prstDash val="solid"/>
+                      <a:round/>
+                      <a:headEnd type="none" w="med" len="med"/>
+                      <a:tailEnd type="none" w="med" len="med"/>
+                    </a:lnT>
+                    <a:lnB w="6350" cap="flat" cmpd="sng" algn="ctr">
+                      <a:solidFill>
+                        <a:srgbClr val="E0E0E0"/>
+                      </a:solidFill>
+                      <a:prstDash val="solid"/>
+                      <a:round/>
+                      <a:headEnd type="none" w="med" len="med"/>
+                      <a:tailEnd type="none" w="med" len="med"/>
+                    </a:lnB>
+                  </a:tcPr>
+                </a:tc>
+                <a:tc>
+                  <a:txBody>
+                    <a:bodyPr/>
+                    <a:lstStyle/>
+                    <a:p>
+                      <a:pPr algn="ctr" indent="0" marL="0">
+                        <a:buNone/>
+                      </a:pPr>
+                      <a:r>
+                        <a:rPr lang="en-US" sz="1100" dirty="0">
+                          <a:solidFill>
+                            <a:srgbClr val="10332F"/>
+                          </a:solidFill>
+                          <a:latin typeface="Calibri" pitchFamily="34" charset="0"/>
+                          <a:ea typeface="Calibri" pitchFamily="34" charset="-122"/>
+                          <a:cs typeface="Calibri" pitchFamily="34" charset="-120"/>
+                        </a:rPr>
+                        <a:t>54</a:t>
+                      </a:r>
+                      <a:endParaRPr lang="en-US" sz="1100" dirty="0">
+                        <a:latin typeface="Calibri" charset="0"/>
+                        <a:ea typeface="Calibri" charset="0"/>
+                        <a:cs typeface="Calibri" charset="0"/>
+                      </a:endParaRPr>
+                    </a:p>
+                  </a:txBody>
+                  <a:tcPr marL="91440" marR="91440" marT="45720" marB="45720" anchor="ctr">
+                    <a:lnL w="6350" cap="flat" cmpd="sng" algn="ctr">
+                      <a:solidFill>
+                        <a:srgbClr val="E0E0E0"/>
+                      </a:solidFill>
+                      <a:prstDash val="solid"/>
+                      <a:round/>
+                      <a:headEnd type="none" w="med" len="med"/>
+                      <a:tailEnd type="none" w="med" len="med"/>
+                    </a:lnL>
+                    <a:lnR w="6350" cap="flat" cmpd="sng" algn="ctr">
+                      <a:solidFill>
+                        <a:srgbClr val="E0E0E0"/>
+                      </a:solidFill>
+                      <a:prstDash val="solid"/>
+                      <a:round/>
+                      <a:headEnd type="none" w="med" len="med"/>
+                      <a:tailEnd type="none" w="med" len="med"/>
+                    </a:lnR>
+                    <a:lnT w="6350" cap="flat" cmpd="sng" algn="ctr">
+                      <a:solidFill>
+                        <a:srgbClr val="E0E0E0"/>
+                      </a:solidFill>
+                      <a:prstDash val="solid"/>
+                      <a:round/>
+                      <a:headEnd type="none" w="med" len="med"/>
+                      <a:tailEnd type="none" w="med" len="med"/>
+                    </a:lnT>
+                    <a:lnB w="6350" cap="flat" cmpd="sng" algn="ctr">
+                      <a:solidFill>
+                        <a:srgbClr val="E0E0E0"/>
+                      </a:solidFill>
+                      <a:prstDash val="solid"/>
+                      <a:round/>
+                      <a:headEnd type="none" w="med" len="med"/>
+                      <a:tailEnd type="none" w="med" len="med"/>
+                    </a:lnB>
+                  </a:tcPr>
+                </a:tc>
+                <a:tc>
+                  <a:txBody>
+                    <a:bodyPr/>
+                    <a:lstStyle/>
+                    <a:p>
+                      <a:pPr algn="ctr" indent="0" marL="0">
+                        <a:buNone/>
+                      </a:pPr>
+                      <a:r>
+                        <a:rPr lang="en-US" sz="1100" dirty="0">
+                          <a:solidFill>
+                            <a:srgbClr val="10332F"/>
+                          </a:solidFill>
+                          <a:latin typeface="Calibri" pitchFamily="34" charset="0"/>
+                          <a:ea typeface="Calibri" pitchFamily="34" charset="-122"/>
+                          <a:cs typeface="Calibri" pitchFamily="34" charset="-120"/>
+                        </a:rPr>
+                        <a:t>30</a:t>
+                      </a:r>
+                      <a:endParaRPr lang="en-US" sz="1100" dirty="0">
+                        <a:latin typeface="Calibri" charset="0"/>
+                        <a:ea typeface="Calibri" charset="0"/>
+                        <a:cs typeface="Calibri" charset="0"/>
+                      </a:endParaRPr>
+                    </a:p>
+                  </a:txBody>
+                  <a:tcPr marL="91440" marR="91440" marT="45720" marB="45720" anchor="ctr">
+                    <a:lnL w="6350" cap="flat" cmpd="sng" algn="ctr">
+                      <a:solidFill>
+                        <a:srgbClr val="E0E0E0"/>
+                      </a:solidFill>
+                      <a:prstDash val="solid"/>
+                      <a:round/>
+                      <a:headEnd type="none" w="med" len="med"/>
+                      <a:tailEnd type="none" w="med" len="med"/>
+                    </a:lnL>
+                    <a:lnR w="6350" cap="flat" cmpd="sng" algn="ctr">
+                      <a:solidFill>
+                        <a:srgbClr val="E0E0E0"/>
+                      </a:solidFill>
+                      <a:prstDash val="solid"/>
+                      <a:round/>
+                      <a:headEnd type="none" w="med" len="med"/>
+                      <a:tailEnd type="none" w="med" len="med"/>
+                    </a:lnR>
+                    <a:lnT w="6350" cap="flat" cmpd="sng" algn="ctr">
+                      <a:solidFill>
+                        <a:srgbClr val="E0E0E0"/>
+                      </a:solidFill>
+                      <a:prstDash val="solid"/>
+                      <a:round/>
+                      <a:headEnd type="none" w="med" len="med"/>
+                      <a:tailEnd type="none" w="med" len="med"/>
+                    </a:lnT>
+                    <a:lnB w="6350" cap="flat" cmpd="sng" algn="ctr">
+                      <a:solidFill>
+                        <a:srgbClr val="E0E0E0"/>
+                      </a:solidFill>
+                      <a:prstDash val="solid"/>
+                      <a:round/>
+                      <a:headEnd type="none" w="med" len="med"/>
+                      <a:tailEnd type="none" w="med" len="med"/>
+                    </a:lnB>
+                  </a:tcPr>
+                </a:tc>
+              </a:tr>
+            </a:tbl>
+          </a:graphicData>
+        </a:graphic>
+      </p:graphicFrame>
       <p:sp>
         <p:nvSpPr>
-          <p:cNvPr id="5" name="Text 2"/>
+          <p:cNvPr id="6" name="Text 2"/>
           <p:cNvSpPr/>
           <p:nvPr/>
         </p:nvSpPr>
         <p:spPr>
           <a:xfrm>
-            <a:off x="457200" y="5120640"/>
-            <a:ext cx="11247120" cy="640080"/>
+            <a:off x="457200" y="5943600"/>
+            <a:ext cx="11247120" cy="548640"/>
           </a:xfrm>
           <a:prstGeom prst="rect">
             <a:avLst/>
@@ -14885,7 +17286,7 @@
               <a:buNone/>
             </a:pPr>
             <a:r>
-              <a:rPr lang="en-US" sz="1300" b="1" dirty="0">
+              <a:rPr lang="en-US" sz="1200" b="1" dirty="0">
                 <a:solidFill>
                   <a:srgbClr val="FF7B52"/>
                 </a:solidFill>
@@ -14899,7 +17300,7 @@
               <a:buNone/>
             </a:pPr>
             <a:r>
-              <a:rPr lang="en-US" sz="1300" b="1" dirty="0">
+              <a:rPr lang="en-US" sz="1200" b="1" dirty="0">
                 <a:solidFill>
                   <a:srgbClr val="E85F36"/>
                 </a:solidFill>
@@ -14913,7 +17314,7 @@
               <a:buNone/>
             </a:pPr>
             <a:r>
-              <a:rPr lang="en-US" sz="1300" dirty="0">
+              <a:rPr lang="en-US" sz="1200" dirty="0">
                 <a:solidFill>
                   <a:srgbClr val="10332F"/>
                 </a:solidFill>
@@ -14927,7 +17328,7 @@
               <a:buNone/>
             </a:pPr>
             <a:r>
-              <a:rPr lang="en-US" sz="1300" b="1" dirty="0">
+              <a:rPr lang="en-US" sz="1200" b="1" dirty="0">
                 <a:solidFill>
                   <a:srgbClr val="E85F36"/>
                 </a:solidFill>
@@ -14941,7 +17342,7 @@
               <a:buNone/>
             </a:pPr>
             <a:r>
-              <a:rPr lang="en-US" sz="1300" dirty="0">
+              <a:rPr lang="en-US" sz="1200" dirty="0">
                 <a:solidFill>
                   <a:srgbClr val="10332F"/>
                 </a:solidFill>
@@ -14949,15 +17350,15 @@
                 <a:ea typeface="Calibri" pitchFamily="34" charset="-122"/>
                 <a:cs typeface="Calibri" pitchFamily="34" charset="-120"/>
               </a:rPr>
-              <a:t> bayram dönemiyle Kasım'ı da aşmıştır.</a:t>
+              <a:t> bayram dönemiyle Kasım'ı da aşmıştır. Haziran ayı bitmediği için chart düşüş gösterebilir.</a:t>
             </a:r>
-            <a:endParaRPr lang="en-US" sz="1300" dirty="0"/>
+            <a:endParaRPr lang="en-US" sz="1200" dirty="0"/>
           </a:p>
         </p:txBody>
       </p:sp>
       <p:pic>
         <p:nvPicPr>
-          <p:cNvPr id="6" name="Image 0" descr="/Users/Erdo/Desktop/Claude Projects/Özdilek/ozdilekteyim-trafik-analizi/sunum/assets/inbound-o-teal.png">    </p:cNvPr>
+          <p:cNvPr id="7" name="Image 0" descr="/Users/Erdo/Desktop/Claude Projects/Özdilek/ozdilekteyim-trafik-analizi/sunum/assets/inbound-o-teal.png">    </p:cNvPr>
           <p:cNvPicPr>
             <a:picLocks noChangeAspect="1"/>
           </p:cNvPicPr>
@@ -14981,7 +17382,7 @@
       </p:pic>
       <p:sp>
         <p:nvSpPr>
-          <p:cNvPr id="7" name="Shape 3"/>
+          <p:cNvPr id="8" name="Shape 3"/>
           <p:cNvSpPr/>
           <p:nvPr/>
         </p:nvSpPr>
@@ -15003,7 +17404,7 @@
       </p:sp>
       <p:sp>
         <p:nvSpPr>
-          <p:cNvPr id="8" name="Text 4"/>
+          <p:cNvPr id="9" name="Text 4"/>
           <p:cNvSpPr/>
           <p:nvPr/>
         </p:nvSpPr>

</xml_diff>